<commit_message>
add closing insights slide
</commit_message>
<xml_diff>
--- a/deliverables/beyond-average-case-safety.pptx
+++ b/deliverables/beyond-average-case-safety.pptx
@@ -2,31 +2,32 @@
 <file path=ppt/presentation.xml><?xml version="1.0" encoding="utf-8"?>
 <p:presentation xmlns:p="http://schemas.openxmlformats.org/presentationml/2006/main">
   <p:sldMasterIdLst>
-    <p:sldMasterId xmlns:r="http://schemas.openxmlformats.org/officeDocument/2006/relationships" id="2147483648" r:id="Re25ceaa0adf946a9"/>
+    <p:sldMasterId xmlns:r="http://schemas.openxmlformats.org/officeDocument/2006/relationships" id="2147483648" r:id="Reac7fa20bf1d4bb3"/>
   </p:sldMasterIdLst>
   <p:notesMasterIdLst>
-    <p:notesMasterId xmlns:r="http://schemas.openxmlformats.org/officeDocument/2006/relationships" r:id="Rc6fc7086c77a4904"/>
+    <p:notesMasterId xmlns:r="http://schemas.openxmlformats.org/officeDocument/2006/relationships" r:id="Ra52b349bd3474dc1"/>
   </p:notesMasterIdLst>
   <p:sldIdLst>
-    <p:sldId xmlns:r="http://schemas.openxmlformats.org/officeDocument/2006/relationships" id="256" r:id="R9e986ebd3a9d46b2"/>
-    <p:sldId xmlns:r="http://schemas.openxmlformats.org/officeDocument/2006/relationships" id="257" r:id="Rfb6d4593d27847ba"/>
-    <p:sldId xmlns:r="http://schemas.openxmlformats.org/officeDocument/2006/relationships" id="258" r:id="Refffa261eb6f4608"/>
-    <p:sldId xmlns:r="http://schemas.openxmlformats.org/officeDocument/2006/relationships" id="259" r:id="Rf47cacb9ea674fd7"/>
-    <p:sldId xmlns:r="http://schemas.openxmlformats.org/officeDocument/2006/relationships" id="260" r:id="R94c2985d68944dd7"/>
-    <p:sldId xmlns:r="http://schemas.openxmlformats.org/officeDocument/2006/relationships" id="261" r:id="R2f8bac45c9284301"/>
-    <p:sldId xmlns:r="http://schemas.openxmlformats.org/officeDocument/2006/relationships" id="262" r:id="R959bb19303804032"/>
-    <p:sldId xmlns:r="http://schemas.openxmlformats.org/officeDocument/2006/relationships" id="263" r:id="R2ba4a18a122343be"/>
-    <p:sldId xmlns:r="http://schemas.openxmlformats.org/officeDocument/2006/relationships" id="264" r:id="R4ea4dd09c89d432d"/>
-    <p:sldId xmlns:r="http://schemas.openxmlformats.org/officeDocument/2006/relationships" id="265" r:id="R5c698a86521f4b5f"/>
-    <p:sldId xmlns:r="http://schemas.openxmlformats.org/officeDocument/2006/relationships" id="266" r:id="Rfb8ea4bfe4c9472e"/>
-    <p:sldId xmlns:r="http://schemas.openxmlformats.org/officeDocument/2006/relationships" id="267" r:id="R74b061228a78441b"/>
-    <p:sldId xmlns:r="http://schemas.openxmlformats.org/officeDocument/2006/relationships" id="268" r:id="Rcb05800d6e6c4ed6"/>
-    <p:sldId xmlns:r="http://schemas.openxmlformats.org/officeDocument/2006/relationships" id="269" r:id="R8c6258614f634810"/>
-    <p:sldId xmlns:r="http://schemas.openxmlformats.org/officeDocument/2006/relationships" id="270" r:id="R78c5713aa36f43b4"/>
-    <p:sldId xmlns:r="http://schemas.openxmlformats.org/officeDocument/2006/relationships" id="271" r:id="R8af2a0ace50145dc"/>
-    <p:sldId xmlns:r="http://schemas.openxmlformats.org/officeDocument/2006/relationships" id="272" r:id="R496f6d85d75e4fac"/>
-    <p:sldId xmlns:r="http://schemas.openxmlformats.org/officeDocument/2006/relationships" id="273" r:id="R0a2c24e270054fb5"/>
-    <p:sldId xmlns:r="http://schemas.openxmlformats.org/officeDocument/2006/relationships" id="274" r:id="R8d4043f5cf5a4681"/>
+    <p:sldId xmlns:r="http://schemas.openxmlformats.org/officeDocument/2006/relationships" id="256" r:id="R7979765a95cf45a1"/>
+    <p:sldId xmlns:r="http://schemas.openxmlformats.org/officeDocument/2006/relationships" id="257" r:id="R3153485ad39f462b"/>
+    <p:sldId xmlns:r="http://schemas.openxmlformats.org/officeDocument/2006/relationships" id="258" r:id="R3e5f46dff64b4224"/>
+    <p:sldId xmlns:r="http://schemas.openxmlformats.org/officeDocument/2006/relationships" id="259" r:id="R52adcc8f4c194338"/>
+    <p:sldId xmlns:r="http://schemas.openxmlformats.org/officeDocument/2006/relationships" id="260" r:id="R2f3d3bb271b04ca0"/>
+    <p:sldId xmlns:r="http://schemas.openxmlformats.org/officeDocument/2006/relationships" id="261" r:id="R440cefe11d2a453c"/>
+    <p:sldId xmlns:r="http://schemas.openxmlformats.org/officeDocument/2006/relationships" id="262" r:id="R8aa1ee146bb44dc9"/>
+    <p:sldId xmlns:r="http://schemas.openxmlformats.org/officeDocument/2006/relationships" id="263" r:id="Rb6f06206977b4239"/>
+    <p:sldId xmlns:r="http://schemas.openxmlformats.org/officeDocument/2006/relationships" id="264" r:id="R82862a95ec3744ae"/>
+    <p:sldId xmlns:r="http://schemas.openxmlformats.org/officeDocument/2006/relationships" id="265" r:id="R95c723ef244248c9"/>
+    <p:sldId xmlns:r="http://schemas.openxmlformats.org/officeDocument/2006/relationships" id="266" r:id="R0b96c4a553d54b26"/>
+    <p:sldId xmlns:r="http://schemas.openxmlformats.org/officeDocument/2006/relationships" id="267" r:id="R2054799ba1434cc4"/>
+    <p:sldId xmlns:r="http://schemas.openxmlformats.org/officeDocument/2006/relationships" id="268" r:id="R187d584026e14846"/>
+    <p:sldId xmlns:r="http://schemas.openxmlformats.org/officeDocument/2006/relationships" id="269" r:id="R2a78caf1e80947c7"/>
+    <p:sldId xmlns:r="http://schemas.openxmlformats.org/officeDocument/2006/relationships" id="270" r:id="R8256a5db26c04419"/>
+    <p:sldId xmlns:r="http://schemas.openxmlformats.org/officeDocument/2006/relationships" id="271" r:id="R3160fa873b904724"/>
+    <p:sldId xmlns:r="http://schemas.openxmlformats.org/officeDocument/2006/relationships" id="272" r:id="R23bab5bfa7504044"/>
+    <p:sldId xmlns:r="http://schemas.openxmlformats.org/officeDocument/2006/relationships" id="273" r:id="Ra6cba447601f4ca3"/>
+    <p:sldId xmlns:r="http://schemas.openxmlformats.org/officeDocument/2006/relationships" id="274" r:id="Rf5bc3be42dd34288"/>
+    <p:sldId xmlns:r="http://schemas.openxmlformats.org/officeDocument/2006/relationships" id="275" r:id="R26e4feb3dbb744e8"/>
   </p:sldIdLst>
   <p:sldSz cx="12192000" cy="6858000"/>
   <p:notesSz cx="6858000" cy="9144000"/>
@@ -1790,6 +1791,146 @@
 </p:notes>
 </file>
 
+<file path=ppt/notesSlides/notesSlide20.xml><?xml version="1.0" encoding="utf-8"?>
+<p:notes xmlns:p="http://schemas.openxmlformats.org/presentationml/2006/main">
+  <p:cSld>
+    <p:spTree>
+      <p:nvGrpSpPr>
+        <p:cNvPr id="1" name=""/>
+        <p:cNvGrpSpPr/>
+        <p:nvPr/>
+      </p:nvGrpSpPr>
+      <p:grpSpPr>
+        <a:xfrm xmlns:a="http://schemas.openxmlformats.org/drawingml/2006/main"/>
+      </p:grpSpPr>
+      <p:sp>
+        <p:nvSpPr>
+          <p:cNvPr id="2" name="Slide Image Placeholder 1"/>
+          <p:cNvSpPr>
+            <a:spLocks xmlns:a="http://schemas.openxmlformats.org/drawingml/2006/main" noGrp="1"/>
+          </p:cNvSpPr>
+          <p:nvPr>
+            <p:ph type="sldImg" idx="0"/>
+          </p:nvPr>
+        </p:nvSpPr>
+        <p:spPr/>
+      </p:sp>
+      <p:sp>
+        <p:nvSpPr>
+          <p:cNvPr id="3" name="Notes Placeholder 2"/>
+          <p:cNvSpPr>
+            <a:spLocks xmlns:a="http://schemas.openxmlformats.org/drawingml/2006/main" noGrp="1"/>
+          </p:cNvSpPr>
+          <p:nvPr>
+            <p:ph type="body" idx="1"/>
+          </p:nvPr>
+        </p:nvSpPr>
+        <p:spPr/>
+        <p:txBody>
+          <a:bodyPr xmlns:a="http://schemas.openxmlformats.org/drawingml/2006/main"/>
+          <a:lstStyle xmlns:a="http://schemas.openxmlformats.org/drawingml/2006/main"/>
+          <a:p xmlns:a="http://schemas.openxmlformats.org/drawingml/2006/main">
+            <a:r>
+              <a:t>PRESENTER NOTES</a:t>
+            </a:r>
+          </a:p>
+          <a:p xmlns:a="http://schemas.openxmlformats.org/drawingml/2006/main">
+            <a:r>
+              <a:t/>
+            </a:r>
+          </a:p>
+          <a:p xmlns:a="http://schemas.openxmlformats.org/drawingml/2006/main">
+            <a:r>
+              <a:t>The closing synthesis is deliberately evidence-linked.</a:t>
+            </a:r>
+          </a:p>
+          <a:p xmlns:a="http://schemas.openxmlformats.org/drawingml/2006/main">
+            <a:r>
+              <a:t/>
+            </a:r>
+          </a:p>
+          <a:p xmlns:a="http://schemas.openxmlformats.org/drawingml/2006/main">
+            <a:r>
+              <a:t>First, security is compositional: local checks accepted the registered harmful workflow. Second, representation adapts: surface paraphrasing broke a fixed code, but semantic adaptation restored full success, while typed mediation removed the registered carrier. Third, targeted provenance repair prevented harm without destroying exact utility. Fourth, a stringent lifetime false-alarm bound did not guarantee useful low-rate intervention; before-harm detection was only 0.275. Fifth, diversity is promising only when matched failure sets do not overlap and the benefit survives enforcement, adaptation, and held-out transfer.</a:t>
+            </a:r>
+          </a:p>
+          <a:p xmlns:a="http://schemas.openxmlformats.org/drawingml/2006/main">
+            <a:r>
+              <a:t/>
+            </a:r>
+          </a:p>
+          <a:p xmlns:a="http://schemas.openxmlformats.org/drawingml/2006/main">
+            <a:r>
+              <a:t>The final row preserves the boundary of the evidence. Controlled Gamma was positive, but the interaction gap was also positive and selector advantage plus genuine held-out transfer remain open.</a:t>
+            </a:r>
+          </a:p>
+          <a:p xmlns:a="http://schemas.openxmlformats.org/drawingml/2006/main">
+            <a:r>
+              <a:t/>
+            </a:r>
+          </a:p>
+          <a:p xmlns:a="http://schemas.openxmlformats.org/drawingml/2006/main">
+            <a:r>
+              <a:t>[Sources]</a:t>
+            </a:r>
+          </a:p>
+          <a:p xmlns:a="http://schemas.openxmlformats.org/drawingml/2006/main">
+            <a:r>
+              <a:t>- artifacts/reviewer-evidence-20260821/phase7-model-capacity-7b-vllm-trace-complete.json</a:t>
+            </a:r>
+          </a:p>
+          <a:p xmlns:a="http://schemas.openxmlformats.org/drawingml/2006/main">
+            <a:r>
+              <a:t>- artifacts/reviewer-evidence-20260821/phase7-model-workflow-7b-vllm-trace-complete.json</a:t>
+            </a:r>
+          </a:p>
+          <a:p xmlns:a="http://schemas.openxmlformats.org/drawingml/2006/main">
+            <a:r>
+              <a:t>- artifacts/phase5-confirmatory-report.json</a:t>
+            </a:r>
+          </a:p>
+          <a:p xmlns:a="http://schemas.openxmlformats.org/drawingml/2006/main">
+            <a:r>
+              <a:t>- artifacts/reviewer-evidence-20260821/tail-report.json</a:t>
+            </a:r>
+          </a:p>
+          <a:p xmlns:a="http://schemas.openxmlformats.org/drawingml/2006/main">
+            <a:r>
+              <a:t>- paper/main.tex</a:t>
+            </a:r>
+          </a:p>
+          <a:p xmlns:a="http://schemas.openxmlformats.org/drawingml/2006/main">
+            <a:r>
+              <a:t>[/Sources]</a:t>
+            </a:r>
+          </a:p>
+        </p:txBody>
+      </p:sp>
+      <p:sp>
+        <p:nvSpPr>
+          <p:cNvPr id="4" name="Slide Number Placeholder 3"/>
+          <p:cNvSpPr>
+            <a:spLocks xmlns:a="http://schemas.openxmlformats.org/drawingml/2006/main" noGrp="1"/>
+          </p:cNvSpPr>
+          <p:nvPr>
+            <p:ph type="sldNum" idx="5"/>
+          </p:nvPr>
+        </p:nvSpPr>
+        <p:spPr/>
+        <p:txBody>
+          <a:bodyPr xmlns:a="http://schemas.openxmlformats.org/drawingml/2006/main"/>
+          <a:lstStyle xmlns:a="http://schemas.openxmlformats.org/drawingml/2006/main"/>
+          <a:p xmlns:a="http://schemas.openxmlformats.org/drawingml/2006/main"/>
+        </p:txBody>
+      </p:sp>
+    </p:spTree>
+  </p:cSld>
+  <p:clrMapOvr>
+    <a:masterClrMapping xmlns:a="http://schemas.openxmlformats.org/drawingml/2006/main"/>
+  </p:clrMapOvr>
+</p:notes>
+</file>
+
 <file path=ppt/notesSlides/notesSlide3.xml><?xml version="1.0" encoding="utf-8"?>
 <p:notes xmlns:p="http://schemas.openxmlformats.org/presentationml/2006/main">
   <p:cSld>
@@ -2618,7 +2759,7 @@
   </p:cSld>
   <p:clrMap bg1="lt1" tx1="dk1" bg2="lt2" tx2="dk2" accent1="accent1" accent2="accent2" accent3="accent3" accent4="accent4" accent5="accent5" accent6="accent6" hlink="hlink" folHlink="folHlink"/>
   <p:sldLayoutIdLst>
-    <p:sldLayoutId xmlns:r="http://schemas.openxmlformats.org/officeDocument/2006/relationships" id="2147483649" r:id="R27f6d012d8384bfd"/>
+    <p:sldLayoutId xmlns:r="http://schemas.openxmlformats.org/officeDocument/2006/relationships" id="2147483649" r:id="R248ce45c8ddc4ec8"/>
   </p:sldLayoutIdLst>
   <p:txStyles>
     <p:titleStyle>
@@ -6041,7 +6182,7 @@
         </p:xfrm>
         <a:graphic xmlns:a="http://schemas.openxmlformats.org/drawingml/2006/main">
           <a:graphicData uri="http://schemas.openxmlformats.org/drawingml/2006/chart">
-            <c:chart xmlns:r="http://schemas.openxmlformats.org/officeDocument/2006/relationships" xmlns:c="http://schemas.openxmlformats.org/drawingml/2006/chart" r:id="R8052352e56684a36"/>
+            <c:chart xmlns:r="http://schemas.openxmlformats.org/officeDocument/2006/relationships" xmlns:c="http://schemas.openxmlformats.org/drawingml/2006/chart" r:id="Ree6c6792c6b5492e"/>
           </a:graphicData>
         </a:graphic>
       </p:graphicFrame>
@@ -6566,7 +6707,7 @@
         </p:xfrm>
         <a:graphic xmlns:a="http://schemas.openxmlformats.org/drawingml/2006/main">
           <a:graphicData uri="http://schemas.openxmlformats.org/drawingml/2006/chart">
-            <c:chart xmlns:r="http://schemas.openxmlformats.org/officeDocument/2006/relationships" xmlns:c="http://schemas.openxmlformats.org/drawingml/2006/chart" r:id="R3e9218fc2cef4fb0"/>
+            <c:chart xmlns:r="http://schemas.openxmlformats.org/officeDocument/2006/relationships" xmlns:c="http://schemas.openxmlformats.org/drawingml/2006/chart" r:id="Rae3c59d42e284371"/>
           </a:graphicData>
         </a:graphic>
       </p:graphicFrame>
@@ -7034,7 +7175,7 @@
         </p:xfrm>
         <a:graphic xmlns:a="http://schemas.openxmlformats.org/drawingml/2006/main">
           <a:graphicData uri="http://schemas.openxmlformats.org/drawingml/2006/chart">
-            <c:chart xmlns:r="http://schemas.openxmlformats.org/officeDocument/2006/relationships" xmlns:c="http://schemas.openxmlformats.org/drawingml/2006/chart" r:id="R6e6ba96f4c5b4e7a"/>
+            <c:chart xmlns:r="http://schemas.openxmlformats.org/officeDocument/2006/relationships" xmlns:c="http://schemas.openxmlformats.org/drawingml/2006/chart" r:id="R9cf440efae624a45"/>
           </a:graphicData>
         </a:graphic>
       </p:graphicFrame>
@@ -7894,7 +8035,7 @@
       </p:sp>
       <p:cxnSp>
         <p:nvCxnSpPr>
-          <p:cNvPr id="120" name=""/>
+          <p:cNvPr id="136" name=""/>
           <p:cNvCxnSpPr/>
           <p:nvPr/>
         </p:nvCxnSpPr>
@@ -9409,7 +9550,7 @@
         </p:xfrm>
         <a:graphic xmlns:a="http://schemas.openxmlformats.org/drawingml/2006/main">
           <a:graphicData uri="http://schemas.openxmlformats.org/drawingml/2006/chart">
-            <c:chart xmlns:r="http://schemas.openxmlformats.org/officeDocument/2006/relationships" xmlns:c="http://schemas.openxmlformats.org/drawingml/2006/chart" r:id="Rd81619174b6a4013"/>
+            <c:chart xmlns:r="http://schemas.openxmlformats.org/officeDocument/2006/relationships" xmlns:c="http://schemas.openxmlformats.org/drawingml/2006/chart" r:id="Ra91f3d85faf6495b"/>
           </a:graphicData>
         </a:graphic>
       </p:graphicFrame>
@@ -12926,6 +13067,1739 @@
 </p:sld>
 </file>
 
+<file path=ppt/slides/slide20.xml><?xml version="1.0" encoding="utf-8"?>
+<p:sld xmlns:p="http://schemas.openxmlformats.org/presentationml/2006/main">
+  <p:cSld>
+    <p:spTree>
+      <p:nvGrpSpPr>
+        <p:cNvPr id="1" name=""/>
+        <p:cNvGrpSpPr/>
+        <p:nvPr/>
+      </p:nvGrpSpPr>
+      <p:grpSpPr>
+        <a:xfrm xmlns:a="http://schemas.openxmlformats.org/drawingml/2006/main"/>
+      </p:grpSpPr>
+      <p:sp>
+        <p:nvSpPr>
+          <p:cNvPr id="33" name="">
+            <a:extLst xmlns:a="http://schemas.openxmlformats.org/drawingml/2006/main">
+              <a:ext uri="{FF2B5EF4-FFF2-40B4-BE49-F238E27FC236}">
+                <a16:creationId xmlns:a16="http://schemas.microsoft.com/office/drawing/2014/main" id="{5310ECD3-08AE-4304-97E2-ABA54357479E}"/>
+              </a:ext>
+            </a:extLst>
+          </p:cNvPr>
+          <p:cNvSpPr>
+            <a:spLocks xmlns:a="http://schemas.openxmlformats.org/drawingml/2006/main" noGrp="1"/>
+          </p:cNvSpPr>
+          <p:nvPr/>
+        </p:nvSpPr>
+        <p:spPr>
+          <a:xfrm xmlns:a="http://schemas.openxmlformats.org/drawingml/2006/main">
+            <a:off x="400050" y="266700"/>
+            <a:ext cx="6667500" cy="266700"/>
+          </a:xfrm>
+          <a:prstGeom xmlns:a="http://schemas.openxmlformats.org/drawingml/2006/main" prst="rect">
+            <a:avLst/>
+          </a:prstGeom>
+          <a:noFill xmlns:a="http://schemas.openxmlformats.org/drawingml/2006/main"/>
+          <a:ln xmlns:a="http://schemas.openxmlformats.org/drawingml/2006/main" w="0">
+            <a:noFill/>
+            <a:prstDash val="solid"/>
+          </a:ln>
+        </p:spPr>
+        <p:txBody>
+          <a:bodyPr xmlns:a="http://schemas.openxmlformats.org/drawingml/2006/main" anchor="t"/>
+          <a:lstStyle xmlns:a="http://schemas.openxmlformats.org/drawingml/2006/main"/>
+          <a:p xmlns:a="http://schemas.openxmlformats.org/drawingml/2006/main">
+            <a:pPr algn="l">
+              <a:buNone/>
+              <a:defRPr sz="1200" b="1">
+                <a:solidFill>
+                  <a:srgbClr val="5D636D"/>
+                </a:solidFill>
+                <a:latin typeface="Helvetica Neue"/>
+                <a:ea typeface="Helvetica Neue"/>
+                <a:cs typeface="Helvetica Neue"/>
+              </a:defRPr>
+            </a:pPr>
+            <a:r>
+              <a:rPr sz="1200" b="1">
+                <a:solidFill>
+                  <a:srgbClr val="5D636D"/>
+                </a:solidFill>
+                <a:latin typeface="Helvetica Neue"/>
+                <a:ea typeface="Helvetica Neue"/>
+                <a:cs typeface="Helvetica Neue"/>
+              </a:rPr>
+              <a:t>MULTI-AGENT DEFENSE EVALUATION</a:t>
+            </a:r>
+          </a:p>
+        </p:txBody>
+      </p:sp>
+      <p:sp>
+        <p:nvSpPr>
+          <p:cNvPr id="2" name="slide-10-title">
+            <a:extLst xmlns:a="http://schemas.openxmlformats.org/drawingml/2006/main">
+              <a:ext uri="{FF2B5EF4-FFF2-40B4-BE49-F238E27FC236}">
+                <a16:creationId xmlns:a16="http://schemas.microsoft.com/office/drawing/2014/main" id="{E07834F3-1512-4A27-BD49-56266779D743}"/>
+              </a:ext>
+            </a:extLst>
+          </p:cNvPr>
+          <p:cNvSpPr>
+            <a:spLocks xmlns:a="http://schemas.openxmlformats.org/drawingml/2006/main" noGrp="1"/>
+          </p:cNvSpPr>
+          <p:nvPr/>
+        </p:nvSpPr>
+        <p:spPr>
+          <a:xfrm xmlns:a="http://schemas.openxmlformats.org/drawingml/2006/main">
+            <a:off x="400050" y="619125"/>
+            <a:ext cx="11049000" cy="742950"/>
+          </a:xfrm>
+          <a:prstGeom xmlns:a="http://schemas.openxmlformats.org/drawingml/2006/main" prst="rect">
+            <a:avLst/>
+          </a:prstGeom>
+          <a:noFill xmlns:a="http://schemas.openxmlformats.org/drawingml/2006/main"/>
+          <a:ln xmlns:a="http://schemas.openxmlformats.org/drawingml/2006/main" w="0">
+            <a:noFill/>
+            <a:prstDash val="solid"/>
+          </a:ln>
+        </p:spPr>
+        <p:txBody>
+          <a:bodyPr xmlns:a="http://schemas.openxmlformats.org/drawingml/2006/main" anchor="t"/>
+          <a:lstStyle xmlns:a="http://schemas.openxmlformats.org/drawingml/2006/main"/>
+          <a:p xmlns:a="http://schemas.openxmlformats.org/drawingml/2006/main">
+            <a:pPr algn="l">
+              <a:buNone/>
+              <a:defRPr sz="3000" b="1">
+                <a:solidFill>
+                  <a:srgbClr val="000000"/>
+                </a:solidFill>
+                <a:latin typeface="Helvetica Neue"/>
+                <a:ea typeface="Helvetica Neue"/>
+                <a:cs typeface="Helvetica Neue"/>
+              </a:defRPr>
+            </a:pPr>
+            <a:r>
+              <a:rPr sz="3000" b="1">
+                <a:solidFill>
+                  <a:srgbClr val="000000"/>
+                </a:solidFill>
+                <a:latin typeface="Helvetica Neue"/>
+                <a:ea typeface="Helvetica Neue"/>
+                <a:cs typeface="Helvetica Neue"/>
+              </a:rPr>
+              <a:t>Five insights change multi-agent defense design</a:t>
+            </a:r>
+          </a:p>
+        </p:txBody>
+      </p:sp>
+      <p:sp>
+        <p:nvSpPr>
+          <p:cNvPr id="3" name="">
+            <a:extLst xmlns:a="http://schemas.openxmlformats.org/drawingml/2006/main">
+              <a:ext uri="{FF2B5EF4-FFF2-40B4-BE49-F238E27FC236}">
+                <a16:creationId xmlns:a16="http://schemas.microsoft.com/office/drawing/2014/main" id="{779D766C-49B7-429F-A581-E931604A8FE8}"/>
+              </a:ext>
+            </a:extLst>
+          </p:cNvPr>
+          <p:cNvSpPr>
+            <a:spLocks xmlns:a="http://schemas.openxmlformats.org/drawingml/2006/main" noGrp="1"/>
+          </p:cNvSpPr>
+          <p:nvPr/>
+        </p:nvSpPr>
+        <p:spPr>
+          <a:xfrm xmlns:a="http://schemas.openxmlformats.org/drawingml/2006/main">
+            <a:off x="11239500" y="6334125"/>
+            <a:ext cx="523875" cy="228600"/>
+          </a:xfrm>
+          <a:prstGeom xmlns:a="http://schemas.openxmlformats.org/drawingml/2006/main" prst="rect">
+            <a:avLst/>
+          </a:prstGeom>
+          <a:noFill xmlns:a="http://schemas.openxmlformats.org/drawingml/2006/main"/>
+          <a:ln xmlns:a="http://schemas.openxmlformats.org/drawingml/2006/main" w="0">
+            <a:noFill/>
+            <a:prstDash val="solid"/>
+          </a:ln>
+        </p:spPr>
+        <p:txBody>
+          <a:bodyPr xmlns:a="http://schemas.openxmlformats.org/drawingml/2006/main" anchor="t"/>
+          <a:lstStyle xmlns:a="http://schemas.openxmlformats.org/drawingml/2006/main"/>
+          <a:p xmlns:a="http://schemas.openxmlformats.org/drawingml/2006/main">
+            <a:pPr algn="r">
+              <a:buNone/>
+              <a:defRPr sz="1050" b="0">
+                <a:solidFill>
+                  <a:srgbClr val="5D636D"/>
+                </a:solidFill>
+                <a:latin typeface="Helvetica Neue"/>
+                <a:ea typeface="Helvetica Neue"/>
+                <a:cs typeface="Helvetica Neue"/>
+              </a:defRPr>
+            </a:pPr>
+            <a:r>
+              <a:rPr sz="1050" b="0">
+                <a:solidFill>
+                  <a:srgbClr val="5D636D"/>
+                </a:solidFill>
+                <a:latin typeface="Helvetica Neue"/>
+                <a:ea typeface="Helvetica Neue"/>
+                <a:cs typeface="Helvetica Neue"/>
+              </a:rPr>
+              <a:t>20</a:t>
+            </a:r>
+          </a:p>
+        </p:txBody>
+      </p:sp>
+      <p:sp>
+        <p:nvSpPr>
+          <p:cNvPr id="4" name="">
+            <a:extLst xmlns:a="http://schemas.openxmlformats.org/drawingml/2006/main">
+              <a:ext uri="{FF2B5EF4-FFF2-40B4-BE49-F238E27FC236}">
+                <a16:creationId xmlns:a16="http://schemas.microsoft.com/office/drawing/2014/main" id="{4A392410-FACB-4AF5-9012-FFC9E47843C1}"/>
+              </a:ext>
+            </a:extLst>
+          </p:cNvPr>
+          <p:cNvSpPr>
+            <a:spLocks xmlns:a="http://schemas.openxmlformats.org/drawingml/2006/main" noGrp="1"/>
+          </p:cNvSpPr>
+          <p:nvPr/>
+        </p:nvSpPr>
+        <p:spPr>
+          <a:xfrm xmlns:a="http://schemas.openxmlformats.org/drawingml/2006/main">
+            <a:off x="476250" y="1581150"/>
+            <a:ext cx="619125" cy="266700"/>
+          </a:xfrm>
+          <a:prstGeom xmlns:a="http://schemas.openxmlformats.org/drawingml/2006/main" prst="rect">
+            <a:avLst/>
+          </a:prstGeom>
+          <a:noFill xmlns:a="http://schemas.openxmlformats.org/drawingml/2006/main"/>
+          <a:ln xmlns:a="http://schemas.openxmlformats.org/drawingml/2006/main" w="0">
+            <a:noFill/>
+            <a:prstDash val="solid"/>
+          </a:ln>
+        </p:spPr>
+        <p:txBody>
+          <a:bodyPr xmlns:a="http://schemas.openxmlformats.org/drawingml/2006/main" anchor="t"/>
+          <a:lstStyle xmlns:a="http://schemas.openxmlformats.org/drawingml/2006/main"/>
+          <a:p xmlns:a="http://schemas.openxmlformats.org/drawingml/2006/main">
+            <a:pPr algn="l">
+              <a:buNone/>
+              <a:defRPr sz="1275" b="1">
+                <a:solidFill>
+                  <a:srgbClr val="5D636D"/>
+                </a:solidFill>
+                <a:latin typeface="Helvetica Neue"/>
+                <a:ea typeface="Helvetica Neue"/>
+                <a:cs typeface="Helvetica Neue"/>
+              </a:defRPr>
+            </a:pPr>
+            <a:r>
+              <a:rPr sz="1275" b="1">
+                <a:solidFill>
+                  <a:srgbClr val="5D636D"/>
+                </a:solidFill>
+                <a:latin typeface="Helvetica Neue"/>
+                <a:ea typeface="Helvetica Neue"/>
+                <a:cs typeface="Helvetica Neue"/>
+              </a:rPr>
+              <a:t>#</a:t>
+            </a:r>
+          </a:p>
+        </p:txBody>
+      </p:sp>
+      <p:sp>
+        <p:nvSpPr>
+          <p:cNvPr id="5" name="">
+            <a:extLst xmlns:a="http://schemas.openxmlformats.org/drawingml/2006/main">
+              <a:ext uri="{FF2B5EF4-FFF2-40B4-BE49-F238E27FC236}">
+                <a16:creationId xmlns:a16="http://schemas.microsoft.com/office/drawing/2014/main" id="{F7690FD0-06E6-4DB6-947B-F1EEFE290E75}"/>
+              </a:ext>
+            </a:extLst>
+          </p:cNvPr>
+          <p:cNvSpPr>
+            <a:spLocks xmlns:a="http://schemas.openxmlformats.org/drawingml/2006/main" noGrp="1"/>
+          </p:cNvSpPr>
+          <p:nvPr/>
+        </p:nvSpPr>
+        <p:spPr>
+          <a:xfrm xmlns:a="http://schemas.openxmlformats.org/drawingml/2006/main">
+            <a:off x="1285875" y="1581150"/>
+            <a:ext cx="2667000" cy="266700"/>
+          </a:xfrm>
+          <a:prstGeom xmlns:a="http://schemas.openxmlformats.org/drawingml/2006/main" prst="rect">
+            <a:avLst/>
+          </a:prstGeom>
+          <a:noFill xmlns:a="http://schemas.openxmlformats.org/drawingml/2006/main"/>
+          <a:ln xmlns:a="http://schemas.openxmlformats.org/drawingml/2006/main" w="0">
+            <a:noFill/>
+            <a:prstDash val="solid"/>
+          </a:ln>
+        </p:spPr>
+        <p:txBody>
+          <a:bodyPr xmlns:a="http://schemas.openxmlformats.org/drawingml/2006/main" anchor="t"/>
+          <a:lstStyle xmlns:a="http://schemas.openxmlformats.org/drawingml/2006/main"/>
+          <a:p xmlns:a="http://schemas.openxmlformats.org/drawingml/2006/main">
+            <a:pPr algn="l">
+              <a:buNone/>
+              <a:defRPr sz="1275" b="1">
+                <a:solidFill>
+                  <a:srgbClr val="5D636D"/>
+                </a:solidFill>
+                <a:latin typeface="Helvetica Neue"/>
+                <a:ea typeface="Helvetica Neue"/>
+                <a:cs typeface="Helvetica Neue"/>
+              </a:defRPr>
+            </a:pPr>
+            <a:r>
+              <a:rPr sz="1275" b="1">
+                <a:solidFill>
+                  <a:srgbClr val="5D636D"/>
+                </a:solidFill>
+                <a:latin typeface="Helvetica Neue"/>
+                <a:ea typeface="Helvetica Neue"/>
+                <a:cs typeface="Helvetica Neue"/>
+              </a:rPr>
+              <a:t>INSIGHT</a:t>
+            </a:r>
+          </a:p>
+        </p:txBody>
+      </p:sp>
+      <p:sp>
+        <p:nvSpPr>
+          <p:cNvPr id="6" name="">
+            <a:extLst xmlns:a="http://schemas.openxmlformats.org/drawingml/2006/main">
+              <a:ext uri="{FF2B5EF4-FFF2-40B4-BE49-F238E27FC236}">
+                <a16:creationId xmlns:a16="http://schemas.microsoft.com/office/drawing/2014/main" id="{BDECB01F-1972-446C-8808-A0CCD550671E}"/>
+              </a:ext>
+            </a:extLst>
+          </p:cNvPr>
+          <p:cNvSpPr>
+            <a:spLocks xmlns:a="http://schemas.openxmlformats.org/drawingml/2006/main" noGrp="1"/>
+          </p:cNvSpPr>
+          <p:nvPr/>
+        </p:nvSpPr>
+        <p:spPr>
+          <a:xfrm xmlns:a="http://schemas.openxmlformats.org/drawingml/2006/main">
+            <a:off x="4095750" y="1581150"/>
+            <a:ext cx="5191125" cy="266700"/>
+          </a:xfrm>
+          <a:prstGeom xmlns:a="http://schemas.openxmlformats.org/drawingml/2006/main" prst="rect">
+            <a:avLst/>
+          </a:prstGeom>
+          <a:noFill xmlns:a="http://schemas.openxmlformats.org/drawingml/2006/main"/>
+          <a:ln xmlns:a="http://schemas.openxmlformats.org/drawingml/2006/main" w="0">
+            <a:noFill/>
+            <a:prstDash val="solid"/>
+          </a:ln>
+        </p:spPr>
+        <p:txBody>
+          <a:bodyPr xmlns:a="http://schemas.openxmlformats.org/drawingml/2006/main" anchor="t"/>
+          <a:lstStyle xmlns:a="http://schemas.openxmlformats.org/drawingml/2006/main"/>
+          <a:p xmlns:a="http://schemas.openxmlformats.org/drawingml/2006/main">
+            <a:pPr algn="l">
+              <a:buNone/>
+              <a:defRPr sz="1275" b="1">
+                <a:solidFill>
+                  <a:srgbClr val="5D636D"/>
+                </a:solidFill>
+                <a:latin typeface="Helvetica Neue"/>
+                <a:ea typeface="Helvetica Neue"/>
+                <a:cs typeface="Helvetica Neue"/>
+              </a:defRPr>
+            </a:pPr>
+            <a:r>
+              <a:rPr sz="1275" b="1">
+                <a:solidFill>
+                  <a:srgbClr val="5D636D"/>
+                </a:solidFill>
+                <a:latin typeface="Helvetica Neue"/>
+                <a:ea typeface="Helvetica Neue"/>
+                <a:cs typeface="Helvetica Neue"/>
+              </a:rPr>
+              <a:t>WHAT THE EVIDENCE SHOWS</a:t>
+            </a:r>
+          </a:p>
+        </p:txBody>
+      </p:sp>
+      <p:sp>
+        <p:nvSpPr>
+          <p:cNvPr id="7" name="">
+            <a:extLst xmlns:a="http://schemas.openxmlformats.org/drawingml/2006/main">
+              <a:ext uri="{FF2B5EF4-FFF2-40B4-BE49-F238E27FC236}">
+                <a16:creationId xmlns:a16="http://schemas.microsoft.com/office/drawing/2014/main" id="{41ACECBB-4FF3-44E9-8319-A035E4FAFAC6}"/>
+              </a:ext>
+            </a:extLst>
+          </p:cNvPr>
+          <p:cNvSpPr>
+            <a:spLocks xmlns:a="http://schemas.openxmlformats.org/drawingml/2006/main" noGrp="1"/>
+          </p:cNvSpPr>
+          <p:nvPr/>
+        </p:nvSpPr>
+        <p:spPr>
+          <a:xfrm xmlns:a="http://schemas.openxmlformats.org/drawingml/2006/main">
+            <a:off x="9858375" y="1581150"/>
+            <a:ext cx="1524000" cy="266700"/>
+          </a:xfrm>
+          <a:prstGeom xmlns:a="http://schemas.openxmlformats.org/drawingml/2006/main" prst="rect">
+            <a:avLst/>
+          </a:prstGeom>
+          <a:noFill xmlns:a="http://schemas.openxmlformats.org/drawingml/2006/main"/>
+          <a:ln xmlns:a="http://schemas.openxmlformats.org/drawingml/2006/main" w="0">
+            <a:noFill/>
+            <a:prstDash val="solid"/>
+          </a:ln>
+        </p:spPr>
+        <p:txBody>
+          <a:bodyPr xmlns:a="http://schemas.openxmlformats.org/drawingml/2006/main" anchor="t"/>
+          <a:lstStyle xmlns:a="http://schemas.openxmlformats.org/drawingml/2006/main"/>
+          <a:p xmlns:a="http://schemas.openxmlformats.org/drawingml/2006/main">
+            <a:pPr algn="l">
+              <a:buNone/>
+              <a:defRPr sz="1275" b="1">
+                <a:solidFill>
+                  <a:srgbClr val="5D636D"/>
+                </a:solidFill>
+                <a:latin typeface="Helvetica Neue"/>
+                <a:ea typeface="Helvetica Neue"/>
+                <a:cs typeface="Helvetica Neue"/>
+              </a:defRPr>
+            </a:pPr>
+            <a:r>
+              <a:rPr sz="1275" b="1">
+                <a:solidFill>
+                  <a:srgbClr val="5D636D"/>
+                </a:solidFill>
+                <a:latin typeface="Helvetica Neue"/>
+                <a:ea typeface="Helvetica Neue"/>
+                <a:cs typeface="Helvetica Neue"/>
+              </a:rPr>
+              <a:t>DESIGN MOVE</a:t>
+            </a:r>
+          </a:p>
+        </p:txBody>
+      </p:sp>
+      <p:cxnSp>
+        <p:nvCxnSpPr>
+          <p:cNvPr id="136" name=""/>
+          <p:cNvCxnSpPr/>
+          <p:nvPr/>
+        </p:nvCxnSpPr>
+        <p:spPr>
+          <a:xfrm xmlns:a="http://schemas.openxmlformats.org/drawingml/2006/main">
+            <a:off x="400050" y="1943100"/>
+            <a:ext cx="11391900" cy="0"/>
+          </a:xfrm>
+          <a:prstGeom xmlns:a="http://schemas.openxmlformats.org/drawingml/2006/main" prst="straightConnector1">
+            <a:avLst/>
+          </a:prstGeom>
+          <a:ln xmlns:a="http://schemas.openxmlformats.org/drawingml/2006/main" w="19050">
+            <a:solidFill>
+              <a:srgbClr val="000000"/>
+            </a:solidFill>
+            <a:prstDash val="solid"/>
+          </a:ln>
+        </p:spPr>
+      </p:cxnSp>
+      <p:sp>
+        <p:nvSpPr>
+          <p:cNvPr id="9" name="">
+            <a:extLst xmlns:a="http://schemas.openxmlformats.org/drawingml/2006/main">
+              <a:ext uri="{FF2B5EF4-FFF2-40B4-BE49-F238E27FC236}">
+                <a16:creationId xmlns:a16="http://schemas.microsoft.com/office/drawing/2014/main" id="{BC3959C0-5CF5-46FF-95A8-B49BF9450EED}"/>
+              </a:ext>
+            </a:extLst>
+          </p:cNvPr>
+          <p:cNvSpPr>
+            <a:spLocks xmlns:a="http://schemas.openxmlformats.org/drawingml/2006/main" noGrp="1"/>
+          </p:cNvSpPr>
+          <p:nvPr/>
+        </p:nvSpPr>
+        <p:spPr>
+          <a:xfrm xmlns:a="http://schemas.openxmlformats.org/drawingml/2006/main">
+            <a:off x="400050" y="2019300"/>
+            <a:ext cx="11391900" cy="685800"/>
+          </a:xfrm>
+          <a:prstGeom xmlns:a="http://schemas.openxmlformats.org/drawingml/2006/main" prst="rect">
+            <a:avLst/>
+          </a:prstGeom>
+          <a:solidFill xmlns:a="http://schemas.openxmlformats.org/drawingml/2006/main">
+            <a:srgbClr val="F6F7F8"/>
+          </a:solidFill>
+          <a:ln xmlns:a="http://schemas.openxmlformats.org/drawingml/2006/main" w="0">
+            <a:noFill/>
+            <a:prstDash val="solid"/>
+          </a:ln>
+        </p:spPr>
+      </p:sp>
+      <p:sp>
+        <p:nvSpPr>
+          <p:cNvPr id="10" name="">
+            <a:extLst xmlns:a="http://schemas.openxmlformats.org/drawingml/2006/main">
+              <a:ext uri="{FF2B5EF4-FFF2-40B4-BE49-F238E27FC236}">
+                <a16:creationId xmlns:a16="http://schemas.microsoft.com/office/drawing/2014/main" id="{0AA9A9D8-6F11-42C5-AD56-63A26CC97D8F}"/>
+              </a:ext>
+            </a:extLst>
+          </p:cNvPr>
+          <p:cNvSpPr>
+            <a:spLocks xmlns:a="http://schemas.openxmlformats.org/drawingml/2006/main" noGrp="1"/>
+          </p:cNvSpPr>
+          <p:nvPr/>
+        </p:nvSpPr>
+        <p:spPr>
+          <a:xfrm xmlns:a="http://schemas.openxmlformats.org/drawingml/2006/main">
+            <a:off x="476250" y="2114550"/>
+            <a:ext cx="619125" cy="285750"/>
+          </a:xfrm>
+          <a:prstGeom xmlns:a="http://schemas.openxmlformats.org/drawingml/2006/main" prst="rect">
+            <a:avLst/>
+          </a:prstGeom>
+          <a:noFill xmlns:a="http://schemas.openxmlformats.org/drawingml/2006/main"/>
+          <a:ln xmlns:a="http://schemas.openxmlformats.org/drawingml/2006/main" w="0">
+            <a:noFill/>
+            <a:prstDash val="solid"/>
+          </a:ln>
+        </p:spPr>
+        <p:txBody>
+          <a:bodyPr xmlns:a="http://schemas.openxmlformats.org/drawingml/2006/main" anchor="t"/>
+          <a:lstStyle xmlns:a="http://schemas.openxmlformats.org/drawingml/2006/main"/>
+          <a:p xmlns:a="http://schemas.openxmlformats.org/drawingml/2006/main">
+            <a:pPr algn="l">
+              <a:buNone/>
+              <a:defRPr sz="1500" b="1">
+                <a:solidFill>
+                  <a:srgbClr val="000000"/>
+                </a:solidFill>
+                <a:latin typeface="Helvetica Neue"/>
+                <a:ea typeface="Helvetica Neue"/>
+                <a:cs typeface="Helvetica Neue"/>
+              </a:defRPr>
+            </a:pPr>
+            <a:r>
+              <a:rPr sz="1500" b="1">
+                <a:solidFill>
+                  <a:srgbClr val="000000"/>
+                </a:solidFill>
+                <a:latin typeface="Helvetica Neue"/>
+                <a:ea typeface="Helvetica Neue"/>
+                <a:cs typeface="Helvetica Neue"/>
+              </a:rPr>
+              <a:t>1</a:t>
+            </a:r>
+          </a:p>
+        </p:txBody>
+      </p:sp>
+      <p:sp>
+        <p:nvSpPr>
+          <p:cNvPr id="11" name="">
+            <a:extLst xmlns:a="http://schemas.openxmlformats.org/drawingml/2006/main">
+              <a:ext uri="{FF2B5EF4-FFF2-40B4-BE49-F238E27FC236}">
+                <a16:creationId xmlns:a16="http://schemas.microsoft.com/office/drawing/2014/main" id="{E4AB5759-755D-4F48-BBF0-3A52CF17B60F}"/>
+              </a:ext>
+            </a:extLst>
+          </p:cNvPr>
+          <p:cNvSpPr>
+            <a:spLocks xmlns:a="http://schemas.openxmlformats.org/drawingml/2006/main" noGrp="1"/>
+          </p:cNvSpPr>
+          <p:nvPr/>
+        </p:nvSpPr>
+        <p:spPr>
+          <a:xfrm xmlns:a="http://schemas.openxmlformats.org/drawingml/2006/main">
+            <a:off x="1285875" y="2114550"/>
+            <a:ext cx="2667000" cy="457200"/>
+          </a:xfrm>
+          <a:prstGeom xmlns:a="http://schemas.openxmlformats.org/drawingml/2006/main" prst="rect">
+            <a:avLst/>
+          </a:prstGeom>
+          <a:noFill xmlns:a="http://schemas.openxmlformats.org/drawingml/2006/main"/>
+          <a:ln xmlns:a="http://schemas.openxmlformats.org/drawingml/2006/main" w="0">
+            <a:noFill/>
+            <a:prstDash val="solid"/>
+          </a:ln>
+        </p:spPr>
+        <p:txBody>
+          <a:bodyPr xmlns:a="http://schemas.openxmlformats.org/drawingml/2006/main" anchor="t"/>
+          <a:lstStyle xmlns:a="http://schemas.openxmlformats.org/drawingml/2006/main"/>
+          <a:p xmlns:a="http://schemas.openxmlformats.org/drawingml/2006/main">
+            <a:pPr algn="l">
+              <a:buNone/>
+              <a:defRPr sz="1425" b="1">
+                <a:solidFill>
+                  <a:srgbClr val="000000"/>
+                </a:solidFill>
+                <a:latin typeface="Helvetica Neue"/>
+                <a:ea typeface="Helvetica Neue"/>
+                <a:cs typeface="Helvetica Neue"/>
+              </a:defRPr>
+            </a:pPr>
+            <a:r>
+              <a:rPr sz="1425" b="1">
+                <a:solidFill>
+                  <a:srgbClr val="000000"/>
+                </a:solidFill>
+                <a:latin typeface="Helvetica Neue"/>
+                <a:ea typeface="Helvetica Neue"/>
+                <a:cs typeface="Helvetica Neue"/>
+              </a:rPr>
+              <a:t>Security is compositional</a:t>
+            </a:r>
+          </a:p>
+        </p:txBody>
+      </p:sp>
+      <p:sp>
+        <p:nvSpPr>
+          <p:cNvPr id="12" name="">
+            <a:extLst xmlns:a="http://schemas.openxmlformats.org/drawingml/2006/main">
+              <a:ext uri="{FF2B5EF4-FFF2-40B4-BE49-F238E27FC236}">
+                <a16:creationId xmlns:a16="http://schemas.microsoft.com/office/drawing/2014/main" id="{FE09F39D-BB0F-448D-96CD-FD5FC5AA92F7}"/>
+              </a:ext>
+            </a:extLst>
+          </p:cNvPr>
+          <p:cNvSpPr>
+            <a:spLocks xmlns:a="http://schemas.openxmlformats.org/drawingml/2006/main" noGrp="1"/>
+          </p:cNvSpPr>
+          <p:nvPr/>
+        </p:nvSpPr>
+        <p:spPr>
+          <a:xfrm xmlns:a="http://schemas.openxmlformats.org/drawingml/2006/main">
+            <a:off x="4095750" y="2114550"/>
+            <a:ext cx="5191125" cy="457200"/>
+          </a:xfrm>
+          <a:prstGeom xmlns:a="http://schemas.openxmlformats.org/drawingml/2006/main" prst="rect">
+            <a:avLst/>
+          </a:prstGeom>
+          <a:noFill xmlns:a="http://schemas.openxmlformats.org/drawingml/2006/main"/>
+          <a:ln xmlns:a="http://schemas.openxmlformats.org/drawingml/2006/main" w="0">
+            <a:noFill/>
+            <a:prstDash val="solid"/>
+          </a:ln>
+        </p:spPr>
+        <p:txBody>
+          <a:bodyPr xmlns:a="http://schemas.openxmlformats.org/drawingml/2006/main" anchor="t"/>
+          <a:lstStyle xmlns:a="http://schemas.openxmlformats.org/drawingml/2006/main"/>
+          <a:p xmlns:a="http://schemas.openxmlformats.org/drawingml/2006/main">
+            <a:pPr algn="l">
+              <a:buNone/>
+              <a:defRPr sz="1350" b="0">
+                <a:solidFill>
+                  <a:srgbClr val="5D636D"/>
+                </a:solidFill>
+                <a:latin typeface="Helvetica Neue"/>
+                <a:ea typeface="Helvetica Neue"/>
+                <a:cs typeface="Helvetica Neue"/>
+              </a:defRPr>
+            </a:pPr>
+            <a:r>
+              <a:rPr sz="1350" b="0">
+                <a:solidFill>
+                  <a:srgbClr val="5D636D"/>
+                </a:solidFill>
+                <a:latin typeface="Helvetica Neue"/>
+                <a:ea typeface="Helvetica Neue"/>
+                <a:cs typeface="Helvetica Neue"/>
+              </a:rPr>
+              <a:t>Local-only checks permitted a harmful six-role workflow.</a:t>
+            </a:r>
+          </a:p>
+        </p:txBody>
+      </p:sp>
+      <p:sp>
+        <p:nvSpPr>
+          <p:cNvPr id="13" name="">
+            <a:extLst xmlns:a="http://schemas.openxmlformats.org/drawingml/2006/main">
+              <a:ext uri="{FF2B5EF4-FFF2-40B4-BE49-F238E27FC236}">
+                <a16:creationId xmlns:a16="http://schemas.microsoft.com/office/drawing/2014/main" id="{B5D2D3CA-72DC-4411-B627-E259685AF77E}"/>
+              </a:ext>
+            </a:extLst>
+          </p:cNvPr>
+          <p:cNvSpPr>
+            <a:spLocks xmlns:a="http://schemas.openxmlformats.org/drawingml/2006/main" noGrp="1"/>
+          </p:cNvSpPr>
+          <p:nvPr/>
+        </p:nvSpPr>
+        <p:spPr>
+          <a:xfrm xmlns:a="http://schemas.openxmlformats.org/drawingml/2006/main">
+            <a:off x="9858375" y="2114550"/>
+            <a:ext cx="1524000" cy="304800"/>
+          </a:xfrm>
+          <a:prstGeom xmlns:a="http://schemas.openxmlformats.org/drawingml/2006/main" prst="rect">
+            <a:avLst/>
+          </a:prstGeom>
+          <a:noFill xmlns:a="http://schemas.openxmlformats.org/drawingml/2006/main"/>
+          <a:ln xmlns:a="http://schemas.openxmlformats.org/drawingml/2006/main" w="0">
+            <a:noFill/>
+            <a:prstDash val="solid"/>
+          </a:ln>
+        </p:spPr>
+        <p:txBody>
+          <a:bodyPr xmlns:a="http://schemas.openxmlformats.org/drawingml/2006/main" anchor="t"/>
+          <a:lstStyle xmlns:a="http://schemas.openxmlformats.org/drawingml/2006/main"/>
+          <a:p xmlns:a="http://schemas.openxmlformats.org/drawingml/2006/main">
+            <a:pPr algn="l">
+              <a:buNone/>
+              <a:defRPr sz="1425" b="1">
+                <a:solidFill>
+                  <a:srgbClr val="3D8DFF"/>
+                </a:solidFill>
+                <a:latin typeface="Helvetica Neue"/>
+                <a:ea typeface="Helvetica Neue"/>
+                <a:cs typeface="Helvetica Neue"/>
+              </a:defRPr>
+            </a:pPr>
+            <a:r>
+              <a:rPr sz="1425" b="1">
+                <a:solidFill>
+                  <a:srgbClr val="3D8DFF"/>
+                </a:solidFill>
+                <a:latin typeface="Helvetica Neue"/>
+                <a:ea typeface="Helvetica Neue"/>
+                <a:cs typeface="Helvetica Neue"/>
+              </a:rPr>
+              <a:t>TRACE TRAJECTORY</a:t>
+            </a:r>
+          </a:p>
+        </p:txBody>
+      </p:sp>
+      <p:sp>
+        <p:nvSpPr>
+          <p:cNvPr id="14" name="">
+            <a:extLst xmlns:a="http://schemas.openxmlformats.org/drawingml/2006/main">
+              <a:ext uri="{FF2B5EF4-FFF2-40B4-BE49-F238E27FC236}">
+                <a16:creationId xmlns:a16="http://schemas.microsoft.com/office/drawing/2014/main" id="{1D4DCAE7-2AC5-43FD-9062-C791D0DA54BF}"/>
+              </a:ext>
+            </a:extLst>
+          </p:cNvPr>
+          <p:cNvSpPr>
+            <a:spLocks xmlns:a="http://schemas.openxmlformats.org/drawingml/2006/main" noGrp="1"/>
+          </p:cNvSpPr>
+          <p:nvPr/>
+        </p:nvSpPr>
+        <p:spPr>
+          <a:xfrm xmlns:a="http://schemas.openxmlformats.org/drawingml/2006/main">
+            <a:off x="476250" y="2895600"/>
+            <a:ext cx="619125" cy="285750"/>
+          </a:xfrm>
+          <a:prstGeom xmlns:a="http://schemas.openxmlformats.org/drawingml/2006/main" prst="rect">
+            <a:avLst/>
+          </a:prstGeom>
+          <a:noFill xmlns:a="http://schemas.openxmlformats.org/drawingml/2006/main"/>
+          <a:ln xmlns:a="http://schemas.openxmlformats.org/drawingml/2006/main" w="0">
+            <a:noFill/>
+            <a:prstDash val="solid"/>
+          </a:ln>
+        </p:spPr>
+        <p:txBody>
+          <a:bodyPr xmlns:a="http://schemas.openxmlformats.org/drawingml/2006/main" anchor="t"/>
+          <a:lstStyle xmlns:a="http://schemas.openxmlformats.org/drawingml/2006/main"/>
+          <a:p xmlns:a="http://schemas.openxmlformats.org/drawingml/2006/main">
+            <a:pPr algn="l">
+              <a:buNone/>
+              <a:defRPr sz="1500" b="1">
+                <a:solidFill>
+                  <a:srgbClr val="000000"/>
+                </a:solidFill>
+                <a:latin typeface="Helvetica Neue"/>
+                <a:ea typeface="Helvetica Neue"/>
+                <a:cs typeface="Helvetica Neue"/>
+              </a:defRPr>
+            </a:pPr>
+            <a:r>
+              <a:rPr sz="1500" b="1">
+                <a:solidFill>
+                  <a:srgbClr val="000000"/>
+                </a:solidFill>
+                <a:latin typeface="Helvetica Neue"/>
+                <a:ea typeface="Helvetica Neue"/>
+                <a:cs typeface="Helvetica Neue"/>
+              </a:rPr>
+              <a:t>2</a:t>
+            </a:r>
+          </a:p>
+        </p:txBody>
+      </p:sp>
+      <p:sp>
+        <p:nvSpPr>
+          <p:cNvPr id="15" name="">
+            <a:extLst xmlns:a="http://schemas.openxmlformats.org/drawingml/2006/main">
+              <a:ext uri="{FF2B5EF4-FFF2-40B4-BE49-F238E27FC236}">
+                <a16:creationId xmlns:a16="http://schemas.microsoft.com/office/drawing/2014/main" id="{DEABFCDC-D759-4FFC-9FEB-4AB3624D831D}"/>
+              </a:ext>
+            </a:extLst>
+          </p:cNvPr>
+          <p:cNvSpPr>
+            <a:spLocks xmlns:a="http://schemas.openxmlformats.org/drawingml/2006/main" noGrp="1"/>
+          </p:cNvSpPr>
+          <p:nvPr/>
+        </p:nvSpPr>
+        <p:spPr>
+          <a:xfrm xmlns:a="http://schemas.openxmlformats.org/drawingml/2006/main">
+            <a:off x="1285875" y="2895600"/>
+            <a:ext cx="2667000" cy="457200"/>
+          </a:xfrm>
+          <a:prstGeom xmlns:a="http://schemas.openxmlformats.org/drawingml/2006/main" prst="rect">
+            <a:avLst/>
+          </a:prstGeom>
+          <a:noFill xmlns:a="http://schemas.openxmlformats.org/drawingml/2006/main"/>
+          <a:ln xmlns:a="http://schemas.openxmlformats.org/drawingml/2006/main" w="0">
+            <a:noFill/>
+            <a:prstDash val="solid"/>
+          </a:ln>
+        </p:spPr>
+        <p:txBody>
+          <a:bodyPr xmlns:a="http://schemas.openxmlformats.org/drawingml/2006/main" anchor="t"/>
+          <a:lstStyle xmlns:a="http://schemas.openxmlformats.org/drawingml/2006/main"/>
+          <a:p xmlns:a="http://schemas.openxmlformats.org/drawingml/2006/main">
+            <a:pPr algn="l">
+              <a:buNone/>
+              <a:defRPr sz="1425" b="1">
+                <a:solidFill>
+                  <a:srgbClr val="000000"/>
+                </a:solidFill>
+                <a:latin typeface="Helvetica Neue"/>
+                <a:ea typeface="Helvetica Neue"/>
+                <a:cs typeface="Helvetica Neue"/>
+              </a:defRPr>
+            </a:pPr>
+            <a:r>
+              <a:rPr sz="1425" b="1">
+                <a:solidFill>
+                  <a:srgbClr val="000000"/>
+                </a:solidFill>
+                <a:latin typeface="Helvetica Neue"/>
+                <a:ea typeface="Helvetica Neue"/>
+                <a:cs typeface="Helvetica Neue"/>
+              </a:rPr>
+              <a:t>Representation adapts</a:t>
+            </a:r>
+          </a:p>
+        </p:txBody>
+      </p:sp>
+      <p:sp>
+        <p:nvSpPr>
+          <p:cNvPr id="16" name="">
+            <a:extLst xmlns:a="http://schemas.openxmlformats.org/drawingml/2006/main">
+              <a:ext uri="{FF2B5EF4-FFF2-40B4-BE49-F238E27FC236}">
+                <a16:creationId xmlns:a16="http://schemas.microsoft.com/office/drawing/2014/main" id="{E4695ED0-6BDF-47C0-9E8D-987BCF8A4208}"/>
+              </a:ext>
+            </a:extLst>
+          </p:cNvPr>
+          <p:cNvSpPr>
+            <a:spLocks xmlns:a="http://schemas.openxmlformats.org/drawingml/2006/main" noGrp="1"/>
+          </p:cNvSpPr>
+          <p:nvPr/>
+        </p:nvSpPr>
+        <p:spPr>
+          <a:xfrm xmlns:a="http://schemas.openxmlformats.org/drawingml/2006/main">
+            <a:off x="4095750" y="2895600"/>
+            <a:ext cx="5191125" cy="457200"/>
+          </a:xfrm>
+          <a:prstGeom xmlns:a="http://schemas.openxmlformats.org/drawingml/2006/main" prst="rect">
+            <a:avLst/>
+          </a:prstGeom>
+          <a:noFill xmlns:a="http://schemas.openxmlformats.org/drawingml/2006/main"/>
+          <a:ln xmlns:a="http://schemas.openxmlformats.org/drawingml/2006/main" w="0">
+            <a:noFill/>
+            <a:prstDash val="solid"/>
+          </a:ln>
+        </p:spPr>
+        <p:txBody>
+          <a:bodyPr xmlns:a="http://schemas.openxmlformats.org/drawingml/2006/main" anchor="t"/>
+          <a:lstStyle xmlns:a="http://schemas.openxmlformats.org/drawingml/2006/main"/>
+          <a:p xmlns:a="http://schemas.openxmlformats.org/drawingml/2006/main">
+            <a:pPr algn="l">
+              <a:buNone/>
+              <a:defRPr sz="1350" b="0">
+                <a:solidFill>
+                  <a:srgbClr val="5D636D"/>
+                </a:solidFill>
+                <a:latin typeface="Helvetica Neue"/>
+                <a:ea typeface="Helvetica Neue"/>
+                <a:cs typeface="Helvetica Neue"/>
+              </a:defRPr>
+            </a:pPr>
+            <a:r>
+              <a:rPr sz="1350" b="0">
+                <a:solidFill>
+                  <a:srgbClr val="5D636D"/>
+                </a:solidFill>
+                <a:latin typeface="Helvetica Neue"/>
+                <a:ea typeface="Helvetica Neue"/>
+                <a:cs typeface="Helvetica Neue"/>
+              </a:rPr>
+              <a:t>Semantic adaptation restored 1.00; typed mediation returned success to 0.25.</a:t>
+            </a:r>
+          </a:p>
+        </p:txBody>
+      </p:sp>
+      <p:sp>
+        <p:nvSpPr>
+          <p:cNvPr id="17" name="">
+            <a:extLst xmlns:a="http://schemas.openxmlformats.org/drawingml/2006/main">
+              <a:ext uri="{FF2B5EF4-FFF2-40B4-BE49-F238E27FC236}">
+                <a16:creationId xmlns:a16="http://schemas.microsoft.com/office/drawing/2014/main" id="{FF38898E-93BD-4886-B06B-F44EBF9E8758}"/>
+              </a:ext>
+            </a:extLst>
+          </p:cNvPr>
+          <p:cNvSpPr>
+            <a:spLocks xmlns:a="http://schemas.openxmlformats.org/drawingml/2006/main" noGrp="1"/>
+          </p:cNvSpPr>
+          <p:nvPr/>
+        </p:nvSpPr>
+        <p:spPr>
+          <a:xfrm xmlns:a="http://schemas.openxmlformats.org/drawingml/2006/main">
+            <a:off x="9858375" y="2895600"/>
+            <a:ext cx="1524000" cy="304800"/>
+          </a:xfrm>
+          <a:prstGeom xmlns:a="http://schemas.openxmlformats.org/drawingml/2006/main" prst="rect">
+            <a:avLst/>
+          </a:prstGeom>
+          <a:noFill xmlns:a="http://schemas.openxmlformats.org/drawingml/2006/main"/>
+          <a:ln xmlns:a="http://schemas.openxmlformats.org/drawingml/2006/main" w="0">
+            <a:noFill/>
+            <a:prstDash val="solid"/>
+          </a:ln>
+        </p:spPr>
+        <p:txBody>
+          <a:bodyPr xmlns:a="http://schemas.openxmlformats.org/drawingml/2006/main" anchor="t"/>
+          <a:lstStyle xmlns:a="http://schemas.openxmlformats.org/drawingml/2006/main"/>
+          <a:p xmlns:a="http://schemas.openxmlformats.org/drawingml/2006/main">
+            <a:pPr algn="l">
+              <a:buNone/>
+              <a:defRPr sz="1425" b="1">
+                <a:solidFill>
+                  <a:srgbClr val="3D8DFF"/>
+                </a:solidFill>
+                <a:latin typeface="Helvetica Neue"/>
+                <a:ea typeface="Helvetica Neue"/>
+                <a:cs typeface="Helvetica Neue"/>
+              </a:defRPr>
+            </a:pPr>
+            <a:r>
+              <a:rPr sz="1425" b="1">
+                <a:solidFill>
+                  <a:srgbClr val="3D8DFF"/>
+                </a:solidFill>
+                <a:latin typeface="Helvetica Neue"/>
+                <a:ea typeface="Helvetica Neue"/>
+                <a:cs typeface="Helvetica Neue"/>
+              </a:rPr>
+              <a:t>TYPE INTERFACES</a:t>
+            </a:r>
+          </a:p>
+        </p:txBody>
+      </p:sp>
+      <p:sp>
+        <p:nvSpPr>
+          <p:cNvPr id="18" name="">
+            <a:extLst xmlns:a="http://schemas.openxmlformats.org/drawingml/2006/main">
+              <a:ext uri="{FF2B5EF4-FFF2-40B4-BE49-F238E27FC236}">
+                <a16:creationId xmlns:a16="http://schemas.microsoft.com/office/drawing/2014/main" id="{C31B62F4-6391-4903-B77B-3A5567FDA69A}"/>
+              </a:ext>
+            </a:extLst>
+          </p:cNvPr>
+          <p:cNvSpPr>
+            <a:spLocks xmlns:a="http://schemas.openxmlformats.org/drawingml/2006/main" noGrp="1"/>
+          </p:cNvSpPr>
+          <p:nvPr/>
+        </p:nvSpPr>
+        <p:spPr>
+          <a:xfrm xmlns:a="http://schemas.openxmlformats.org/drawingml/2006/main">
+            <a:off x="400050" y="3581400"/>
+            <a:ext cx="11391900" cy="685800"/>
+          </a:xfrm>
+          <a:prstGeom xmlns:a="http://schemas.openxmlformats.org/drawingml/2006/main" prst="rect">
+            <a:avLst/>
+          </a:prstGeom>
+          <a:solidFill xmlns:a="http://schemas.openxmlformats.org/drawingml/2006/main">
+            <a:srgbClr val="F6F7F8"/>
+          </a:solidFill>
+          <a:ln xmlns:a="http://schemas.openxmlformats.org/drawingml/2006/main" w="0">
+            <a:noFill/>
+            <a:prstDash val="solid"/>
+          </a:ln>
+        </p:spPr>
+      </p:sp>
+      <p:sp>
+        <p:nvSpPr>
+          <p:cNvPr id="19" name="">
+            <a:extLst xmlns:a="http://schemas.openxmlformats.org/drawingml/2006/main">
+              <a:ext uri="{FF2B5EF4-FFF2-40B4-BE49-F238E27FC236}">
+                <a16:creationId xmlns:a16="http://schemas.microsoft.com/office/drawing/2014/main" id="{128D7E86-C26C-47DD-A2AA-EF16EC3C7116}"/>
+              </a:ext>
+            </a:extLst>
+          </p:cNvPr>
+          <p:cNvSpPr>
+            <a:spLocks xmlns:a="http://schemas.openxmlformats.org/drawingml/2006/main" noGrp="1"/>
+          </p:cNvSpPr>
+          <p:nvPr/>
+        </p:nvSpPr>
+        <p:spPr>
+          <a:xfrm xmlns:a="http://schemas.openxmlformats.org/drawingml/2006/main">
+            <a:off x="476250" y="3676650"/>
+            <a:ext cx="619125" cy="285750"/>
+          </a:xfrm>
+          <a:prstGeom xmlns:a="http://schemas.openxmlformats.org/drawingml/2006/main" prst="rect">
+            <a:avLst/>
+          </a:prstGeom>
+          <a:noFill xmlns:a="http://schemas.openxmlformats.org/drawingml/2006/main"/>
+          <a:ln xmlns:a="http://schemas.openxmlformats.org/drawingml/2006/main" w="0">
+            <a:noFill/>
+            <a:prstDash val="solid"/>
+          </a:ln>
+        </p:spPr>
+        <p:txBody>
+          <a:bodyPr xmlns:a="http://schemas.openxmlformats.org/drawingml/2006/main" anchor="t"/>
+          <a:lstStyle xmlns:a="http://schemas.openxmlformats.org/drawingml/2006/main"/>
+          <a:p xmlns:a="http://schemas.openxmlformats.org/drawingml/2006/main">
+            <a:pPr algn="l">
+              <a:buNone/>
+              <a:defRPr sz="1500" b="1">
+                <a:solidFill>
+                  <a:srgbClr val="000000"/>
+                </a:solidFill>
+                <a:latin typeface="Helvetica Neue"/>
+                <a:ea typeface="Helvetica Neue"/>
+                <a:cs typeface="Helvetica Neue"/>
+              </a:defRPr>
+            </a:pPr>
+            <a:r>
+              <a:rPr sz="1500" b="1">
+                <a:solidFill>
+                  <a:srgbClr val="000000"/>
+                </a:solidFill>
+                <a:latin typeface="Helvetica Neue"/>
+                <a:ea typeface="Helvetica Neue"/>
+                <a:cs typeface="Helvetica Neue"/>
+              </a:rPr>
+              <a:t>3</a:t>
+            </a:r>
+          </a:p>
+        </p:txBody>
+      </p:sp>
+      <p:sp>
+        <p:nvSpPr>
+          <p:cNvPr id="20" name="">
+            <a:extLst xmlns:a="http://schemas.openxmlformats.org/drawingml/2006/main">
+              <a:ext uri="{FF2B5EF4-FFF2-40B4-BE49-F238E27FC236}">
+                <a16:creationId xmlns:a16="http://schemas.microsoft.com/office/drawing/2014/main" id="{13818B89-FD32-46E0-A25F-AE94A79B8A51}"/>
+              </a:ext>
+            </a:extLst>
+          </p:cNvPr>
+          <p:cNvSpPr>
+            <a:spLocks xmlns:a="http://schemas.openxmlformats.org/drawingml/2006/main" noGrp="1"/>
+          </p:cNvSpPr>
+          <p:nvPr/>
+        </p:nvSpPr>
+        <p:spPr>
+          <a:xfrm xmlns:a="http://schemas.openxmlformats.org/drawingml/2006/main">
+            <a:off x="1285875" y="3676650"/>
+            <a:ext cx="2667000" cy="457200"/>
+          </a:xfrm>
+          <a:prstGeom xmlns:a="http://schemas.openxmlformats.org/drawingml/2006/main" prst="rect">
+            <a:avLst/>
+          </a:prstGeom>
+          <a:noFill xmlns:a="http://schemas.openxmlformats.org/drawingml/2006/main"/>
+          <a:ln xmlns:a="http://schemas.openxmlformats.org/drawingml/2006/main" w="0">
+            <a:noFill/>
+            <a:prstDash val="solid"/>
+          </a:ln>
+        </p:spPr>
+        <p:txBody>
+          <a:bodyPr xmlns:a="http://schemas.openxmlformats.org/drawingml/2006/main" anchor="t"/>
+          <a:lstStyle xmlns:a="http://schemas.openxmlformats.org/drawingml/2006/main"/>
+          <a:p xmlns:a="http://schemas.openxmlformats.org/drawingml/2006/main">
+            <a:pPr algn="l">
+              <a:buNone/>
+              <a:defRPr sz="1425" b="1">
+                <a:solidFill>
+                  <a:srgbClr val="000000"/>
+                </a:solidFill>
+                <a:latin typeface="Helvetica Neue"/>
+                <a:ea typeface="Helvetica Neue"/>
+                <a:cs typeface="Helvetica Neue"/>
+              </a:defRPr>
+            </a:pPr>
+            <a:r>
+              <a:rPr sz="1425" b="1">
+                <a:solidFill>
+                  <a:srgbClr val="000000"/>
+                </a:solidFill>
+                <a:latin typeface="Helvetica Neue"/>
+                <a:ea typeface="Helvetica Neue"/>
+                <a:cs typeface="Helvetica Neue"/>
+              </a:rPr>
+              <a:t>Repair preserves utility</a:t>
+            </a:r>
+          </a:p>
+        </p:txBody>
+      </p:sp>
+      <p:sp>
+        <p:nvSpPr>
+          <p:cNvPr id="21" name="">
+            <a:extLst xmlns:a="http://schemas.openxmlformats.org/drawingml/2006/main">
+              <a:ext uri="{FF2B5EF4-FFF2-40B4-BE49-F238E27FC236}">
+                <a16:creationId xmlns:a16="http://schemas.microsoft.com/office/drawing/2014/main" id="{3FB3ACDF-0EC6-4D5A-B56E-63A48719870E}"/>
+              </a:ext>
+            </a:extLst>
+          </p:cNvPr>
+          <p:cNvSpPr>
+            <a:spLocks xmlns:a="http://schemas.openxmlformats.org/drawingml/2006/main" noGrp="1"/>
+          </p:cNvSpPr>
+          <p:nvPr/>
+        </p:nvSpPr>
+        <p:spPr>
+          <a:xfrm xmlns:a="http://schemas.openxmlformats.org/drawingml/2006/main">
+            <a:off x="4095750" y="3676650"/>
+            <a:ext cx="5191125" cy="457200"/>
+          </a:xfrm>
+          <a:prstGeom xmlns:a="http://schemas.openxmlformats.org/drawingml/2006/main" prst="rect">
+            <a:avLst/>
+          </a:prstGeom>
+          <a:noFill xmlns:a="http://schemas.openxmlformats.org/drawingml/2006/main"/>
+          <a:ln xmlns:a="http://schemas.openxmlformats.org/drawingml/2006/main" w="0">
+            <a:noFill/>
+            <a:prstDash val="solid"/>
+          </a:ln>
+        </p:spPr>
+        <p:txBody>
+          <a:bodyPr xmlns:a="http://schemas.openxmlformats.org/drawingml/2006/main" anchor="t"/>
+          <a:lstStyle xmlns:a="http://schemas.openxmlformats.org/drawingml/2006/main"/>
+          <a:p xmlns:a="http://schemas.openxmlformats.org/drawingml/2006/main">
+            <a:pPr algn="l">
+              <a:buNone/>
+              <a:defRPr sz="1350" b="0">
+                <a:solidFill>
+                  <a:srgbClr val="5D636D"/>
+                </a:solidFill>
+                <a:latin typeface="Helvetica Neue"/>
+                <a:ea typeface="Helvetica Neue"/>
+                <a:cs typeface="Helvetica Neue"/>
+              </a:defRPr>
+            </a:pPr>
+            <a:r>
+              <a:rPr sz="1350" b="0">
+                <a:solidFill>
+                  <a:srgbClr val="5D636D"/>
+                </a:solidFill>
+                <a:latin typeface="Helvetica Neue"/>
+                <a:ea typeface="Helvetica Neue"/>
+                <a:cs typeface="Helvetica Neue"/>
+              </a:rPr>
+              <a:t>Targeted repair blocked harm while exact utility stayed 1.00.</a:t>
+            </a:r>
+          </a:p>
+        </p:txBody>
+      </p:sp>
+      <p:sp>
+        <p:nvSpPr>
+          <p:cNvPr id="22" name="">
+            <a:extLst xmlns:a="http://schemas.openxmlformats.org/drawingml/2006/main">
+              <a:ext uri="{FF2B5EF4-FFF2-40B4-BE49-F238E27FC236}">
+                <a16:creationId xmlns:a16="http://schemas.microsoft.com/office/drawing/2014/main" id="{2C330313-2CE2-473A-9B89-6BC5E344E4A0}"/>
+              </a:ext>
+            </a:extLst>
+          </p:cNvPr>
+          <p:cNvSpPr>
+            <a:spLocks xmlns:a="http://schemas.openxmlformats.org/drawingml/2006/main" noGrp="1"/>
+          </p:cNvSpPr>
+          <p:nvPr/>
+        </p:nvSpPr>
+        <p:spPr>
+          <a:xfrm xmlns:a="http://schemas.openxmlformats.org/drawingml/2006/main">
+            <a:off x="9858375" y="3676650"/>
+            <a:ext cx="1524000" cy="304800"/>
+          </a:xfrm>
+          <a:prstGeom xmlns:a="http://schemas.openxmlformats.org/drawingml/2006/main" prst="rect">
+            <a:avLst/>
+          </a:prstGeom>
+          <a:noFill xmlns:a="http://schemas.openxmlformats.org/drawingml/2006/main"/>
+          <a:ln xmlns:a="http://schemas.openxmlformats.org/drawingml/2006/main" w="0">
+            <a:noFill/>
+            <a:prstDash val="solid"/>
+          </a:ln>
+        </p:spPr>
+        <p:txBody>
+          <a:bodyPr xmlns:a="http://schemas.openxmlformats.org/drawingml/2006/main" anchor="t"/>
+          <a:lstStyle xmlns:a="http://schemas.openxmlformats.org/drawingml/2006/main"/>
+          <a:p xmlns:a="http://schemas.openxmlformats.org/drawingml/2006/main">
+            <a:pPr algn="l">
+              <a:buNone/>
+              <a:defRPr sz="1425" b="1">
+                <a:solidFill>
+                  <a:srgbClr val="3D8DFF"/>
+                </a:solidFill>
+                <a:latin typeface="Helvetica Neue"/>
+                <a:ea typeface="Helvetica Neue"/>
+                <a:cs typeface="Helvetica Neue"/>
+              </a:defRPr>
+            </a:pPr>
+            <a:r>
+              <a:rPr sz="1425" b="1">
+                <a:solidFill>
+                  <a:srgbClr val="3D8DFF"/>
+                </a:solidFill>
+                <a:latin typeface="Helvetica Neue"/>
+                <a:ea typeface="Helvetica Neue"/>
+                <a:cs typeface="Helvetica Neue"/>
+              </a:rPr>
+              <a:t>REPAIR FIRST</a:t>
+            </a:r>
+          </a:p>
+        </p:txBody>
+      </p:sp>
+      <p:sp>
+        <p:nvSpPr>
+          <p:cNvPr id="23" name="">
+            <a:extLst xmlns:a="http://schemas.openxmlformats.org/drawingml/2006/main">
+              <a:ext uri="{FF2B5EF4-FFF2-40B4-BE49-F238E27FC236}">
+                <a16:creationId xmlns:a16="http://schemas.microsoft.com/office/drawing/2014/main" id="{85AC6C0A-9318-433B-A5B1-2C30717330CD}"/>
+              </a:ext>
+            </a:extLst>
+          </p:cNvPr>
+          <p:cNvSpPr>
+            <a:spLocks xmlns:a="http://schemas.openxmlformats.org/drawingml/2006/main" noGrp="1"/>
+          </p:cNvSpPr>
+          <p:nvPr/>
+        </p:nvSpPr>
+        <p:spPr>
+          <a:xfrm xmlns:a="http://schemas.openxmlformats.org/drawingml/2006/main">
+            <a:off x="476250" y="4457700"/>
+            <a:ext cx="619125" cy="285750"/>
+          </a:xfrm>
+          <a:prstGeom xmlns:a="http://schemas.openxmlformats.org/drawingml/2006/main" prst="rect">
+            <a:avLst/>
+          </a:prstGeom>
+          <a:noFill xmlns:a="http://schemas.openxmlformats.org/drawingml/2006/main"/>
+          <a:ln xmlns:a="http://schemas.openxmlformats.org/drawingml/2006/main" w="0">
+            <a:noFill/>
+            <a:prstDash val="solid"/>
+          </a:ln>
+        </p:spPr>
+        <p:txBody>
+          <a:bodyPr xmlns:a="http://schemas.openxmlformats.org/drawingml/2006/main" anchor="t"/>
+          <a:lstStyle xmlns:a="http://schemas.openxmlformats.org/drawingml/2006/main"/>
+          <a:p xmlns:a="http://schemas.openxmlformats.org/drawingml/2006/main">
+            <a:pPr algn="l">
+              <a:buNone/>
+              <a:defRPr sz="1500" b="1">
+                <a:solidFill>
+                  <a:srgbClr val="000000"/>
+                </a:solidFill>
+                <a:latin typeface="Helvetica Neue"/>
+                <a:ea typeface="Helvetica Neue"/>
+                <a:cs typeface="Helvetica Neue"/>
+              </a:defRPr>
+            </a:pPr>
+            <a:r>
+              <a:rPr sz="1500" b="1">
+                <a:solidFill>
+                  <a:srgbClr val="000000"/>
+                </a:solidFill>
+                <a:latin typeface="Helvetica Neue"/>
+                <a:ea typeface="Helvetica Neue"/>
+                <a:cs typeface="Helvetica Neue"/>
+              </a:rPr>
+              <a:t>4</a:t>
+            </a:r>
+          </a:p>
+        </p:txBody>
+      </p:sp>
+      <p:sp>
+        <p:nvSpPr>
+          <p:cNvPr id="24" name="">
+            <a:extLst xmlns:a="http://schemas.openxmlformats.org/drawingml/2006/main">
+              <a:ext uri="{FF2B5EF4-FFF2-40B4-BE49-F238E27FC236}">
+                <a16:creationId xmlns:a16="http://schemas.microsoft.com/office/drawing/2014/main" id="{9F3368E0-86F3-4901-8045-FCDE2A17ACA8}"/>
+              </a:ext>
+            </a:extLst>
+          </p:cNvPr>
+          <p:cNvSpPr>
+            <a:spLocks xmlns:a="http://schemas.openxmlformats.org/drawingml/2006/main" noGrp="1"/>
+          </p:cNvSpPr>
+          <p:nvPr/>
+        </p:nvSpPr>
+        <p:spPr>
+          <a:xfrm xmlns:a="http://schemas.openxmlformats.org/drawingml/2006/main">
+            <a:off x="1285875" y="4457700"/>
+            <a:ext cx="2667000" cy="457200"/>
+          </a:xfrm>
+          <a:prstGeom xmlns:a="http://schemas.openxmlformats.org/drawingml/2006/main" prst="rect">
+            <a:avLst/>
+          </a:prstGeom>
+          <a:noFill xmlns:a="http://schemas.openxmlformats.org/drawingml/2006/main"/>
+          <a:ln xmlns:a="http://schemas.openxmlformats.org/drawingml/2006/main" w="0">
+            <a:noFill/>
+            <a:prstDash val="solid"/>
+          </a:ln>
+        </p:spPr>
+        <p:txBody>
+          <a:bodyPr xmlns:a="http://schemas.openxmlformats.org/drawingml/2006/main" anchor="t"/>
+          <a:lstStyle xmlns:a="http://schemas.openxmlformats.org/drawingml/2006/main"/>
+          <a:p xmlns:a="http://schemas.openxmlformats.org/drawingml/2006/main">
+            <a:pPr algn="l">
+              <a:buNone/>
+              <a:defRPr sz="1425" b="1">
+                <a:solidFill>
+                  <a:srgbClr val="000000"/>
+                </a:solidFill>
+                <a:latin typeface="Helvetica Neue"/>
+                <a:ea typeface="Helvetica Neue"/>
+                <a:cs typeface="Helvetica Neue"/>
+              </a:defRPr>
+            </a:pPr>
+            <a:r>
+              <a:rPr sz="1425" b="1">
+                <a:solidFill>
+                  <a:srgbClr val="000000"/>
+                </a:solidFill>
+                <a:latin typeface="Helvetica Neue"/>
+                <a:ea typeface="Helvetica Neue"/>
+                <a:cs typeface="Helvetica Neue"/>
+              </a:rPr>
+              <a:t>Before-harm timing matters</a:t>
+            </a:r>
+          </a:p>
+        </p:txBody>
+      </p:sp>
+      <p:sp>
+        <p:nvSpPr>
+          <p:cNvPr id="25" name="">
+            <a:extLst xmlns:a="http://schemas.openxmlformats.org/drawingml/2006/main">
+              <a:ext uri="{FF2B5EF4-FFF2-40B4-BE49-F238E27FC236}">
+                <a16:creationId xmlns:a16="http://schemas.microsoft.com/office/drawing/2014/main" id="{0F029E85-6090-472A-A25B-7CF90505378B}"/>
+              </a:ext>
+            </a:extLst>
+          </p:cNvPr>
+          <p:cNvSpPr>
+            <a:spLocks xmlns:a="http://schemas.openxmlformats.org/drawingml/2006/main" noGrp="1"/>
+          </p:cNvSpPr>
+          <p:nvPr/>
+        </p:nvSpPr>
+        <p:spPr>
+          <a:xfrm xmlns:a="http://schemas.openxmlformats.org/drawingml/2006/main">
+            <a:off x="4095750" y="4457700"/>
+            <a:ext cx="5191125" cy="457200"/>
+          </a:xfrm>
+          <a:prstGeom xmlns:a="http://schemas.openxmlformats.org/drawingml/2006/main" prst="rect">
+            <a:avLst/>
+          </a:prstGeom>
+          <a:noFill xmlns:a="http://schemas.openxmlformats.org/drawingml/2006/main"/>
+          <a:ln xmlns:a="http://schemas.openxmlformats.org/drawingml/2006/main" w="0">
+            <a:noFill/>
+            <a:prstDash val="solid"/>
+          </a:ln>
+        </p:spPr>
+        <p:txBody>
+          <a:bodyPr xmlns:a="http://schemas.openxmlformats.org/drawingml/2006/main" anchor="t"/>
+          <a:lstStyle xmlns:a="http://schemas.openxmlformats.org/drawingml/2006/main"/>
+          <a:p xmlns:a="http://schemas.openxmlformats.org/drawingml/2006/main">
+            <a:pPr algn="l">
+              <a:buNone/>
+              <a:defRPr sz="1350" b="0">
+                <a:solidFill>
+                  <a:srgbClr val="5D636D"/>
+                </a:solidFill>
+                <a:latin typeface="Helvetica Neue"/>
+                <a:ea typeface="Helvetica Neue"/>
+                <a:cs typeface="Helvetica Neue"/>
+              </a:defRPr>
+            </a:pPr>
+            <a:r>
+              <a:rPr sz="1350" b="0">
+                <a:solidFill>
+                  <a:srgbClr val="5D636D"/>
+                </a:solidFill>
+                <a:latin typeface="Helvetica Neue"/>
+                <a:ea typeface="Helvetica Neue"/>
+                <a:cs typeface="Helvetica Neue"/>
+              </a:rPr>
+              <a:t>Low-rate before-harm detection was 0.275 despite low benign alarms.</a:t>
+            </a:r>
+          </a:p>
+        </p:txBody>
+      </p:sp>
+      <p:sp>
+        <p:nvSpPr>
+          <p:cNvPr id="26" name="">
+            <a:extLst xmlns:a="http://schemas.openxmlformats.org/drawingml/2006/main">
+              <a:ext uri="{FF2B5EF4-FFF2-40B4-BE49-F238E27FC236}">
+                <a16:creationId xmlns:a16="http://schemas.microsoft.com/office/drawing/2014/main" id="{7E38026B-58A4-4CF5-BAB9-13258B195075}"/>
+              </a:ext>
+            </a:extLst>
+          </p:cNvPr>
+          <p:cNvSpPr>
+            <a:spLocks xmlns:a="http://schemas.openxmlformats.org/drawingml/2006/main" noGrp="1"/>
+          </p:cNvSpPr>
+          <p:nvPr/>
+        </p:nvSpPr>
+        <p:spPr>
+          <a:xfrm xmlns:a="http://schemas.openxmlformats.org/drawingml/2006/main">
+            <a:off x="9858375" y="4457700"/>
+            <a:ext cx="1524000" cy="304800"/>
+          </a:xfrm>
+          <a:prstGeom xmlns:a="http://schemas.openxmlformats.org/drawingml/2006/main" prst="rect">
+            <a:avLst/>
+          </a:prstGeom>
+          <a:noFill xmlns:a="http://schemas.openxmlformats.org/drawingml/2006/main"/>
+          <a:ln xmlns:a="http://schemas.openxmlformats.org/drawingml/2006/main" w="0">
+            <a:noFill/>
+            <a:prstDash val="solid"/>
+          </a:ln>
+        </p:spPr>
+        <p:txBody>
+          <a:bodyPr xmlns:a="http://schemas.openxmlformats.org/drawingml/2006/main" anchor="t"/>
+          <a:lstStyle xmlns:a="http://schemas.openxmlformats.org/drawingml/2006/main"/>
+          <a:p xmlns:a="http://schemas.openxmlformats.org/drawingml/2006/main">
+            <a:pPr algn="l">
+              <a:buNone/>
+              <a:defRPr sz="1425" b="1">
+                <a:solidFill>
+                  <a:srgbClr val="3D8DFF"/>
+                </a:solidFill>
+                <a:latin typeface="Helvetica Neue"/>
+                <a:ea typeface="Helvetica Neue"/>
+                <a:cs typeface="Helvetica Neue"/>
+              </a:defRPr>
+            </a:pPr>
+            <a:r>
+              <a:rPr sz="1425" b="1">
+                <a:solidFill>
+                  <a:srgbClr val="3D8DFF"/>
+                </a:solidFill>
+                <a:latin typeface="Helvetica Neue"/>
+                <a:ea typeface="Helvetica Neue"/>
+                <a:cs typeface="Helvetica Neue"/>
+              </a:rPr>
+              <a:t>OPTIMIZE DELAY</a:t>
+            </a:r>
+          </a:p>
+        </p:txBody>
+      </p:sp>
+      <p:sp>
+        <p:nvSpPr>
+          <p:cNvPr id="27" name="">
+            <a:extLst xmlns:a="http://schemas.openxmlformats.org/drawingml/2006/main">
+              <a:ext uri="{FF2B5EF4-FFF2-40B4-BE49-F238E27FC236}">
+                <a16:creationId xmlns:a16="http://schemas.microsoft.com/office/drawing/2014/main" id="{A0FFC104-DD28-430E-BA94-0DE112CBCDF5}"/>
+              </a:ext>
+            </a:extLst>
+          </p:cNvPr>
+          <p:cNvSpPr>
+            <a:spLocks xmlns:a="http://schemas.openxmlformats.org/drawingml/2006/main" noGrp="1"/>
+          </p:cNvSpPr>
+          <p:nvPr/>
+        </p:nvSpPr>
+        <p:spPr>
+          <a:xfrm xmlns:a="http://schemas.openxmlformats.org/drawingml/2006/main">
+            <a:off x="400050" y="5143500"/>
+            <a:ext cx="11391900" cy="685800"/>
+          </a:xfrm>
+          <a:prstGeom xmlns:a="http://schemas.openxmlformats.org/drawingml/2006/main" prst="rect">
+            <a:avLst/>
+          </a:prstGeom>
+          <a:solidFill xmlns:a="http://schemas.openxmlformats.org/drawingml/2006/main">
+            <a:srgbClr val="F6F7F8"/>
+          </a:solidFill>
+          <a:ln xmlns:a="http://schemas.openxmlformats.org/drawingml/2006/main" w="0">
+            <a:noFill/>
+            <a:prstDash val="solid"/>
+          </a:ln>
+        </p:spPr>
+      </p:sp>
+      <p:sp>
+        <p:nvSpPr>
+          <p:cNvPr id="28" name="">
+            <a:extLst xmlns:a="http://schemas.openxmlformats.org/drawingml/2006/main">
+              <a:ext uri="{FF2B5EF4-FFF2-40B4-BE49-F238E27FC236}">
+                <a16:creationId xmlns:a16="http://schemas.microsoft.com/office/drawing/2014/main" id="{57519946-B7D7-481F-8941-85C5E8746C10}"/>
+              </a:ext>
+            </a:extLst>
+          </p:cNvPr>
+          <p:cNvSpPr>
+            <a:spLocks xmlns:a="http://schemas.openxmlformats.org/drawingml/2006/main" noGrp="1"/>
+          </p:cNvSpPr>
+          <p:nvPr/>
+        </p:nvSpPr>
+        <p:spPr>
+          <a:xfrm xmlns:a="http://schemas.openxmlformats.org/drawingml/2006/main">
+            <a:off x="476250" y="5238750"/>
+            <a:ext cx="619125" cy="285750"/>
+          </a:xfrm>
+          <a:prstGeom xmlns:a="http://schemas.openxmlformats.org/drawingml/2006/main" prst="rect">
+            <a:avLst/>
+          </a:prstGeom>
+          <a:noFill xmlns:a="http://schemas.openxmlformats.org/drawingml/2006/main"/>
+          <a:ln xmlns:a="http://schemas.openxmlformats.org/drawingml/2006/main" w="0">
+            <a:noFill/>
+            <a:prstDash val="solid"/>
+          </a:ln>
+        </p:spPr>
+        <p:txBody>
+          <a:bodyPr xmlns:a="http://schemas.openxmlformats.org/drawingml/2006/main" anchor="t"/>
+          <a:lstStyle xmlns:a="http://schemas.openxmlformats.org/drawingml/2006/main"/>
+          <a:p xmlns:a="http://schemas.openxmlformats.org/drawingml/2006/main">
+            <a:pPr algn="l">
+              <a:buNone/>
+              <a:defRPr sz="1500" b="1">
+                <a:solidFill>
+                  <a:srgbClr val="000000"/>
+                </a:solidFill>
+                <a:latin typeface="Helvetica Neue"/>
+                <a:ea typeface="Helvetica Neue"/>
+                <a:cs typeface="Helvetica Neue"/>
+              </a:defRPr>
+            </a:pPr>
+            <a:r>
+              <a:rPr sz="1500" b="1">
+                <a:solidFill>
+                  <a:srgbClr val="000000"/>
+                </a:solidFill>
+                <a:latin typeface="Helvetica Neue"/>
+                <a:ea typeface="Helvetica Neue"/>
+                <a:cs typeface="Helvetica Neue"/>
+              </a:rPr>
+              <a:t>5</a:t>
+            </a:r>
+          </a:p>
+        </p:txBody>
+      </p:sp>
+      <p:sp>
+        <p:nvSpPr>
+          <p:cNvPr id="29" name="">
+            <a:extLst xmlns:a="http://schemas.openxmlformats.org/drawingml/2006/main">
+              <a:ext uri="{FF2B5EF4-FFF2-40B4-BE49-F238E27FC236}">
+                <a16:creationId xmlns:a16="http://schemas.microsoft.com/office/drawing/2014/main" id="{96DA00D5-624E-431F-A2CE-12E0FE62BAC8}"/>
+              </a:ext>
+            </a:extLst>
+          </p:cNvPr>
+          <p:cNvSpPr>
+            <a:spLocks xmlns:a="http://schemas.openxmlformats.org/drawingml/2006/main" noGrp="1"/>
+          </p:cNvSpPr>
+          <p:nvPr/>
+        </p:nvSpPr>
+        <p:spPr>
+          <a:xfrm xmlns:a="http://schemas.openxmlformats.org/drawingml/2006/main">
+            <a:off x="1285875" y="5238750"/>
+            <a:ext cx="2667000" cy="457200"/>
+          </a:xfrm>
+          <a:prstGeom xmlns:a="http://schemas.openxmlformats.org/drawingml/2006/main" prst="rect">
+            <a:avLst/>
+          </a:prstGeom>
+          <a:noFill xmlns:a="http://schemas.openxmlformats.org/drawingml/2006/main"/>
+          <a:ln xmlns:a="http://schemas.openxmlformats.org/drawingml/2006/main" w="0">
+            <a:noFill/>
+            <a:prstDash val="solid"/>
+          </a:ln>
+        </p:spPr>
+        <p:txBody>
+          <a:bodyPr xmlns:a="http://schemas.openxmlformats.org/drawingml/2006/main" anchor="t"/>
+          <a:lstStyle xmlns:a="http://schemas.openxmlformats.org/drawingml/2006/main"/>
+          <a:p xmlns:a="http://schemas.openxmlformats.org/drawingml/2006/main">
+            <a:pPr algn="l">
+              <a:buNone/>
+              <a:defRPr sz="1425" b="1">
+                <a:solidFill>
+                  <a:srgbClr val="000000"/>
+                </a:solidFill>
+                <a:latin typeface="Helvetica Neue"/>
+                <a:ea typeface="Helvetica Neue"/>
+                <a:cs typeface="Helvetica Neue"/>
+              </a:defRPr>
+            </a:pPr>
+            <a:r>
+              <a:rPr sz="1425" b="1">
+                <a:solidFill>
+                  <a:srgbClr val="000000"/>
+                </a:solidFill>
+                <a:latin typeface="Helvetica Neue"/>
+                <a:ea typeface="Helvetica Neue"/>
+                <a:cs typeface="Helvetica Neue"/>
+              </a:rPr>
+              <a:t>Diversity needs proof</a:t>
+            </a:r>
+          </a:p>
+        </p:txBody>
+      </p:sp>
+      <p:sp>
+        <p:nvSpPr>
+          <p:cNvPr id="30" name="">
+            <a:extLst xmlns:a="http://schemas.openxmlformats.org/drawingml/2006/main">
+              <a:ext uri="{FF2B5EF4-FFF2-40B4-BE49-F238E27FC236}">
+                <a16:creationId xmlns:a16="http://schemas.microsoft.com/office/drawing/2014/main" id="{E3DA2D1B-3415-4F0D-9600-FD2A83FA9F46}"/>
+              </a:ext>
+            </a:extLst>
+          </p:cNvPr>
+          <p:cNvSpPr>
+            <a:spLocks xmlns:a="http://schemas.openxmlformats.org/drawingml/2006/main" noGrp="1"/>
+          </p:cNvSpPr>
+          <p:nvPr/>
+        </p:nvSpPr>
+        <p:spPr>
+          <a:xfrm xmlns:a="http://schemas.openxmlformats.org/drawingml/2006/main">
+            <a:off x="4095750" y="5238750"/>
+            <a:ext cx="5191125" cy="457200"/>
+          </a:xfrm>
+          <a:prstGeom xmlns:a="http://schemas.openxmlformats.org/drawingml/2006/main" prst="rect">
+            <a:avLst/>
+          </a:prstGeom>
+          <a:noFill xmlns:a="http://schemas.openxmlformats.org/drawingml/2006/main"/>
+          <a:ln xmlns:a="http://schemas.openxmlformats.org/drawingml/2006/main" w="0">
+            <a:noFill/>
+            <a:prstDash val="solid"/>
+          </a:ln>
+        </p:spPr>
+        <p:txBody>
+          <a:bodyPr xmlns:a="http://schemas.openxmlformats.org/drawingml/2006/main" anchor="t"/>
+          <a:lstStyle xmlns:a="http://schemas.openxmlformats.org/drawingml/2006/main"/>
+          <a:p xmlns:a="http://schemas.openxmlformats.org/drawingml/2006/main">
+            <a:pPr algn="l">
+              <a:buNone/>
+              <a:defRPr sz="1350" b="0">
+                <a:solidFill>
+                  <a:srgbClr val="5D636D"/>
+                </a:solidFill>
+                <a:latin typeface="Helvetica Neue"/>
+                <a:ea typeface="Helvetica Neue"/>
+                <a:cs typeface="Helvetica Neue"/>
+              </a:defRPr>
+            </a:pPr>
+            <a:r>
+              <a:rPr sz="1350" b="0">
+                <a:solidFill>
+                  <a:srgbClr val="5D636D"/>
+                </a:solidFill>
+                <a:latin typeface="Helvetica Neue"/>
+                <a:ea typeface="Helvetica Neue"/>
+                <a:cs typeface="Helvetica Neue"/>
+              </a:rPr>
+              <a:t>Γ=0.406, but interaction was +0.025; transfer remains open.</a:t>
+            </a:r>
+          </a:p>
+        </p:txBody>
+      </p:sp>
+      <p:sp>
+        <p:nvSpPr>
+          <p:cNvPr id="31" name="">
+            <a:extLst xmlns:a="http://schemas.openxmlformats.org/drawingml/2006/main">
+              <a:ext uri="{FF2B5EF4-FFF2-40B4-BE49-F238E27FC236}">
+                <a16:creationId xmlns:a16="http://schemas.microsoft.com/office/drawing/2014/main" id="{FAB52420-C4CE-4477-A5F5-EEA2EFAC6879}"/>
+              </a:ext>
+            </a:extLst>
+          </p:cNvPr>
+          <p:cNvSpPr>
+            <a:spLocks xmlns:a="http://schemas.openxmlformats.org/drawingml/2006/main" noGrp="1"/>
+          </p:cNvSpPr>
+          <p:nvPr/>
+        </p:nvSpPr>
+        <p:spPr>
+          <a:xfrm xmlns:a="http://schemas.openxmlformats.org/drawingml/2006/main">
+            <a:off x="9858375" y="5238750"/>
+            <a:ext cx="1524000" cy="304800"/>
+          </a:xfrm>
+          <a:prstGeom xmlns:a="http://schemas.openxmlformats.org/drawingml/2006/main" prst="rect">
+            <a:avLst/>
+          </a:prstGeom>
+          <a:noFill xmlns:a="http://schemas.openxmlformats.org/drawingml/2006/main"/>
+          <a:ln xmlns:a="http://schemas.openxmlformats.org/drawingml/2006/main" w="0">
+            <a:noFill/>
+            <a:prstDash val="solid"/>
+          </a:ln>
+        </p:spPr>
+        <p:txBody>
+          <a:bodyPr xmlns:a="http://schemas.openxmlformats.org/drawingml/2006/main" anchor="t"/>
+          <a:lstStyle xmlns:a="http://schemas.openxmlformats.org/drawingml/2006/main"/>
+          <a:p xmlns:a="http://schemas.openxmlformats.org/drawingml/2006/main">
+            <a:pPr algn="l">
+              <a:buNone/>
+              <a:defRPr sz="1425" b="1">
+                <a:solidFill>
+                  <a:srgbClr val="3D8DFF"/>
+                </a:solidFill>
+                <a:latin typeface="Helvetica Neue"/>
+                <a:ea typeface="Helvetica Neue"/>
+                <a:cs typeface="Helvetica Neue"/>
+              </a:defRPr>
+            </a:pPr>
+            <a:r>
+              <a:rPr sz="1425" b="1">
+                <a:solidFill>
+                  <a:srgbClr val="3D8DFF"/>
+                </a:solidFill>
+                <a:latin typeface="Helvetica Neue"/>
+                <a:ea typeface="Helvetica Neue"/>
+                <a:cs typeface="Helvetica Neue"/>
+              </a:rPr>
+              <a:t>MATCH FAILURES</a:t>
+            </a:r>
+          </a:p>
+        </p:txBody>
+      </p:sp>
+      <p:sp>
+        <p:nvSpPr>
+          <p:cNvPr id="32" name="">
+            <a:extLst xmlns:a="http://schemas.openxmlformats.org/drawingml/2006/main">
+              <a:ext uri="{FF2B5EF4-FFF2-40B4-BE49-F238E27FC236}">
+                <a16:creationId xmlns:a16="http://schemas.microsoft.com/office/drawing/2014/main" id="{4038F686-D7F8-44E0-990B-6C52ECCE0A52}"/>
+              </a:ext>
+            </a:extLst>
+          </p:cNvPr>
+          <p:cNvSpPr>
+            <a:spLocks xmlns:a="http://schemas.openxmlformats.org/drawingml/2006/main" noGrp="1"/>
+          </p:cNvSpPr>
+          <p:nvPr/>
+        </p:nvSpPr>
+        <p:spPr>
+          <a:xfrm xmlns:a="http://schemas.openxmlformats.org/drawingml/2006/main">
+            <a:off x="400050" y="6191250"/>
+            <a:ext cx="9525000" cy="228600"/>
+          </a:xfrm>
+          <a:prstGeom xmlns:a="http://schemas.openxmlformats.org/drawingml/2006/main" prst="rect">
+            <a:avLst/>
+          </a:prstGeom>
+          <a:noFill xmlns:a="http://schemas.openxmlformats.org/drawingml/2006/main"/>
+          <a:ln xmlns:a="http://schemas.openxmlformats.org/drawingml/2006/main" w="0">
+            <a:noFill/>
+            <a:prstDash val="solid"/>
+          </a:ln>
+        </p:spPr>
+        <p:txBody>
+          <a:bodyPr xmlns:a="http://schemas.openxmlformats.org/drawingml/2006/main" anchor="t"/>
+          <a:lstStyle xmlns:a="http://schemas.openxmlformats.org/drawingml/2006/main"/>
+          <a:p xmlns:a="http://schemas.openxmlformats.org/drawingml/2006/main">
+            <a:pPr algn="l">
+              <a:buNone/>
+              <a:defRPr sz="1200" b="0">
+                <a:solidFill>
+                  <a:srgbClr val="5D636D"/>
+                </a:solidFill>
+                <a:latin typeface="Helvetica Neue"/>
+                <a:ea typeface="Helvetica Neue"/>
+                <a:cs typeface="Helvetica Neue"/>
+              </a:defRPr>
+            </a:pPr>
+            <a:r>
+              <a:rPr sz="1200" b="0">
+                <a:solidFill>
+                  <a:srgbClr val="5D636D"/>
+                </a:solidFill>
+                <a:latin typeface="Helvetica Neue"/>
+                <a:ea typeface="Helvetica Neue"/>
+                <a:cs typeface="Helvetica Neue"/>
+              </a:rPr>
+              <a:t>Core lesson: optimize trajectories and common-mode failures—not average scores or layer count alone.</a:t>
+            </a:r>
+          </a:p>
+        </p:txBody>
+      </p:sp>
+    </p:spTree>
+    <p:extLst>
+      <p:ext uri="{BB962C8B-B14F-4D97-AF65-F5344CB8AC3E}">
+        <p14:creationId xmlns:p14="http://schemas.microsoft.com/office/powerpoint/2010/main" val="1868691257"/>
+      </p:ext>
+    </p:extLst>
+  </p:cSld>
+</p:sld>
+</file>
+
 <file path=ppt/slides/slide3.xml><?xml version="1.0" encoding="utf-8"?>
 <p:sld xmlns:p="http://schemas.openxmlformats.org/presentationml/2006/main">
   <p:cSld>
@@ -13282,7 +15156,7 @@
       </p:sp>
       <p:cxnSp>
         <p:nvCxnSpPr>
-          <p:cNvPr id="317" name=""/>
+          <p:cNvPr id="373" name=""/>
           <p:cNvCxnSpPr/>
           <p:nvPr/>
         </p:nvCxnSpPr>
@@ -13418,7 +15292,7 @@
       </p:sp>
       <p:cxnSp>
         <p:nvCxnSpPr>
-          <p:cNvPr id="320" name=""/>
+          <p:cNvPr id="376" name=""/>
           <p:cNvCxnSpPr/>
           <p:nvPr/>
         </p:nvCxnSpPr>
@@ -13554,7 +15428,7 @@
       </p:sp>
       <p:cxnSp>
         <p:nvCxnSpPr>
-          <p:cNvPr id="323" name=""/>
+          <p:cNvPr id="379" name=""/>
           <p:cNvCxnSpPr/>
           <p:nvPr/>
         </p:nvCxnSpPr>
@@ -13690,7 +15564,7 @@
       </p:sp>
       <p:cxnSp>
         <p:nvCxnSpPr>
-          <p:cNvPr id="326" name=""/>
+          <p:cNvPr id="382" name=""/>
           <p:cNvCxnSpPr/>
           <p:nvPr/>
         </p:nvCxnSpPr>
@@ -13826,7 +15700,7 @@
       </p:sp>
       <p:cxnSp>
         <p:nvCxnSpPr>
-          <p:cNvPr id="329" name=""/>
+          <p:cNvPr id="385" name=""/>
           <p:cNvCxnSpPr/>
           <p:nvPr/>
         </p:nvCxnSpPr>
@@ -13962,7 +15836,7 @@
       </p:sp>
       <p:cxnSp>
         <p:nvCxnSpPr>
-          <p:cNvPr id="332" name=""/>
+          <p:cNvPr id="388" name=""/>
           <p:cNvCxnSpPr/>
           <p:nvPr/>
         </p:nvCxnSpPr>
@@ -14098,7 +15972,7 @@
       </p:sp>
       <p:cxnSp>
         <p:nvCxnSpPr>
-          <p:cNvPr id="335" name=""/>
+          <p:cNvPr id="391" name=""/>
           <p:cNvCxnSpPr/>
           <p:nvPr/>
         </p:nvCxnSpPr>
@@ -14234,7 +16108,7 @@
       </p:sp>
       <p:cxnSp>
         <p:nvCxnSpPr>
-          <p:cNvPr id="338" name=""/>
+          <p:cNvPr id="394" name=""/>
           <p:cNvCxnSpPr/>
           <p:nvPr/>
         </p:nvCxnSpPr>
@@ -15569,6 +17443,7 @@
           </a:p>
           <a:p xmlns:a="http://schemas.openxmlformats.org/drawingml/2006/main">
             <a:pPr>
+              <a:buNone/>
               <a:defRPr sz="1650" b="0">
                 <a:solidFill>
                   <a:srgbClr val="5D636D"/>
@@ -17479,7 +19354,7 @@
       </p:sp>
       <p:cxnSp>
         <p:nvCxnSpPr>
-          <p:cNvPr id="70" name=""/>
+          <p:cNvPr id="78" name=""/>
           <p:cNvCxnSpPr/>
           <p:nvPr/>
         </p:nvCxnSpPr>

</xml_diff>

<commit_message>
add Fairlead infrastructure slide
</commit_message>
<xml_diff>
--- a/deliverables/beyond-average-case-safety.pptx
+++ b/deliverables/beyond-average-case-safety.pptx
@@ -2,33 +2,34 @@
 <file path=ppt/presentation.xml><?xml version="1.0" encoding="utf-8"?>
 <p:presentation xmlns:p="http://schemas.openxmlformats.org/presentationml/2006/main">
   <p:sldMasterIdLst>
-    <p:sldMasterId xmlns:r="http://schemas.openxmlformats.org/officeDocument/2006/relationships" id="2147483648" r:id="R2074b190cf584a4c"/>
+    <p:sldMasterId xmlns:r="http://schemas.openxmlformats.org/officeDocument/2006/relationships" id="2147483648" r:id="R52288bd0786b4522"/>
   </p:sldMasterIdLst>
   <p:notesMasterIdLst>
-    <p:notesMasterId xmlns:r="http://schemas.openxmlformats.org/officeDocument/2006/relationships" r:id="R15bdf765ef934bcd"/>
+    <p:notesMasterId xmlns:r="http://schemas.openxmlformats.org/officeDocument/2006/relationships" r:id="Re022d4c3fda34454"/>
   </p:notesMasterIdLst>
   <p:sldIdLst>
-    <p:sldId xmlns:r="http://schemas.openxmlformats.org/officeDocument/2006/relationships" id="256" r:id="Rd861e449ed5f44dd"/>
-    <p:sldId xmlns:r="http://schemas.openxmlformats.org/officeDocument/2006/relationships" id="257" r:id="R1534745ec7ff415a"/>
-    <p:sldId xmlns:r="http://schemas.openxmlformats.org/officeDocument/2006/relationships" id="258" r:id="Rea58b28849f340ea"/>
-    <p:sldId xmlns:r="http://schemas.openxmlformats.org/officeDocument/2006/relationships" id="259" r:id="R286c0e3b731840fc"/>
-    <p:sldId xmlns:r="http://schemas.openxmlformats.org/officeDocument/2006/relationships" id="260" r:id="Rf3a79e77eeab4d94"/>
-    <p:sldId xmlns:r="http://schemas.openxmlformats.org/officeDocument/2006/relationships" id="261" r:id="R7ab38b76ec8c48e4"/>
-    <p:sldId xmlns:r="http://schemas.openxmlformats.org/officeDocument/2006/relationships" id="262" r:id="R79734d39749040b0"/>
-    <p:sldId xmlns:r="http://schemas.openxmlformats.org/officeDocument/2006/relationships" id="263" r:id="R16f6f9ba63a845b6"/>
-    <p:sldId xmlns:r="http://schemas.openxmlformats.org/officeDocument/2006/relationships" id="264" r:id="Re7f453572bbb4866"/>
-    <p:sldId xmlns:r="http://schemas.openxmlformats.org/officeDocument/2006/relationships" id="265" r:id="R5f22f51e070e441c"/>
-    <p:sldId xmlns:r="http://schemas.openxmlformats.org/officeDocument/2006/relationships" id="266" r:id="R146adddb85864ef8"/>
-    <p:sldId xmlns:r="http://schemas.openxmlformats.org/officeDocument/2006/relationships" id="267" r:id="R665448b3832e4f69"/>
-    <p:sldId xmlns:r="http://schemas.openxmlformats.org/officeDocument/2006/relationships" id="268" r:id="Reeb3fea3e3a84ff0"/>
-    <p:sldId xmlns:r="http://schemas.openxmlformats.org/officeDocument/2006/relationships" id="269" r:id="R3e7f6359156c42ed"/>
-    <p:sldId xmlns:r="http://schemas.openxmlformats.org/officeDocument/2006/relationships" id="270" r:id="Rb80cf4ac21444a1a"/>
-    <p:sldId xmlns:r="http://schemas.openxmlformats.org/officeDocument/2006/relationships" id="271" r:id="Rff2fa00183eb4f13"/>
-    <p:sldId xmlns:r="http://schemas.openxmlformats.org/officeDocument/2006/relationships" id="272" r:id="R3bac19502fe744a8"/>
-    <p:sldId xmlns:r="http://schemas.openxmlformats.org/officeDocument/2006/relationships" id="273" r:id="R8107a52eff0b4244"/>
-    <p:sldId xmlns:r="http://schemas.openxmlformats.org/officeDocument/2006/relationships" id="274" r:id="R36b5847fe23b4dc7"/>
-    <p:sldId xmlns:r="http://schemas.openxmlformats.org/officeDocument/2006/relationships" id="275" r:id="Re502caff4ed44ed5"/>
-    <p:sldId xmlns:r="http://schemas.openxmlformats.org/officeDocument/2006/relationships" id="276" r:id="R36375b200cb347fe"/>
+    <p:sldId xmlns:r="http://schemas.openxmlformats.org/officeDocument/2006/relationships" id="256" r:id="R814fafc558d64f4c"/>
+    <p:sldId xmlns:r="http://schemas.openxmlformats.org/officeDocument/2006/relationships" id="257" r:id="Rb958ec18815b42a7"/>
+    <p:sldId xmlns:r="http://schemas.openxmlformats.org/officeDocument/2006/relationships" id="258" r:id="Rd0cb72c31014471b"/>
+    <p:sldId xmlns:r="http://schemas.openxmlformats.org/officeDocument/2006/relationships" id="259" r:id="R5f5e34d279e04839"/>
+    <p:sldId xmlns:r="http://schemas.openxmlformats.org/officeDocument/2006/relationships" id="260" r:id="Re42d3305b8774755"/>
+    <p:sldId xmlns:r="http://schemas.openxmlformats.org/officeDocument/2006/relationships" id="261" r:id="R1b8cbd95c7e54afe"/>
+    <p:sldId xmlns:r="http://schemas.openxmlformats.org/officeDocument/2006/relationships" id="262" r:id="R6a1198ff95e44184"/>
+    <p:sldId xmlns:r="http://schemas.openxmlformats.org/officeDocument/2006/relationships" id="263" r:id="R6fc69624b9b64839"/>
+    <p:sldId xmlns:r="http://schemas.openxmlformats.org/officeDocument/2006/relationships" id="264" r:id="R591ea47c07954d7a"/>
+    <p:sldId xmlns:r="http://schemas.openxmlformats.org/officeDocument/2006/relationships" id="265" r:id="Rdf0f83db0d6e477e"/>
+    <p:sldId xmlns:r="http://schemas.openxmlformats.org/officeDocument/2006/relationships" id="266" r:id="R9a406bd0a6f94e79"/>
+    <p:sldId xmlns:r="http://schemas.openxmlformats.org/officeDocument/2006/relationships" id="267" r:id="Rcb473682418e4a95"/>
+    <p:sldId xmlns:r="http://schemas.openxmlformats.org/officeDocument/2006/relationships" id="268" r:id="Rf256cb0b3e1f4ad5"/>
+    <p:sldId xmlns:r="http://schemas.openxmlformats.org/officeDocument/2006/relationships" id="269" r:id="Rf9c09f03eee54152"/>
+    <p:sldId xmlns:r="http://schemas.openxmlformats.org/officeDocument/2006/relationships" id="270" r:id="R067034cb86b449ca"/>
+    <p:sldId xmlns:r="http://schemas.openxmlformats.org/officeDocument/2006/relationships" id="271" r:id="R63795b4ffb7f42d9"/>
+    <p:sldId xmlns:r="http://schemas.openxmlformats.org/officeDocument/2006/relationships" id="272" r:id="R9501a0c0ba47440a"/>
+    <p:sldId xmlns:r="http://schemas.openxmlformats.org/officeDocument/2006/relationships" id="273" r:id="Rec4c2f6a45174a13"/>
+    <p:sldId xmlns:r="http://schemas.openxmlformats.org/officeDocument/2006/relationships" id="274" r:id="Rf3d0be6be927426f"/>
+    <p:sldId xmlns:r="http://schemas.openxmlformats.org/officeDocument/2006/relationships" id="275" r:id="R7ed778b24cb74e72"/>
+    <p:sldId xmlns:r="http://schemas.openxmlformats.org/officeDocument/2006/relationships" id="276" r:id="R3b4aed10fa83449f"/>
+    <p:sldId xmlns:r="http://schemas.openxmlformats.org/officeDocument/2006/relationships" id="277" r:id="Rd118349154d24477"/>
   </p:sldIdLst>
   <p:sldSz cx="12192000" cy="6858000"/>
   <p:notesSz cx="6858000" cy="9144000"/>
@@ -2047,6 +2048,136 @@
 </p:notes>
 </file>
 
+<file path=ppt/notesSlides/notesSlide22.xml><?xml version="1.0" encoding="utf-8"?>
+<p:notes xmlns:p="http://schemas.openxmlformats.org/presentationml/2006/main">
+  <p:cSld>
+    <p:spTree>
+      <p:nvGrpSpPr>
+        <p:cNvPr id="1" name=""/>
+        <p:cNvGrpSpPr/>
+        <p:nvPr/>
+      </p:nvGrpSpPr>
+      <p:grpSpPr>
+        <a:xfrm xmlns:a="http://schemas.openxmlformats.org/drawingml/2006/main"/>
+      </p:grpSpPr>
+      <p:sp>
+        <p:nvSpPr>
+          <p:cNvPr id="2" name="Slide Image Placeholder 1"/>
+          <p:cNvSpPr>
+            <a:spLocks xmlns:a="http://schemas.openxmlformats.org/drawingml/2006/main" noGrp="1"/>
+          </p:cNvSpPr>
+          <p:nvPr>
+            <p:ph type="sldImg" idx="0"/>
+          </p:nvPr>
+        </p:nvSpPr>
+        <p:spPr/>
+      </p:sp>
+      <p:sp>
+        <p:nvSpPr>
+          <p:cNvPr id="3" name="Notes Placeholder 2"/>
+          <p:cNvSpPr>
+            <a:spLocks xmlns:a="http://schemas.openxmlformats.org/drawingml/2006/main" noGrp="1"/>
+          </p:cNvSpPr>
+          <p:nvPr>
+            <p:ph type="body" idx="1"/>
+          </p:nvPr>
+        </p:nvSpPr>
+        <p:spPr/>
+        <p:txBody>
+          <a:bodyPr xmlns:a="http://schemas.openxmlformats.org/drawingml/2006/main"/>
+          <a:lstStyle xmlns:a="http://schemas.openxmlformats.org/drawingml/2006/main"/>
+          <a:p xmlns:a="http://schemas.openxmlformats.org/drawingml/2006/main">
+            <a:r>
+              <a:t>PRESENTER NOTES</a:t>
+            </a:r>
+          </a:p>
+          <a:p xmlns:a="http://schemas.openxmlformats.org/drawingml/2006/main">
+            <a:r>
+              <a:t/>
+            </a:r>
+          </a:p>
+          <a:p xmlns:a="http://schemas.openxmlformats.org/drawingml/2006/main">
+            <a:r>
+              <a:t>Fairlead is a Rust inference gateway and compute router. It does not run inference: vLLM owns model loading, GPU execution, caching, and token streaming. Fairlead chooses the backend and applies routing, health, retry, resource, pool, and admission policy.</a:t>
+            </a:r>
+          </a:p>
+          <a:p xmlns:a="http://schemas.openxmlformats.org/drawingml/2006/main">
+            <a:r>
+              <a:t/>
+            </a:r>
+          </a:p>
+          <a:p xmlns:a="http://schemas.openxmlformats.org/drawingml/2006/main">
+            <a:r>
+              <a:t>For future multi-agent evaluations, the evaluation_shard extension provides a durable scheduling unit above individual model turns. Fairlead can own job state, worker-pool placement, claims, leases, renewal, retry, restart recovery, idempotency, callbacks, and operational metrics. Agent Defense Evals should continue to own prompts, attacks, seeds, immutable traces, scores, calibration, and statistical reports.</a:t>
+            </a:r>
+          </a:p>
+          <a:p xmlns:a="http://schemas.openxmlformats.org/drawingml/2006/main">
+            <a:r>
+              <a:t/>
+            </a:r>
+          </a:p>
+          <a:p xmlns:a="http://schemas.openxmlformats.org/drawingml/2006/main">
+            <a:r>
+              <a:t>The remaining qualification gate is operational: add the Python evaluation worker, verify artifact digests, preserve Fairlead response provenance in every trace, run a live-vLLM canary, exercise controlled Fairlead and vLLM restarts, and complete the target-machine soak. This supports repeatability; it does not itself prove a security claim.</a:t>
+            </a:r>
+          </a:p>
+          <a:p xmlns:a="http://schemas.openxmlformats.org/drawingml/2006/main">
+            <a:r>
+              <a:t/>
+            </a:r>
+          </a:p>
+          <a:p xmlns:a="http://schemas.openxmlformats.org/drawingml/2006/main">
+            <a:r>
+              <a:t>[Sources]</a:t>
+            </a:r>
+          </a:p>
+          <a:p xmlns:a="http://schemas.openxmlformats.org/drawingml/2006/main">
+            <a:r>
+              <a:t>- https://github.com/ybordag/fairlead</a:t>
+            </a:r>
+          </a:p>
+          <a:p xmlns:a="http://schemas.openxmlformats.org/drawingml/2006/main">
+            <a:r>
+              <a:t>- https://github.com/ybordag/fairlead/blob/evaluation-shard/docs/current_work/phase_9b_evaluation_shard.md</a:t>
+            </a:r>
+          </a:p>
+          <a:p xmlns:a="http://schemas.openxmlformats.org/drawingml/2006/main">
+            <a:r>
+              <a:t>- https://github.com/ybordag/fairlead/blob/overnight-hardening/docs/current_work/phase_9c_overnight_hardening.md</a:t>
+            </a:r>
+          </a:p>
+          <a:p xmlns:a="http://schemas.openxmlformats.org/drawingml/2006/main">
+            <a:r>
+              <a:t>[/Sources]</a:t>
+            </a:r>
+          </a:p>
+        </p:txBody>
+      </p:sp>
+      <p:sp>
+        <p:nvSpPr>
+          <p:cNvPr id="4" name="Slide Number Placeholder 3"/>
+          <p:cNvSpPr>
+            <a:spLocks xmlns:a="http://schemas.openxmlformats.org/drawingml/2006/main" noGrp="1"/>
+          </p:cNvSpPr>
+          <p:nvPr>
+            <p:ph type="sldNum" idx="5"/>
+          </p:nvPr>
+        </p:nvSpPr>
+        <p:spPr/>
+        <p:txBody>
+          <a:bodyPr xmlns:a="http://schemas.openxmlformats.org/drawingml/2006/main"/>
+          <a:lstStyle xmlns:a="http://schemas.openxmlformats.org/drawingml/2006/main"/>
+          <a:p xmlns:a="http://schemas.openxmlformats.org/drawingml/2006/main"/>
+        </p:txBody>
+      </p:sp>
+    </p:spTree>
+  </p:cSld>
+  <p:clrMapOvr>
+    <a:masterClrMapping xmlns:a="http://schemas.openxmlformats.org/drawingml/2006/main"/>
+  </p:clrMapOvr>
+</p:notes>
+</file>
+
 <file path=ppt/notesSlides/notesSlide3.xml><?xml version="1.0" encoding="utf-8"?>
 <p:notes xmlns:p="http://schemas.openxmlformats.org/presentationml/2006/main">
   <p:cSld>
@@ -2865,7 +2996,7 @@
   </p:cSld>
   <p:clrMap bg1="lt1" tx1="dk1" bg2="lt2" tx2="dk2" accent1="accent1" accent2="accent2" accent3="accent3" accent4="accent4" accent5="accent5" accent6="accent6" hlink="hlink" folHlink="folHlink"/>
   <p:sldLayoutIdLst>
-    <p:sldLayoutId xmlns:r="http://schemas.openxmlformats.org/officeDocument/2006/relationships" id="2147483649" r:id="R0b891c8ab00e40fd"/>
+    <p:sldLayoutId xmlns:r="http://schemas.openxmlformats.org/officeDocument/2006/relationships" id="2147483649" r:id="Rdca0ec23689b4c70"/>
   </p:sldLayoutIdLst>
   <p:txStyles>
     <p:titleStyle>
@@ -7201,7 +7332,7 @@
         </p:xfrm>
         <a:graphic xmlns:a="http://schemas.openxmlformats.org/drawingml/2006/main">
           <a:graphicData uri="http://schemas.openxmlformats.org/drawingml/2006/chart">
-            <c:chart xmlns:r="http://schemas.openxmlformats.org/officeDocument/2006/relationships" xmlns:c="http://schemas.openxmlformats.org/drawingml/2006/chart" r:id="Ra955b697b6254655"/>
+            <c:chart xmlns:r="http://schemas.openxmlformats.org/officeDocument/2006/relationships" xmlns:c="http://schemas.openxmlformats.org/drawingml/2006/chart" r:id="Rb68591f74d664dd3"/>
           </a:graphicData>
         </a:graphic>
       </p:graphicFrame>
@@ -7726,7 +7857,7 @@
         </p:xfrm>
         <a:graphic xmlns:a="http://schemas.openxmlformats.org/drawingml/2006/main">
           <a:graphicData uri="http://schemas.openxmlformats.org/drawingml/2006/chart">
-            <c:chart xmlns:r="http://schemas.openxmlformats.org/officeDocument/2006/relationships" xmlns:c="http://schemas.openxmlformats.org/drawingml/2006/chart" r:id="Rc769d492a5fa4b73"/>
+            <c:chart xmlns:r="http://schemas.openxmlformats.org/officeDocument/2006/relationships" xmlns:c="http://schemas.openxmlformats.org/drawingml/2006/chart" r:id="R8319cc8d30b74531"/>
           </a:graphicData>
         </a:graphic>
       </p:graphicFrame>
@@ -8194,7 +8325,7 @@
         </p:xfrm>
         <a:graphic xmlns:a="http://schemas.openxmlformats.org/drawingml/2006/main">
           <a:graphicData uri="http://schemas.openxmlformats.org/drawingml/2006/chart">
-            <c:chart xmlns:r="http://schemas.openxmlformats.org/officeDocument/2006/relationships" xmlns:c="http://schemas.openxmlformats.org/drawingml/2006/chart" r:id="R49a0ed02b79a40aa"/>
+            <c:chart xmlns:r="http://schemas.openxmlformats.org/officeDocument/2006/relationships" xmlns:c="http://schemas.openxmlformats.org/drawingml/2006/chart" r:id="R434525ad53d547d8"/>
           </a:graphicData>
         </a:graphic>
       </p:graphicFrame>
@@ -9054,7 +9185,7 @@
       </p:sp>
       <p:cxnSp>
         <p:nvCxnSpPr>
-          <p:cNvPr id="152" name=""/>
+          <p:cNvPr id="168" name=""/>
           <p:cNvCxnSpPr/>
           <p:nvPr/>
         </p:nvCxnSpPr>
@@ -10569,7 +10700,7 @@
         </p:xfrm>
         <a:graphic xmlns:a="http://schemas.openxmlformats.org/drawingml/2006/main">
           <a:graphicData uri="http://schemas.openxmlformats.org/drawingml/2006/chart">
-            <c:chart xmlns:r="http://schemas.openxmlformats.org/officeDocument/2006/relationships" xmlns:c="http://schemas.openxmlformats.org/drawingml/2006/chart" r:id="Re038a94e7ce9473a"/>
+            <c:chart xmlns:r="http://schemas.openxmlformats.org/officeDocument/2006/relationships" xmlns:c="http://schemas.openxmlformats.org/drawingml/2006/chart" r:id="R0f4f2e4dd2244146"/>
           </a:graphicData>
         </a:graphic>
       </p:graphicFrame>
@@ -14499,7 +14630,7 @@
       </p:sp>
       <p:cxnSp>
         <p:nvCxnSpPr>
-          <p:cNvPr id="152" name=""/>
+          <p:cNvPr id="168" name=""/>
           <p:cNvCxnSpPr/>
           <p:nvPr/>
         </p:nvCxnSpPr>
@@ -15813,6 +15944,871 @@
     <p:extLst>
       <p:ext uri="{BB962C8B-B14F-4D97-AF65-F5344CB8AC3E}">
         <p14:creationId xmlns:p14="http://schemas.microsoft.com/office/powerpoint/2010/main" val="1868691257"/>
+      </p:ext>
+    </p:extLst>
+  </p:cSld>
+</p:sld>
+</file>
+
+<file path=ppt/slides/slide22.xml><?xml version="1.0" encoding="utf-8"?>
+<p:sld xmlns:p="http://schemas.openxmlformats.org/presentationml/2006/main">
+  <p:cSld>
+    <p:spTree>
+      <p:nvGrpSpPr>
+        <p:cNvPr id="1" name=""/>
+        <p:cNvGrpSpPr/>
+        <p:nvPr/>
+      </p:nvGrpSpPr>
+      <p:grpSpPr>
+        <a:xfrm xmlns:a="http://schemas.openxmlformats.org/drawingml/2006/main"/>
+      </p:grpSpPr>
+      <p:sp>
+        <p:nvSpPr>
+          <p:cNvPr id="17" name="">
+            <a:extLst xmlns:a="http://schemas.openxmlformats.org/drawingml/2006/main">
+              <a:ext uri="{FF2B5EF4-FFF2-40B4-BE49-F238E27FC236}">
+                <a16:creationId xmlns:a16="http://schemas.microsoft.com/office/drawing/2014/main" id="{51131C71-3FBE-45E9-B711-EDD3B75D35EC}"/>
+              </a:ext>
+            </a:extLst>
+          </p:cNvPr>
+          <p:cNvSpPr>
+            <a:spLocks xmlns:a="http://schemas.openxmlformats.org/drawingml/2006/main" noGrp="1"/>
+          </p:cNvSpPr>
+          <p:nvPr/>
+        </p:nvSpPr>
+        <p:spPr>
+          <a:xfrm xmlns:a="http://schemas.openxmlformats.org/drawingml/2006/main">
+            <a:off x="400050" y="266700"/>
+            <a:ext cx="6667500" cy="266700"/>
+          </a:xfrm>
+          <a:prstGeom xmlns:a="http://schemas.openxmlformats.org/drawingml/2006/main" prst="rect">
+            <a:avLst/>
+          </a:prstGeom>
+          <a:noFill xmlns:a="http://schemas.openxmlformats.org/drawingml/2006/main"/>
+          <a:ln xmlns:a="http://schemas.openxmlformats.org/drawingml/2006/main" w="0">
+            <a:noFill/>
+            <a:prstDash val="solid"/>
+          </a:ln>
+        </p:spPr>
+        <p:txBody>
+          <a:bodyPr xmlns:a="http://schemas.openxmlformats.org/drawingml/2006/main" anchor="t"/>
+          <a:lstStyle xmlns:a="http://schemas.openxmlformats.org/drawingml/2006/main"/>
+          <a:p xmlns:a="http://schemas.openxmlformats.org/drawingml/2006/main">
+            <a:pPr algn="l">
+              <a:buNone/>
+              <a:defRPr sz="1200" b="1">
+                <a:solidFill>
+                  <a:srgbClr val="5D636D"/>
+                </a:solidFill>
+                <a:latin typeface="Helvetica Neue"/>
+                <a:ea typeface="Helvetica Neue"/>
+                <a:cs typeface="Helvetica Neue"/>
+              </a:defRPr>
+            </a:pPr>
+            <a:r>
+              <a:rPr sz="1200" b="1">
+                <a:solidFill>
+                  <a:srgbClr val="5D636D"/>
+                </a:solidFill>
+                <a:latin typeface="Helvetica Neue"/>
+                <a:ea typeface="Helvetica Neue"/>
+                <a:cs typeface="Helvetica Neue"/>
+              </a:rPr>
+              <a:t>MULTI-AGENT DEFENSE EVALUATION</a:t>
+            </a:r>
+          </a:p>
+        </p:txBody>
+      </p:sp>
+      <p:sp>
+        <p:nvSpPr>
+          <p:cNvPr id="2" name="slide-6-title">
+            <a:extLst xmlns:a="http://schemas.openxmlformats.org/drawingml/2006/main">
+              <a:ext uri="{FF2B5EF4-FFF2-40B4-BE49-F238E27FC236}">
+                <a16:creationId xmlns:a16="http://schemas.microsoft.com/office/drawing/2014/main" id="{CA9E1DB2-44DE-4718-AAFD-A4928026059A}"/>
+              </a:ext>
+            </a:extLst>
+          </p:cNvPr>
+          <p:cNvSpPr>
+            <a:spLocks xmlns:a="http://schemas.openxmlformats.org/drawingml/2006/main" noGrp="1"/>
+          </p:cNvSpPr>
+          <p:nvPr/>
+        </p:nvSpPr>
+        <p:spPr>
+          <a:xfrm xmlns:a="http://schemas.openxmlformats.org/drawingml/2006/main">
+            <a:off x="400050" y="619125"/>
+            <a:ext cx="11049000" cy="742950"/>
+          </a:xfrm>
+          <a:prstGeom xmlns:a="http://schemas.openxmlformats.org/drawingml/2006/main" prst="rect">
+            <a:avLst/>
+          </a:prstGeom>
+          <a:noFill xmlns:a="http://schemas.openxmlformats.org/drawingml/2006/main"/>
+          <a:ln xmlns:a="http://schemas.openxmlformats.org/drawingml/2006/main" w="0">
+            <a:noFill/>
+            <a:prstDash val="solid"/>
+          </a:ln>
+        </p:spPr>
+        <p:txBody>
+          <a:bodyPr xmlns:a="http://schemas.openxmlformats.org/drawingml/2006/main" anchor="t"/>
+          <a:lstStyle xmlns:a="http://schemas.openxmlformats.org/drawingml/2006/main"/>
+          <a:p xmlns:a="http://schemas.openxmlformats.org/drawingml/2006/main">
+            <a:pPr algn="l">
+              <a:buNone/>
+              <a:defRPr sz="3000" b="1">
+                <a:solidFill>
+                  <a:srgbClr val="000000"/>
+                </a:solidFill>
+                <a:latin typeface="Helvetica Neue"/>
+                <a:ea typeface="Helvetica Neue"/>
+                <a:cs typeface="Helvetica Neue"/>
+              </a:defRPr>
+            </a:pPr>
+            <a:r>
+              <a:rPr sz="3000" b="1">
+                <a:solidFill>
+                  <a:srgbClr val="000000"/>
+                </a:solidFill>
+                <a:latin typeface="Helvetica Neue"/>
+                <a:ea typeface="Helvetica Neue"/>
+                <a:cs typeface="Helvetica Neue"/>
+              </a:rPr>
+              <a:t>Fairlead operationalizes future multi-agent evaluations</a:t>
+            </a:r>
+          </a:p>
+        </p:txBody>
+      </p:sp>
+      <p:sp>
+        <p:nvSpPr>
+          <p:cNvPr id="3" name="">
+            <a:extLst xmlns:a="http://schemas.openxmlformats.org/drawingml/2006/main">
+              <a:ext uri="{FF2B5EF4-FFF2-40B4-BE49-F238E27FC236}">
+                <a16:creationId xmlns:a16="http://schemas.microsoft.com/office/drawing/2014/main" id="{C0F74CF4-81B3-48FE-9AEA-F5440C2341C6}"/>
+              </a:ext>
+            </a:extLst>
+          </p:cNvPr>
+          <p:cNvSpPr>
+            <a:spLocks xmlns:a="http://schemas.openxmlformats.org/drawingml/2006/main" noGrp="1"/>
+          </p:cNvSpPr>
+          <p:nvPr/>
+        </p:nvSpPr>
+        <p:spPr>
+          <a:xfrm xmlns:a="http://schemas.openxmlformats.org/drawingml/2006/main">
+            <a:off x="11239500" y="6334125"/>
+            <a:ext cx="523875" cy="228600"/>
+          </a:xfrm>
+          <a:prstGeom xmlns:a="http://schemas.openxmlformats.org/drawingml/2006/main" prst="rect">
+            <a:avLst/>
+          </a:prstGeom>
+          <a:noFill xmlns:a="http://schemas.openxmlformats.org/drawingml/2006/main"/>
+          <a:ln xmlns:a="http://schemas.openxmlformats.org/drawingml/2006/main" w="0">
+            <a:noFill/>
+            <a:prstDash val="solid"/>
+          </a:ln>
+        </p:spPr>
+        <p:txBody>
+          <a:bodyPr xmlns:a="http://schemas.openxmlformats.org/drawingml/2006/main" anchor="t"/>
+          <a:lstStyle xmlns:a="http://schemas.openxmlformats.org/drawingml/2006/main"/>
+          <a:p xmlns:a="http://schemas.openxmlformats.org/drawingml/2006/main">
+            <a:pPr algn="r">
+              <a:buNone/>
+              <a:defRPr sz="1050" b="0">
+                <a:solidFill>
+                  <a:srgbClr val="5D636D"/>
+                </a:solidFill>
+                <a:latin typeface="Helvetica Neue"/>
+                <a:ea typeface="Helvetica Neue"/>
+                <a:cs typeface="Helvetica Neue"/>
+              </a:defRPr>
+            </a:pPr>
+            <a:r>
+              <a:rPr sz="1050" b="0">
+                <a:solidFill>
+                  <a:srgbClr val="5D636D"/>
+                </a:solidFill>
+                <a:latin typeface="Helvetica Neue"/>
+                <a:ea typeface="Helvetica Neue"/>
+                <a:cs typeface="Helvetica Neue"/>
+              </a:rPr>
+              <a:t>22</a:t>
+            </a:r>
+          </a:p>
+        </p:txBody>
+      </p:sp>
+      <p:sp>
+        <p:nvSpPr>
+          <p:cNvPr id="4" name="">
+            <a:extLst xmlns:a="http://schemas.openxmlformats.org/drawingml/2006/main">
+              <a:ext uri="{FF2B5EF4-FFF2-40B4-BE49-F238E27FC236}">
+                <a16:creationId xmlns:a16="http://schemas.microsoft.com/office/drawing/2014/main" id="{C317BDED-2BE1-4928-97F6-FC2F2BA93993}"/>
+              </a:ext>
+            </a:extLst>
+          </p:cNvPr>
+          <p:cNvSpPr>
+            <a:spLocks xmlns:a="http://schemas.openxmlformats.org/drawingml/2006/main" noGrp="1"/>
+          </p:cNvSpPr>
+          <p:nvPr/>
+        </p:nvSpPr>
+        <p:spPr>
+          <a:xfrm xmlns:a="http://schemas.openxmlformats.org/drawingml/2006/main">
+            <a:off x="400050" y="1809750"/>
+            <a:ext cx="3476625" cy="3333750"/>
+          </a:xfrm>
+          <a:prstGeom xmlns:a="http://schemas.openxmlformats.org/drawingml/2006/main" prst="rect">
+            <a:avLst/>
+          </a:prstGeom>
+          <a:solidFill xmlns:a="http://schemas.openxmlformats.org/drawingml/2006/main">
+            <a:srgbClr val="F6F7F8"/>
+          </a:solidFill>
+          <a:ln xmlns:a="http://schemas.openxmlformats.org/drawingml/2006/main" w="0">
+            <a:noFill/>
+            <a:prstDash val="solid"/>
+          </a:ln>
+        </p:spPr>
+      </p:sp>
+      <p:sp>
+        <p:nvSpPr>
+          <p:cNvPr id="5" name="">
+            <a:extLst xmlns:a="http://schemas.openxmlformats.org/drawingml/2006/main">
+              <a:ext uri="{FF2B5EF4-FFF2-40B4-BE49-F238E27FC236}">
+                <a16:creationId xmlns:a16="http://schemas.microsoft.com/office/drawing/2014/main" id="{FD2BDC0F-8382-4F57-96E5-060EA267342B}"/>
+              </a:ext>
+            </a:extLst>
+          </p:cNvPr>
+          <p:cNvSpPr>
+            <a:spLocks xmlns:a="http://schemas.openxmlformats.org/drawingml/2006/main" noGrp="1"/>
+          </p:cNvSpPr>
+          <p:nvPr/>
+        </p:nvSpPr>
+        <p:spPr>
+          <a:xfrm xmlns:a="http://schemas.openxmlformats.org/drawingml/2006/main">
+            <a:off x="400050" y="1809750"/>
+            <a:ext cx="95250" cy="3333750"/>
+          </a:xfrm>
+          <a:prstGeom xmlns:a="http://schemas.openxmlformats.org/drawingml/2006/main" prst="rect">
+            <a:avLst/>
+          </a:prstGeom>
+          <a:solidFill xmlns:a="http://schemas.openxmlformats.org/drawingml/2006/main">
+            <a:srgbClr val="5D636D"/>
+          </a:solidFill>
+          <a:ln xmlns:a="http://schemas.openxmlformats.org/drawingml/2006/main" w="0">
+            <a:noFill/>
+            <a:prstDash val="solid"/>
+          </a:ln>
+        </p:spPr>
+      </p:sp>
+      <p:sp>
+        <p:nvSpPr>
+          <p:cNvPr id="6" name="">
+            <a:extLst xmlns:a="http://schemas.openxmlformats.org/drawingml/2006/main">
+              <a:ext uri="{FF2B5EF4-FFF2-40B4-BE49-F238E27FC236}">
+                <a16:creationId xmlns:a16="http://schemas.microsoft.com/office/drawing/2014/main" id="{F957BA5D-E40A-4135-938D-774336F5BE0A}"/>
+              </a:ext>
+            </a:extLst>
+          </p:cNvPr>
+          <p:cNvSpPr>
+            <a:spLocks xmlns:a="http://schemas.openxmlformats.org/drawingml/2006/main" noGrp="1"/>
+          </p:cNvSpPr>
+          <p:nvPr/>
+        </p:nvSpPr>
+        <p:spPr>
+          <a:xfrm xmlns:a="http://schemas.openxmlformats.org/drawingml/2006/main">
+            <a:off x="666750" y="2076450"/>
+            <a:ext cx="3038475" cy="781050"/>
+          </a:xfrm>
+          <a:prstGeom xmlns:a="http://schemas.openxmlformats.org/drawingml/2006/main" prst="rect">
+            <a:avLst/>
+          </a:prstGeom>
+          <a:noFill xmlns:a="http://schemas.openxmlformats.org/drawingml/2006/main"/>
+          <a:ln xmlns:a="http://schemas.openxmlformats.org/drawingml/2006/main" w="0">
+            <a:noFill/>
+            <a:prstDash val="solid"/>
+          </a:ln>
+        </p:spPr>
+        <p:txBody>
+          <a:bodyPr xmlns:a="http://schemas.openxmlformats.org/drawingml/2006/main" anchor="t"/>
+          <a:lstStyle xmlns:a="http://schemas.openxmlformats.org/drawingml/2006/main"/>
+          <a:p xmlns:a="http://schemas.openxmlformats.org/drawingml/2006/main">
+            <a:pPr algn="l">
+              <a:buNone/>
+              <a:defRPr sz="3150" b="1">
+                <a:solidFill>
+                  <a:srgbClr val="5D636D"/>
+                </a:solidFill>
+                <a:latin typeface="Helvetica Neue"/>
+                <a:ea typeface="Helvetica Neue"/>
+                <a:cs typeface="Helvetica Neue"/>
+              </a:defRPr>
+            </a:pPr>
+            <a:r>
+              <a:rPr sz="3150" b="1">
+                <a:solidFill>
+                  <a:srgbClr val="5D636D"/>
+                </a:solidFill>
+                <a:latin typeface="Helvetica Neue"/>
+                <a:ea typeface="Helvetica Neue"/>
+                <a:cs typeface="Helvetica Neue"/>
+              </a:rPr>
+              <a:t>Inference</a:t>
+            </a:r>
+          </a:p>
+        </p:txBody>
+      </p:sp>
+      <p:sp>
+        <p:nvSpPr>
+          <p:cNvPr id="7" name="">
+            <a:extLst xmlns:a="http://schemas.openxmlformats.org/drawingml/2006/main">
+              <a:ext uri="{FF2B5EF4-FFF2-40B4-BE49-F238E27FC236}">
+                <a16:creationId xmlns:a16="http://schemas.microsoft.com/office/drawing/2014/main" id="{948BF936-6003-469C-9E55-F76CBEA7BD55}"/>
+              </a:ext>
+            </a:extLst>
+          </p:cNvPr>
+          <p:cNvSpPr>
+            <a:spLocks xmlns:a="http://schemas.openxmlformats.org/drawingml/2006/main" noGrp="1"/>
+          </p:cNvSpPr>
+          <p:nvPr/>
+        </p:nvSpPr>
+        <p:spPr>
+          <a:xfrm xmlns:a="http://schemas.openxmlformats.org/drawingml/2006/main">
+            <a:off x="666750" y="2933700"/>
+            <a:ext cx="3038475" cy="2000250"/>
+          </a:xfrm>
+          <a:prstGeom xmlns:a="http://schemas.openxmlformats.org/drawingml/2006/main" prst="rect">
+            <a:avLst/>
+          </a:prstGeom>
+          <a:noFill xmlns:a="http://schemas.openxmlformats.org/drawingml/2006/main"/>
+          <a:ln xmlns:a="http://schemas.openxmlformats.org/drawingml/2006/main" w="0">
+            <a:noFill/>
+            <a:prstDash val="solid"/>
+          </a:ln>
+        </p:spPr>
+        <p:txBody>
+          <a:bodyPr xmlns:a="http://schemas.openxmlformats.org/drawingml/2006/main" anchor="t"/>
+          <a:lstStyle xmlns:a="http://schemas.openxmlformats.org/drawingml/2006/main"/>
+          <a:p xmlns:a="http://schemas.openxmlformats.org/drawingml/2006/main">
+            <a:pPr algn="l">
+              <a:buNone/>
+              <a:defRPr sz="1350" b="0">
+                <a:solidFill>
+                  <a:srgbClr val="5D636D"/>
+                </a:solidFill>
+                <a:latin typeface="Helvetica Neue"/>
+                <a:ea typeface="Helvetica Neue"/>
+                <a:cs typeface="Helvetica Neue"/>
+              </a:defRPr>
+            </a:pPr>
+            <a:r>
+              <a:rPr sz="1350" b="0">
+                <a:solidFill>
+                  <a:srgbClr val="5D636D"/>
+                </a:solidFill>
+                <a:latin typeface="Helvetica Neue"/>
+                <a:ea typeface="Helvetica Neue"/>
+                <a:cs typeface="Helvetica Neue"/>
+              </a:rPr>
+              <a:t>Current Rust gateway</a:t>
+            </a:r>
+          </a:p>
+          <a:p xmlns:a="http://schemas.openxmlformats.org/drawingml/2006/main">
+            <a:r>
+              <a:t/>
+            </a:r>
+          </a:p>
+          <a:p xmlns:a="http://schemas.openxmlformats.org/drawingml/2006/main">
+            <a:pPr algn="l">
+              <a:buNone/>
+              <a:defRPr sz="1350" b="0">
+                <a:solidFill>
+                  <a:srgbClr val="5D636D"/>
+                </a:solidFill>
+                <a:latin typeface="Helvetica Neue"/>
+                <a:ea typeface="Helvetica Neue"/>
+                <a:cs typeface="Helvetica Neue"/>
+              </a:defRPr>
+            </a:pPr>
+            <a:r>
+              <a:rPr sz="1350" b="0">
+                <a:solidFill>
+                  <a:srgbClr val="5D636D"/>
+                </a:solidFill>
+                <a:latin typeface="Helvetica Neue"/>
+                <a:ea typeface="Helvetica Neue"/>
+                <a:cs typeface="Helvetica Neue"/>
+              </a:rPr>
+              <a:t>Routes OpenAI-compatible requests to vLLM with health-aware fallback, model and pool eligibility, and resource-aware admission.</a:t>
+            </a:r>
+          </a:p>
+        </p:txBody>
+      </p:sp>
+      <p:sp>
+        <p:nvSpPr>
+          <p:cNvPr id="8" name="">
+            <a:extLst xmlns:a="http://schemas.openxmlformats.org/drawingml/2006/main">
+              <a:ext uri="{FF2B5EF4-FFF2-40B4-BE49-F238E27FC236}">
+                <a16:creationId xmlns:a16="http://schemas.microsoft.com/office/drawing/2014/main" id="{6EDB8085-898C-4C86-B1FA-6D1D5FF6008B}"/>
+              </a:ext>
+            </a:extLst>
+          </p:cNvPr>
+          <p:cNvSpPr>
+            <a:spLocks xmlns:a="http://schemas.openxmlformats.org/drawingml/2006/main" noGrp="1"/>
+          </p:cNvSpPr>
+          <p:nvPr/>
+        </p:nvSpPr>
+        <p:spPr>
+          <a:xfrm xmlns:a="http://schemas.openxmlformats.org/drawingml/2006/main">
+            <a:off x="4352925" y="1809750"/>
+            <a:ext cx="3476625" cy="3333750"/>
+          </a:xfrm>
+          <a:prstGeom xmlns:a="http://schemas.openxmlformats.org/drawingml/2006/main" prst="rect">
+            <a:avLst/>
+          </a:prstGeom>
+          <a:solidFill xmlns:a="http://schemas.openxmlformats.org/drawingml/2006/main">
+            <a:srgbClr val="F6F7F8"/>
+          </a:solidFill>
+          <a:ln xmlns:a="http://schemas.openxmlformats.org/drawingml/2006/main" w="0">
+            <a:noFill/>
+            <a:prstDash val="solid"/>
+          </a:ln>
+        </p:spPr>
+      </p:sp>
+      <p:sp>
+        <p:nvSpPr>
+          <p:cNvPr id="9" name="">
+            <a:extLst xmlns:a="http://schemas.openxmlformats.org/drawingml/2006/main">
+              <a:ext uri="{FF2B5EF4-FFF2-40B4-BE49-F238E27FC236}">
+                <a16:creationId xmlns:a16="http://schemas.microsoft.com/office/drawing/2014/main" id="{D8AABD1D-F00F-4EC1-9266-2BE52D1E0BCF}"/>
+              </a:ext>
+            </a:extLst>
+          </p:cNvPr>
+          <p:cNvSpPr>
+            <a:spLocks xmlns:a="http://schemas.openxmlformats.org/drawingml/2006/main" noGrp="1"/>
+          </p:cNvSpPr>
+          <p:nvPr/>
+        </p:nvSpPr>
+        <p:spPr>
+          <a:xfrm xmlns:a="http://schemas.openxmlformats.org/drawingml/2006/main">
+            <a:off x="4352925" y="1809750"/>
+            <a:ext cx="95250" cy="3333750"/>
+          </a:xfrm>
+          <a:prstGeom xmlns:a="http://schemas.openxmlformats.org/drawingml/2006/main" prst="rect">
+            <a:avLst/>
+          </a:prstGeom>
+          <a:solidFill xmlns:a="http://schemas.openxmlformats.org/drawingml/2006/main">
+            <a:srgbClr val="3D8DFF"/>
+          </a:solidFill>
+          <a:ln xmlns:a="http://schemas.openxmlformats.org/drawingml/2006/main" w="0">
+            <a:noFill/>
+            <a:prstDash val="solid"/>
+          </a:ln>
+        </p:spPr>
+      </p:sp>
+      <p:sp>
+        <p:nvSpPr>
+          <p:cNvPr id="10" name="">
+            <a:extLst xmlns:a="http://schemas.openxmlformats.org/drawingml/2006/main">
+              <a:ext uri="{FF2B5EF4-FFF2-40B4-BE49-F238E27FC236}">
+                <a16:creationId xmlns:a16="http://schemas.microsoft.com/office/drawing/2014/main" id="{6A659B87-AB64-4F51-A371-EF4D948A5ABB}"/>
+              </a:ext>
+            </a:extLst>
+          </p:cNvPr>
+          <p:cNvSpPr>
+            <a:spLocks xmlns:a="http://schemas.openxmlformats.org/drawingml/2006/main" noGrp="1"/>
+          </p:cNvSpPr>
+          <p:nvPr/>
+        </p:nvSpPr>
+        <p:spPr>
+          <a:xfrm xmlns:a="http://schemas.openxmlformats.org/drawingml/2006/main">
+            <a:off x="4619625" y="2076450"/>
+            <a:ext cx="3038475" cy="781050"/>
+          </a:xfrm>
+          <a:prstGeom xmlns:a="http://schemas.openxmlformats.org/drawingml/2006/main" prst="rect">
+            <a:avLst/>
+          </a:prstGeom>
+          <a:noFill xmlns:a="http://schemas.openxmlformats.org/drawingml/2006/main"/>
+          <a:ln xmlns:a="http://schemas.openxmlformats.org/drawingml/2006/main" w="0">
+            <a:noFill/>
+            <a:prstDash val="solid"/>
+          </a:ln>
+        </p:spPr>
+        <p:txBody>
+          <a:bodyPr xmlns:a="http://schemas.openxmlformats.org/drawingml/2006/main" anchor="t"/>
+          <a:lstStyle xmlns:a="http://schemas.openxmlformats.org/drawingml/2006/main"/>
+          <a:p xmlns:a="http://schemas.openxmlformats.org/drawingml/2006/main">
+            <a:pPr algn="l">
+              <a:buNone/>
+              <a:defRPr sz="3150" b="1">
+                <a:solidFill>
+                  <a:srgbClr val="3D8DFF"/>
+                </a:solidFill>
+                <a:latin typeface="Helvetica Neue"/>
+                <a:ea typeface="Helvetica Neue"/>
+                <a:cs typeface="Helvetica Neue"/>
+              </a:defRPr>
+            </a:pPr>
+            <a:r>
+              <a:rPr sz="3150" b="1">
+                <a:solidFill>
+                  <a:srgbClr val="3D8DFF"/>
+                </a:solidFill>
+                <a:latin typeface="Helvetica Neue"/>
+                <a:ea typeface="Helvetica Neue"/>
+                <a:cs typeface="Helvetica Neue"/>
+              </a:rPr>
+              <a:t>Scheduling</a:t>
+            </a:r>
+          </a:p>
+        </p:txBody>
+      </p:sp>
+      <p:sp>
+        <p:nvSpPr>
+          <p:cNvPr id="11" name="">
+            <a:extLst xmlns:a="http://schemas.openxmlformats.org/drawingml/2006/main">
+              <a:ext uri="{FF2B5EF4-FFF2-40B4-BE49-F238E27FC236}">
+                <a16:creationId xmlns:a16="http://schemas.microsoft.com/office/drawing/2014/main" id="{FA1B36BE-585A-435E-AA53-5D01585EE58C}"/>
+              </a:ext>
+            </a:extLst>
+          </p:cNvPr>
+          <p:cNvSpPr>
+            <a:spLocks xmlns:a="http://schemas.openxmlformats.org/drawingml/2006/main" noGrp="1"/>
+          </p:cNvSpPr>
+          <p:nvPr/>
+        </p:nvSpPr>
+        <p:spPr>
+          <a:xfrm xmlns:a="http://schemas.openxmlformats.org/drawingml/2006/main">
+            <a:off x="4619625" y="2933700"/>
+            <a:ext cx="3038475" cy="2000250"/>
+          </a:xfrm>
+          <a:prstGeom xmlns:a="http://schemas.openxmlformats.org/drawingml/2006/main" prst="rect">
+            <a:avLst/>
+          </a:prstGeom>
+          <a:noFill xmlns:a="http://schemas.openxmlformats.org/drawingml/2006/main"/>
+          <a:ln xmlns:a="http://schemas.openxmlformats.org/drawingml/2006/main" w="0">
+            <a:noFill/>
+            <a:prstDash val="solid"/>
+          </a:ln>
+        </p:spPr>
+        <p:txBody>
+          <a:bodyPr xmlns:a="http://schemas.openxmlformats.org/drawingml/2006/main" anchor="t"/>
+          <a:lstStyle xmlns:a="http://schemas.openxmlformats.org/drawingml/2006/main"/>
+          <a:p xmlns:a="http://schemas.openxmlformats.org/drawingml/2006/main">
+            <a:pPr algn="l">
+              <a:buNone/>
+              <a:defRPr sz="1350" b="0">
+                <a:solidFill>
+                  <a:srgbClr val="5D636D"/>
+                </a:solidFill>
+                <a:latin typeface="Helvetica Neue"/>
+                <a:ea typeface="Helvetica Neue"/>
+                <a:cs typeface="Helvetica Neue"/>
+              </a:defRPr>
+            </a:pPr>
+            <a:r>
+              <a:rPr sz="1350" b="0">
+                <a:solidFill>
+                  <a:srgbClr val="5D636D"/>
+                </a:solidFill>
+                <a:latin typeface="Helvetica Neue"/>
+                <a:ea typeface="Helvetica Neue"/>
+                <a:cs typeface="Helvetica Neue"/>
+              </a:rPr>
+              <a:t>evaluation_shard extension</a:t>
+            </a:r>
+          </a:p>
+          <a:p xmlns:a="http://schemas.openxmlformats.org/drawingml/2006/main">
+            <a:r>
+              <a:t/>
+            </a:r>
+          </a:p>
+          <a:p xmlns:a="http://schemas.openxmlformats.org/drawingml/2006/main">
+            <a:pPr algn="l">
+              <a:buNone/>
+              <a:defRPr sz="1350" b="0">
+                <a:solidFill>
+                  <a:srgbClr val="5D636D"/>
+                </a:solidFill>
+                <a:latin typeface="Helvetica Neue"/>
+                <a:ea typeface="Helvetica Neue"/>
+                <a:cs typeface="Helvetica Neue"/>
+              </a:defRPr>
+            </a:pPr>
+            <a:r>
+              <a:rPr sz="1350" b="0">
+                <a:solidFill>
+                  <a:srgbClr val="5D636D"/>
+                </a:solidFill>
+                <a:latin typeface="Helvetica Neue"/>
+                <a:ea typeface="Helvetica Neue"/>
+                <a:cs typeface="Helvetica Neue"/>
+              </a:rPr>
+              <a:t>Adds worker pools, claims, leases, renewals, retries, restart recovery, idempotency, callbacks, and operational metrics.</a:t>
+            </a:r>
+          </a:p>
+        </p:txBody>
+      </p:sp>
+      <p:sp>
+        <p:nvSpPr>
+          <p:cNvPr id="12" name="">
+            <a:extLst xmlns:a="http://schemas.openxmlformats.org/drawingml/2006/main">
+              <a:ext uri="{FF2B5EF4-FFF2-40B4-BE49-F238E27FC236}">
+                <a16:creationId xmlns:a16="http://schemas.microsoft.com/office/drawing/2014/main" id="{7EAC07C0-0BDD-492D-9A25-0C42D64E6656}"/>
+              </a:ext>
+            </a:extLst>
+          </p:cNvPr>
+          <p:cNvSpPr>
+            <a:spLocks xmlns:a="http://schemas.openxmlformats.org/drawingml/2006/main" noGrp="1"/>
+          </p:cNvSpPr>
+          <p:nvPr/>
+        </p:nvSpPr>
+        <p:spPr>
+          <a:xfrm xmlns:a="http://schemas.openxmlformats.org/drawingml/2006/main">
+            <a:off x="8305800" y="1809750"/>
+            <a:ext cx="3486150" cy="3333750"/>
+          </a:xfrm>
+          <a:prstGeom xmlns:a="http://schemas.openxmlformats.org/drawingml/2006/main" prst="rect">
+            <a:avLst/>
+          </a:prstGeom>
+          <a:solidFill xmlns:a="http://schemas.openxmlformats.org/drawingml/2006/main">
+            <a:srgbClr val="F6F7F8"/>
+          </a:solidFill>
+          <a:ln xmlns:a="http://schemas.openxmlformats.org/drawingml/2006/main" w="0">
+            <a:noFill/>
+            <a:prstDash val="solid"/>
+          </a:ln>
+        </p:spPr>
+      </p:sp>
+      <p:sp>
+        <p:nvSpPr>
+          <p:cNvPr id="13" name="">
+            <a:extLst xmlns:a="http://schemas.openxmlformats.org/drawingml/2006/main">
+              <a:ext uri="{FF2B5EF4-FFF2-40B4-BE49-F238E27FC236}">
+                <a16:creationId xmlns:a16="http://schemas.microsoft.com/office/drawing/2014/main" id="{8C24F48E-FA4D-4F63-B5C6-E8B25428484A}"/>
+              </a:ext>
+            </a:extLst>
+          </p:cNvPr>
+          <p:cNvSpPr>
+            <a:spLocks xmlns:a="http://schemas.openxmlformats.org/drawingml/2006/main" noGrp="1"/>
+          </p:cNvSpPr>
+          <p:nvPr/>
+        </p:nvSpPr>
+        <p:spPr>
+          <a:xfrm xmlns:a="http://schemas.openxmlformats.org/drawingml/2006/main">
+            <a:off x="8305800" y="1809750"/>
+            <a:ext cx="95250" cy="3333750"/>
+          </a:xfrm>
+          <a:prstGeom xmlns:a="http://schemas.openxmlformats.org/drawingml/2006/main" prst="rect">
+            <a:avLst/>
+          </a:prstGeom>
+          <a:solidFill xmlns:a="http://schemas.openxmlformats.org/drawingml/2006/main">
+            <a:srgbClr val="20704A"/>
+          </a:solidFill>
+          <a:ln xmlns:a="http://schemas.openxmlformats.org/drawingml/2006/main" w="0">
+            <a:noFill/>
+            <a:prstDash val="solid"/>
+          </a:ln>
+        </p:spPr>
+      </p:sp>
+      <p:sp>
+        <p:nvSpPr>
+          <p:cNvPr id="14" name="">
+            <a:extLst xmlns:a="http://schemas.openxmlformats.org/drawingml/2006/main">
+              <a:ext uri="{FF2B5EF4-FFF2-40B4-BE49-F238E27FC236}">
+                <a16:creationId xmlns:a16="http://schemas.microsoft.com/office/drawing/2014/main" id="{661B2D4F-964F-42B1-8200-323DE068DD6E}"/>
+              </a:ext>
+            </a:extLst>
+          </p:cNvPr>
+          <p:cNvSpPr>
+            <a:spLocks xmlns:a="http://schemas.openxmlformats.org/drawingml/2006/main" noGrp="1"/>
+          </p:cNvSpPr>
+          <p:nvPr/>
+        </p:nvSpPr>
+        <p:spPr>
+          <a:xfrm xmlns:a="http://schemas.openxmlformats.org/drawingml/2006/main">
+            <a:off x="8572500" y="2076450"/>
+            <a:ext cx="3048000" cy="781050"/>
+          </a:xfrm>
+          <a:prstGeom xmlns:a="http://schemas.openxmlformats.org/drawingml/2006/main" prst="rect">
+            <a:avLst/>
+          </a:prstGeom>
+          <a:noFill xmlns:a="http://schemas.openxmlformats.org/drawingml/2006/main"/>
+          <a:ln xmlns:a="http://schemas.openxmlformats.org/drawingml/2006/main" w="0">
+            <a:noFill/>
+            <a:prstDash val="solid"/>
+          </a:ln>
+        </p:spPr>
+        <p:txBody>
+          <a:bodyPr xmlns:a="http://schemas.openxmlformats.org/drawingml/2006/main" anchor="t"/>
+          <a:lstStyle xmlns:a="http://schemas.openxmlformats.org/drawingml/2006/main"/>
+          <a:p xmlns:a="http://schemas.openxmlformats.org/drawingml/2006/main">
+            <a:pPr algn="l">
+              <a:buNone/>
+              <a:defRPr sz="3150" b="1">
+                <a:solidFill>
+                  <a:srgbClr val="20704A"/>
+                </a:solidFill>
+                <a:latin typeface="Helvetica Neue"/>
+                <a:ea typeface="Helvetica Neue"/>
+                <a:cs typeface="Helvetica Neue"/>
+              </a:defRPr>
+            </a:pPr>
+            <a:r>
+              <a:rPr sz="3150" b="1">
+                <a:solidFill>
+                  <a:srgbClr val="20704A"/>
+                </a:solidFill>
+                <a:latin typeface="Helvetica Neue"/>
+                <a:ea typeface="Helvetica Neue"/>
+                <a:cs typeface="Helvetica Neue"/>
+              </a:rPr>
+              <a:t>Integration</a:t>
+            </a:r>
+          </a:p>
+        </p:txBody>
+      </p:sp>
+      <p:sp>
+        <p:nvSpPr>
+          <p:cNvPr id="15" name="">
+            <a:extLst xmlns:a="http://schemas.openxmlformats.org/drawingml/2006/main">
+              <a:ext uri="{FF2B5EF4-FFF2-40B4-BE49-F238E27FC236}">
+                <a16:creationId xmlns:a16="http://schemas.microsoft.com/office/drawing/2014/main" id="{E76C9C74-72A0-4552-948E-ACA23CC56274}"/>
+              </a:ext>
+            </a:extLst>
+          </p:cNvPr>
+          <p:cNvSpPr>
+            <a:spLocks xmlns:a="http://schemas.openxmlformats.org/drawingml/2006/main" noGrp="1"/>
+          </p:cNvSpPr>
+          <p:nvPr/>
+        </p:nvSpPr>
+        <p:spPr>
+          <a:xfrm xmlns:a="http://schemas.openxmlformats.org/drawingml/2006/main">
+            <a:off x="8572500" y="2933700"/>
+            <a:ext cx="3048000" cy="2000250"/>
+          </a:xfrm>
+          <a:prstGeom xmlns:a="http://schemas.openxmlformats.org/drawingml/2006/main" prst="rect">
+            <a:avLst/>
+          </a:prstGeom>
+          <a:noFill xmlns:a="http://schemas.openxmlformats.org/drawingml/2006/main"/>
+          <a:ln xmlns:a="http://schemas.openxmlformats.org/drawingml/2006/main" w="0">
+            <a:noFill/>
+            <a:prstDash val="solid"/>
+          </a:ln>
+        </p:spPr>
+        <p:txBody>
+          <a:bodyPr xmlns:a="http://schemas.openxmlformats.org/drawingml/2006/main" anchor="t"/>
+          <a:lstStyle xmlns:a="http://schemas.openxmlformats.org/drawingml/2006/main"/>
+          <a:p xmlns:a="http://schemas.openxmlformats.org/drawingml/2006/main">
+            <a:pPr algn="l">
+              <a:buNone/>
+              <a:defRPr sz="1350" b="0">
+                <a:solidFill>
+                  <a:srgbClr val="5D636D"/>
+                </a:solidFill>
+                <a:latin typeface="Helvetica Neue"/>
+                <a:ea typeface="Helvetica Neue"/>
+                <a:cs typeface="Helvetica Neue"/>
+              </a:defRPr>
+            </a:pPr>
+            <a:r>
+              <a:rPr sz="1350" b="0">
+                <a:solidFill>
+                  <a:srgbClr val="5D636D"/>
+                </a:solidFill>
+                <a:latin typeface="Helvetica Neue"/>
+                <a:ea typeface="Helvetica Neue"/>
+                <a:cs typeface="Helvetica Neue"/>
+              </a:rPr>
+              <a:t>Next multi-agent tests</a:t>
+            </a:r>
+          </a:p>
+          <a:p xmlns:a="http://schemas.openxmlformats.org/drawingml/2006/main">
+            <a:r>
+              <a:t/>
+            </a:r>
+          </a:p>
+          <a:p xmlns:a="http://schemas.openxmlformats.org/drawingml/2006/main">
+            <a:pPr algn="l">
+              <a:buNone/>
+              <a:defRPr sz="1350" b="0">
+                <a:solidFill>
+                  <a:srgbClr val="5D636D"/>
+                </a:solidFill>
+                <a:latin typeface="Helvetica Neue"/>
+                <a:ea typeface="Helvetica Neue"/>
+                <a:cs typeface="Helvetica Neue"/>
+              </a:defRPr>
+            </a:pPr>
+            <a:r>
+              <a:rPr sz="1350" b="0">
+                <a:solidFill>
+                  <a:srgbClr val="5D636D"/>
+                </a:solidFill>
+                <a:latin typeface="Helvetica Neue"/>
+                <a:ea typeface="Helvetica Neue"/>
+                <a:cs typeface="Helvetica Neue"/>
+              </a:rPr>
+              <a:t>Shard held-out models and attack cells, preserve routing provenance, verify artifacts, and resume overnight campaigns.</a:t>
+            </a:r>
+          </a:p>
+        </p:txBody>
+      </p:sp>
+      <p:sp>
+        <p:nvSpPr>
+          <p:cNvPr id="16" name="">
+            <a:extLst xmlns:a="http://schemas.openxmlformats.org/drawingml/2006/main">
+              <a:ext uri="{FF2B5EF4-FFF2-40B4-BE49-F238E27FC236}">
+                <a16:creationId xmlns:a16="http://schemas.microsoft.com/office/drawing/2014/main" id="{A84ABC26-1996-4C7A-9D39-7267C562B8D0}"/>
+              </a:ext>
+            </a:extLst>
+          </p:cNvPr>
+          <p:cNvSpPr>
+            <a:spLocks xmlns:a="http://schemas.openxmlformats.org/drawingml/2006/main" noGrp="1"/>
+          </p:cNvSpPr>
+          <p:nvPr/>
+        </p:nvSpPr>
+        <p:spPr>
+          <a:xfrm xmlns:a="http://schemas.openxmlformats.org/drawingml/2006/main">
+            <a:off x="400050" y="5619750"/>
+            <a:ext cx="10953750" cy="400050"/>
+          </a:xfrm>
+          <a:prstGeom xmlns:a="http://schemas.openxmlformats.org/drawingml/2006/main" prst="rect">
+            <a:avLst/>
+          </a:prstGeom>
+          <a:noFill xmlns:a="http://schemas.openxmlformats.org/drawingml/2006/main"/>
+          <a:ln xmlns:a="http://schemas.openxmlformats.org/drawingml/2006/main" w="0">
+            <a:noFill/>
+            <a:prstDash val="solid"/>
+          </a:ln>
+        </p:spPr>
+        <p:txBody>
+          <a:bodyPr xmlns:a="http://schemas.openxmlformats.org/drawingml/2006/main" anchor="t"/>
+          <a:lstStyle xmlns:a="http://schemas.openxmlformats.org/drawingml/2006/main"/>
+          <a:p xmlns:a="http://schemas.openxmlformats.org/drawingml/2006/main">
+            <a:pPr algn="l">
+              <a:buNone/>
+              <a:defRPr sz="2100" b="1">
+                <a:solidFill>
+                  <a:srgbClr val="C86B20"/>
+                </a:solidFill>
+                <a:latin typeface="Helvetica Neue"/>
+                <a:ea typeface="Helvetica Neue"/>
+                <a:cs typeface="Helvetica Neue"/>
+              </a:defRPr>
+            </a:pPr>
+            <a:r>
+              <a:rPr sz="2100" b="1">
+                <a:solidFill>
+                  <a:srgbClr val="C86B20"/>
+                </a:solidFill>
+                <a:latin typeface="Helvetica Neue"/>
+                <a:ea typeface="Helvetica Neue"/>
+                <a:cs typeface="Helvetica Neue"/>
+              </a:rPr>
+              <a:t>Fairlead owns compute control; Agent Defense Evals owns prompts, traces, scores, and statistical validity.</a:t>
+            </a:r>
+          </a:p>
+        </p:txBody>
+      </p:sp>
+    </p:spTree>
+    <p:extLst>
+      <p:ext uri="{BB962C8B-B14F-4D97-AF65-F5344CB8AC3E}">
+        <p14:creationId xmlns:p14="http://schemas.microsoft.com/office/powerpoint/2010/main" val="314582863"/>
       </p:ext>
     </p:extLst>
   </p:cSld>
@@ -16175,7 +17171,7 @@
       </p:sp>
       <p:cxnSp>
         <p:nvCxnSpPr>
-          <p:cNvPr id="429" name=""/>
+          <p:cNvPr id="485" name=""/>
           <p:cNvCxnSpPr/>
           <p:nvPr/>
         </p:nvCxnSpPr>
@@ -16311,7 +17307,7 @@
       </p:sp>
       <p:cxnSp>
         <p:nvCxnSpPr>
-          <p:cNvPr id="432" name=""/>
+          <p:cNvPr id="488" name=""/>
           <p:cNvCxnSpPr/>
           <p:nvPr/>
         </p:nvCxnSpPr>
@@ -16447,7 +17443,7 @@
       </p:sp>
       <p:cxnSp>
         <p:nvCxnSpPr>
-          <p:cNvPr id="435" name=""/>
+          <p:cNvPr id="491" name=""/>
           <p:cNvCxnSpPr/>
           <p:nvPr/>
         </p:nvCxnSpPr>
@@ -16583,7 +17579,7 @@
       </p:sp>
       <p:cxnSp>
         <p:nvCxnSpPr>
-          <p:cNvPr id="438" name=""/>
+          <p:cNvPr id="494" name=""/>
           <p:cNvCxnSpPr/>
           <p:nvPr/>
         </p:nvCxnSpPr>
@@ -16719,7 +17715,7 @@
       </p:sp>
       <p:cxnSp>
         <p:nvCxnSpPr>
-          <p:cNvPr id="441" name=""/>
+          <p:cNvPr id="497" name=""/>
           <p:cNvCxnSpPr/>
           <p:nvPr/>
         </p:nvCxnSpPr>
@@ -16855,7 +17851,7 @@
       </p:sp>
       <p:cxnSp>
         <p:nvCxnSpPr>
-          <p:cNvPr id="444" name=""/>
+          <p:cNvPr id="500" name=""/>
           <p:cNvCxnSpPr/>
           <p:nvPr/>
         </p:nvCxnSpPr>
@@ -16991,7 +17987,7 @@
       </p:sp>
       <p:cxnSp>
         <p:nvCxnSpPr>
-          <p:cNvPr id="447" name=""/>
+          <p:cNvPr id="503" name=""/>
           <p:cNvCxnSpPr/>
           <p:nvPr/>
         </p:nvCxnSpPr>
@@ -17127,7 +18123,7 @@
       </p:sp>
       <p:cxnSp>
         <p:nvCxnSpPr>
-          <p:cNvPr id="450" name=""/>
+          <p:cNvPr id="506" name=""/>
           <p:cNvCxnSpPr/>
           <p:nvPr/>
         </p:nvCxnSpPr>
@@ -18354,7 +19350,7 @@
       </p:sp>
       <p:cxnSp>
         <p:nvCxnSpPr>
-          <p:cNvPr id="152" name=""/>
+          <p:cNvPr id="168" name=""/>
           <p:cNvCxnSpPr/>
           <p:nvPr/>
         </p:nvCxnSpPr>
@@ -20207,7 +21203,7 @@
       </p:sp>
       <p:cxnSp>
         <p:nvCxnSpPr>
-          <p:cNvPr id="152" name=""/>
+          <p:cNvPr id="168" name=""/>
           <p:cNvCxnSpPr/>
           <p:nvPr/>
         </p:nvCxnSpPr>
@@ -23521,7 +24517,7 @@
       </p:sp>
       <p:cxnSp>
         <p:nvCxnSpPr>
-          <p:cNvPr id="86" name=""/>
+          <p:cNvPr id="94" name=""/>
           <p:cNvCxnSpPr/>
           <p:nvPr/>
         </p:nvCxnSpPr>

</xml_diff>

<commit_message>
Clarify defense notation and attack scenarios
</commit_message>
<xml_diff>
--- a/deliverables/beyond-average-case-safety.pptx
+++ b/deliverables/beyond-average-case-safety.pptx
@@ -2,34 +2,35 @@
 <file path=ppt/presentation.xml><?xml version="1.0" encoding="utf-8"?>
 <p:presentation xmlns:p="http://schemas.openxmlformats.org/presentationml/2006/main">
   <p:sldMasterIdLst>
-    <p:sldMasterId xmlns:r="http://schemas.openxmlformats.org/officeDocument/2006/relationships" id="2147483648" r:id="R52288bd0786b4522"/>
+    <p:sldMasterId xmlns:r="http://schemas.openxmlformats.org/officeDocument/2006/relationships" id="2147483648" r:id="Rff5c82e6b4864122"/>
   </p:sldMasterIdLst>
   <p:notesMasterIdLst>
-    <p:notesMasterId xmlns:r="http://schemas.openxmlformats.org/officeDocument/2006/relationships" r:id="Re022d4c3fda34454"/>
+    <p:notesMasterId xmlns:r="http://schemas.openxmlformats.org/officeDocument/2006/relationships" r:id="Reaba4eaf955f449d"/>
   </p:notesMasterIdLst>
   <p:sldIdLst>
-    <p:sldId xmlns:r="http://schemas.openxmlformats.org/officeDocument/2006/relationships" id="256" r:id="R814fafc558d64f4c"/>
-    <p:sldId xmlns:r="http://schemas.openxmlformats.org/officeDocument/2006/relationships" id="257" r:id="Rb958ec18815b42a7"/>
-    <p:sldId xmlns:r="http://schemas.openxmlformats.org/officeDocument/2006/relationships" id="258" r:id="Rd0cb72c31014471b"/>
-    <p:sldId xmlns:r="http://schemas.openxmlformats.org/officeDocument/2006/relationships" id="259" r:id="R5f5e34d279e04839"/>
-    <p:sldId xmlns:r="http://schemas.openxmlformats.org/officeDocument/2006/relationships" id="260" r:id="Re42d3305b8774755"/>
-    <p:sldId xmlns:r="http://schemas.openxmlformats.org/officeDocument/2006/relationships" id="261" r:id="R1b8cbd95c7e54afe"/>
-    <p:sldId xmlns:r="http://schemas.openxmlformats.org/officeDocument/2006/relationships" id="262" r:id="R6a1198ff95e44184"/>
-    <p:sldId xmlns:r="http://schemas.openxmlformats.org/officeDocument/2006/relationships" id="263" r:id="R6fc69624b9b64839"/>
-    <p:sldId xmlns:r="http://schemas.openxmlformats.org/officeDocument/2006/relationships" id="264" r:id="R591ea47c07954d7a"/>
-    <p:sldId xmlns:r="http://schemas.openxmlformats.org/officeDocument/2006/relationships" id="265" r:id="Rdf0f83db0d6e477e"/>
-    <p:sldId xmlns:r="http://schemas.openxmlformats.org/officeDocument/2006/relationships" id="266" r:id="R9a406bd0a6f94e79"/>
-    <p:sldId xmlns:r="http://schemas.openxmlformats.org/officeDocument/2006/relationships" id="267" r:id="Rcb473682418e4a95"/>
-    <p:sldId xmlns:r="http://schemas.openxmlformats.org/officeDocument/2006/relationships" id="268" r:id="Rf256cb0b3e1f4ad5"/>
-    <p:sldId xmlns:r="http://schemas.openxmlformats.org/officeDocument/2006/relationships" id="269" r:id="Rf9c09f03eee54152"/>
-    <p:sldId xmlns:r="http://schemas.openxmlformats.org/officeDocument/2006/relationships" id="270" r:id="R067034cb86b449ca"/>
-    <p:sldId xmlns:r="http://schemas.openxmlformats.org/officeDocument/2006/relationships" id="271" r:id="R63795b4ffb7f42d9"/>
-    <p:sldId xmlns:r="http://schemas.openxmlformats.org/officeDocument/2006/relationships" id="272" r:id="R9501a0c0ba47440a"/>
-    <p:sldId xmlns:r="http://schemas.openxmlformats.org/officeDocument/2006/relationships" id="273" r:id="Rec4c2f6a45174a13"/>
-    <p:sldId xmlns:r="http://schemas.openxmlformats.org/officeDocument/2006/relationships" id="274" r:id="Rf3d0be6be927426f"/>
-    <p:sldId xmlns:r="http://schemas.openxmlformats.org/officeDocument/2006/relationships" id="275" r:id="R7ed778b24cb74e72"/>
-    <p:sldId xmlns:r="http://schemas.openxmlformats.org/officeDocument/2006/relationships" id="276" r:id="R3b4aed10fa83449f"/>
-    <p:sldId xmlns:r="http://schemas.openxmlformats.org/officeDocument/2006/relationships" id="277" r:id="Rd118349154d24477"/>
+    <p:sldId xmlns:r="http://schemas.openxmlformats.org/officeDocument/2006/relationships" id="256" r:id="R0083f9ce391f46c1"/>
+    <p:sldId xmlns:r="http://schemas.openxmlformats.org/officeDocument/2006/relationships" id="257" r:id="Rf4b0da3dc839403c"/>
+    <p:sldId xmlns:r="http://schemas.openxmlformats.org/officeDocument/2006/relationships" id="258" r:id="Re03ea39b3c214c22"/>
+    <p:sldId xmlns:r="http://schemas.openxmlformats.org/officeDocument/2006/relationships" id="259" r:id="Rffc48e8a8b164076"/>
+    <p:sldId xmlns:r="http://schemas.openxmlformats.org/officeDocument/2006/relationships" id="260" r:id="R190ec421593048c8"/>
+    <p:sldId xmlns:r="http://schemas.openxmlformats.org/officeDocument/2006/relationships" id="261" r:id="Ra1029fd875ab4b79"/>
+    <p:sldId xmlns:r="http://schemas.openxmlformats.org/officeDocument/2006/relationships" id="262" r:id="R9718d4a50d31468c"/>
+    <p:sldId xmlns:r="http://schemas.openxmlformats.org/officeDocument/2006/relationships" id="263" r:id="R0736e6aa61254e03"/>
+    <p:sldId xmlns:r="http://schemas.openxmlformats.org/officeDocument/2006/relationships" id="264" r:id="R207df8b224c14a0d"/>
+    <p:sldId xmlns:r="http://schemas.openxmlformats.org/officeDocument/2006/relationships" id="265" r:id="Rf938902809204f66"/>
+    <p:sldId xmlns:r="http://schemas.openxmlformats.org/officeDocument/2006/relationships" id="266" r:id="R8fa49adbc3b14ec6"/>
+    <p:sldId xmlns:r="http://schemas.openxmlformats.org/officeDocument/2006/relationships" id="267" r:id="R951fbe15406e4f41"/>
+    <p:sldId xmlns:r="http://schemas.openxmlformats.org/officeDocument/2006/relationships" id="268" r:id="R0d62fc8c0d0140f2"/>
+    <p:sldId xmlns:r="http://schemas.openxmlformats.org/officeDocument/2006/relationships" id="269" r:id="Rc2174a04fa114f35"/>
+    <p:sldId xmlns:r="http://schemas.openxmlformats.org/officeDocument/2006/relationships" id="270" r:id="Ra8f106a66c4d43e8"/>
+    <p:sldId xmlns:r="http://schemas.openxmlformats.org/officeDocument/2006/relationships" id="271" r:id="R7c2a11e199e04b93"/>
+    <p:sldId xmlns:r="http://schemas.openxmlformats.org/officeDocument/2006/relationships" id="272" r:id="R3a19c025c6104e8f"/>
+    <p:sldId xmlns:r="http://schemas.openxmlformats.org/officeDocument/2006/relationships" id="273" r:id="R346979d9699642c2"/>
+    <p:sldId xmlns:r="http://schemas.openxmlformats.org/officeDocument/2006/relationships" id="274" r:id="R0de70464c3fd447f"/>
+    <p:sldId xmlns:r="http://schemas.openxmlformats.org/officeDocument/2006/relationships" id="275" r:id="Rd50b86e8dd5e480a"/>
+    <p:sldId xmlns:r="http://schemas.openxmlformats.org/officeDocument/2006/relationships" id="276" r:id="R31d0c05ea7ad4ef2"/>
+    <p:sldId xmlns:r="http://schemas.openxmlformats.org/officeDocument/2006/relationships" id="277" r:id="Rdce4622e9ad941a7"/>
+    <p:sldId xmlns:r="http://schemas.openxmlformats.org/officeDocument/2006/relationships" id="278" r:id="R5a39114002304c27"/>
   </p:sldIdLst>
   <p:sldSz cx="12192000" cy="6858000"/>
   <p:notesSz cx="6858000" cy="9144000"/>
@@ -493,7 +494,7 @@
           </a:p>
           <a:p xmlns:a="http://schemas.openxmlformats.org/drawingml/2006/main">
             <a:r>
-              <a:t>"Beyond the average case" is the central shift: a defense should be judged on the hardest registered cells, the overlap of its failure modes, and whether its advantage survives adaptation and held-out transfer.</a:t>
+              <a:t>"Beyond the average case" is the central shift: a defense should be judged on the hardest registered scenarios, the overlap of its failure modes, and whether its advantage survives adaptation and held-out transfer.</a:t>
             </a:r>
           </a:p>
           <a:p xmlns:a="http://schemas.openxmlformats.org/drawingml/2006/main">
@@ -2098,6 +2099,141 @@
           </a:p>
           <a:p xmlns:a="http://schemas.openxmlformats.org/drawingml/2006/main">
             <a:r>
+              <a:t>This addendum makes two empirical hypotheses explicit rather than treating them as facts.</a:t>
+            </a:r>
+          </a:p>
+          <a:p xmlns:a="http://schemas.openxmlformats.org/drawingml/2006/main">
+            <a:r>
+              <a:t/>
+            </a:r>
+          </a:p>
+          <a:p xmlns:a="http://schemas.openxmlformats.org/drawingml/2006/main">
+            <a:r>
+              <a:t>First, rarity and severity are distinct. S(q) measures the share of total harm contributed by the worst q fraction of outcomes. CVaR instead measures average severity within that tail. A large CVaR does not by itself establish that the tail accounts for most aggregate harm.</a:t>
+            </a:r>
+          </a:p>
+          <a:p xmlns:a="http://schemas.openxmlformats.org/drawingml/2006/main">
+            <a:r>
+              <a:t/>
+            </a:r>
+          </a:p>
+          <a:p xmlns:a="http://schemas.openxmlformats.org/drawingml/2006/main">
+            <a:r>
+              <a:t>Second, layered defense is geometric only in a special case. If b_ig is the fraction of harm in scenario family g that bypasses layer i, residual harm sums family-specific losses multiplied by their bypass fractions. Independent failures with stable fractional coverage can produce multiplicative decline; nested or correlated failures can make another layer nearly redundant.</a:t>
+            </a:r>
+          </a:p>
+          <a:p xmlns:a="http://schemas.openxmlformats.org/drawingml/2006/main">
+            <a:r>
+              <a:t/>
+            </a:r>
+          </a:p>
+          <a:p xmlns:a="http://schemas.openxmlformats.org/drawingml/2006/main">
+            <a:r>
+              <a:t>The harness therefore estimates both tail concentration and matched failure overlap.</a:t>
+            </a:r>
+          </a:p>
+          <a:p xmlns:a="http://schemas.openxmlformats.org/drawingml/2006/main">
+            <a:r>
+              <a:t/>
+            </a:r>
+          </a:p>
+          <a:p xmlns:a="http://schemas.openxmlformats.org/drawingml/2006/main">
+            <a:r>
+              <a:t>[Sources]</a:t>
+            </a:r>
+          </a:p>
+          <a:p xmlns:a="http://schemas.openxmlformats.org/drawingml/2006/main">
+            <a:r>
+              <a:t>- paper/main.tex</a:t>
+            </a:r>
+          </a:p>
+          <a:p xmlns:a="http://schemas.openxmlformats.org/drawingml/2006/main">
+            <a:r>
+              <a:t>- Rockafellar, R. T., and Uryasev, S. Optimization of Conditional Value-at-Risk, 2000.</a:t>
+            </a:r>
+          </a:p>
+          <a:p xmlns:a="http://schemas.openxmlformats.org/drawingml/2006/main">
+            <a:r>
+              <a:t>[/Sources]</a:t>
+            </a:r>
+          </a:p>
+        </p:txBody>
+      </p:sp>
+      <p:sp>
+        <p:nvSpPr>
+          <p:cNvPr id="4" name="Slide Number Placeholder 3"/>
+          <p:cNvSpPr>
+            <a:spLocks xmlns:a="http://schemas.openxmlformats.org/drawingml/2006/main" noGrp="1"/>
+          </p:cNvSpPr>
+          <p:nvPr>
+            <p:ph type="sldNum" idx="5"/>
+          </p:nvPr>
+        </p:nvSpPr>
+        <p:spPr/>
+        <p:txBody>
+          <a:bodyPr xmlns:a="http://schemas.openxmlformats.org/drawingml/2006/main"/>
+          <a:lstStyle xmlns:a="http://schemas.openxmlformats.org/drawingml/2006/main"/>
+          <a:p xmlns:a="http://schemas.openxmlformats.org/drawingml/2006/main"/>
+        </p:txBody>
+      </p:sp>
+    </p:spTree>
+  </p:cSld>
+  <p:clrMapOvr>
+    <a:masterClrMapping xmlns:a="http://schemas.openxmlformats.org/drawingml/2006/main"/>
+  </p:clrMapOvr>
+</p:notes>
+</file>
+
+<file path=ppt/notesSlides/notesSlide23.xml><?xml version="1.0" encoding="utf-8"?>
+<p:notes xmlns:p="http://schemas.openxmlformats.org/presentationml/2006/main">
+  <p:cSld>
+    <p:spTree>
+      <p:nvGrpSpPr>
+        <p:cNvPr id="1" name=""/>
+        <p:cNvGrpSpPr/>
+        <p:nvPr/>
+      </p:nvGrpSpPr>
+      <p:grpSpPr>
+        <a:xfrm xmlns:a="http://schemas.openxmlformats.org/drawingml/2006/main"/>
+      </p:grpSpPr>
+      <p:sp>
+        <p:nvSpPr>
+          <p:cNvPr id="2" name="Slide Image Placeholder 1"/>
+          <p:cNvSpPr>
+            <a:spLocks xmlns:a="http://schemas.openxmlformats.org/drawingml/2006/main" noGrp="1"/>
+          </p:cNvSpPr>
+          <p:nvPr>
+            <p:ph type="sldImg" idx="0"/>
+          </p:nvPr>
+        </p:nvSpPr>
+        <p:spPr/>
+      </p:sp>
+      <p:sp>
+        <p:nvSpPr>
+          <p:cNvPr id="3" name="Notes Placeholder 2"/>
+          <p:cNvSpPr>
+            <a:spLocks xmlns:a="http://schemas.openxmlformats.org/drawingml/2006/main" noGrp="1"/>
+          </p:cNvSpPr>
+          <p:nvPr>
+            <p:ph type="body" idx="1"/>
+          </p:nvPr>
+        </p:nvSpPr>
+        <p:spPr/>
+        <p:txBody>
+          <a:bodyPr xmlns:a="http://schemas.openxmlformats.org/drawingml/2006/main"/>
+          <a:lstStyle xmlns:a="http://schemas.openxmlformats.org/drawingml/2006/main"/>
+          <a:p xmlns:a="http://schemas.openxmlformats.org/drawingml/2006/main">
+            <a:r>
+              <a:t>PRESENTER NOTES</a:t>
+            </a:r>
+          </a:p>
+          <a:p xmlns:a="http://schemas.openxmlformats.org/drawingml/2006/main">
+            <a:r>
+              <a:t/>
+            </a:r>
+          </a:p>
+          <a:p xmlns:a="http://schemas.openxmlformats.org/drawingml/2006/main">
+            <a:r>
               <a:t>Fairlead is a Rust inference gateway and compute router. It does not run inference: vLLM owns model loading, GPU execution, caching, and token streaming. Fairlead chooses the backend and applies routing, health, retry, resource, pool, and admission policy.</a:t>
             </a:r>
           </a:p>
@@ -2238,7 +2374,7 @@
           </a:p>
           <a:p xmlns:a="http://schemas.openxmlformats.org/drawingml/2006/main">
             <a:r>
-              <a:t>This motivates conditional tail evaluation. We do not average a catastrophic cell together with many easy cells.</a:t>
+              <a:t>This motivates conditional tail evaluation. We do not average a catastrophic scenario together with many easy scenarios.</a:t>
             </a:r>
           </a:p>
           <a:p xmlns:a="http://schemas.openxmlformats.org/drawingml/2006/main">
@@ -2458,7 +2594,7 @@
           </a:p>
           <a:p xmlns:a="http://schemas.openxmlformats.org/drawingml/2006/main">
             <a:r>
-              <a:t>A trajectory is the full team execution, so it is the unit of security. An attack cell fixes the conditions under which loss is measured. A defense stack is the complete deployed combination, not a list of components considered separately. Tail risk focuses on the severe 10% within a cell. Failure diversity asks whether two defenses fail on different matched opportunities.</a:t>
+              <a:t>A trajectory is the full team execution, so it is the unit of security. An attack scenario fixes the conditions under which loss is measured. A defense stack is the complete deployed combination, not a list of components considered separately.</a:t>
             </a:r>
           </a:p>
           <a:p xmlns:a="http://schemas.openxmlformats.org/drawingml/2006/main">
@@ -2468,12 +2604,37 @@
           </a:p>
           <a:p xmlns:a="http://schemas.openxmlformats.org/drawingml/2006/main">
             <a:r>
+              <a:t>Conditional Value at Risk, abbreviated CVaR, summarizes the upper loss tail. In this deck CVaR10% means the arithmetic mean loss among the worst 10% of trajectories. The 10% convention must be stated because some literature instead indexes the same tail using a 90% confidence level.</a:t>
+            </a:r>
+          </a:p>
+          <a:p xmlns:a="http://schemas.openxmlformats.org/drawingml/2006/main">
+            <a:r>
+              <a:t/>
+            </a:r>
+          </a:p>
+          <a:p xmlns:a="http://schemas.openxmlformats.org/drawingml/2006/main">
+            <a:r>
+              <a:t>Failure diversity asks whether two defenses fail on different matched opportunities.</a:t>
+            </a:r>
+          </a:p>
+          <a:p xmlns:a="http://schemas.openxmlformats.org/drawingml/2006/main">
+            <a:r>
+              <a:t/>
+            </a:r>
+          </a:p>
+          <a:p xmlns:a="http://schemas.openxmlformats.org/drawingml/2006/main">
+            <a:r>
               <a:t>[Sources]</a:t>
             </a:r>
           </a:p>
           <a:p xmlns:a="http://schemas.openxmlformats.org/drawingml/2006/main">
             <a:r>
               <a:t>- paper/main.tex</a:t>
+            </a:r>
+          </a:p>
+          <a:p xmlns:a="http://schemas.openxmlformats.org/drawingml/2006/main">
+            <a:r>
+              <a:t>- Rockafellar, R. T., and Uryasev, S. Optimization of Conditional Value-at-Risk, 2000.</a:t>
             </a:r>
           </a:p>
           <a:p xmlns:a="http://schemas.openxmlformats.org/drawingml/2006/main">
@@ -2668,7 +2829,7 @@
           </a:p>
           <a:p xmlns:a="http://schemas.openxmlformats.org/drawingml/2006/main">
             <a:r>
-              <a:t>The selector minimizes an uncertainty-adjusted worst-cell tail loss subject to utility. Γ measures whether component bypass sets overlap. BR makes the attacker stack-aware.</a:t>
+              <a:t>The slide uses named notation for readability. D is the complete defense stack and s is one registered attack scenario.</a:t>
             </a:r>
           </a:p>
           <a:p xmlns:a="http://schemas.openxmlformats.org/drawingml/2006/main">
@@ -2678,7 +2839,27 @@
           </a:p>
           <a:p xmlns:a="http://schemas.openxmlformats.org/drawingml/2006/main">
             <a:r>
-              <a:t>The novel part is the conjunction, not CVaR by itself: tail risk plus failure diversity plus adaptive retesting.</a:t>
+              <a:t>TailMean10% is the slide's plain-language name for CVaR10%: average loss among the worst 10% of stochastic trajectories. Upper95% is the slide's plain-language name for a 95% upper confidence bound, abbreviated UCB95%: an estimate plus a method-specific uncertainty margin constructed to conservatively cover the unknown population value.</a:t>
+            </a:r>
+          </a:p>
+          <a:p xmlns:a="http://schemas.openxmlformats.org/drawingml/2006/main">
+            <a:r>
+              <a:t/>
+            </a:r>
+          </a:p>
+          <a:p xmlns:a="http://schemas.openxmlformats.org/drawingml/2006/main">
+            <a:r>
+              <a:t>The selector first removes defenses that miss the utility floor. Among the remaining defenses it minimizes the largest cautious tail-loss estimate across registered scenarios, using validation data only. After selection, separate experiments test failure diversity, adaptive best response, and held-out transfer.</a:t>
+            </a:r>
+          </a:p>
+          <a:p xmlns:a="http://schemas.openxmlformats.org/drawingml/2006/main">
+            <a:r>
+              <a:t/>
+            </a:r>
+          </a:p>
+          <a:p xmlns:a="http://schemas.openxmlformats.org/drawingml/2006/main">
+            <a:r>
+              <a:t>The manuscript retains standard notation so the result can be compared with the literature, but it now defines CVaR, UCB, the confidence level, and every symbol immediately.</a:t>
             </a:r>
           </a:p>
           <a:p xmlns:a="http://schemas.openxmlformats.org/drawingml/2006/main">
@@ -2996,7 +3177,7 @@
   </p:cSld>
   <p:clrMap bg1="lt1" tx1="dk1" bg2="lt2" tx2="dk2" accent1="accent1" accent2="accent2" accent3="accent3" accent4="accent4" accent5="accent5" accent6="accent6" hlink="hlink" folHlink="folHlink"/>
   <p:sldLayoutIdLst>
-    <p:sldLayoutId xmlns:r="http://schemas.openxmlformats.org/officeDocument/2006/relationships" id="2147483649" r:id="Rdca0ec23689b4c70"/>
+    <p:sldLayoutId xmlns:r="http://schemas.openxmlformats.org/officeDocument/2006/relationships" id="2147483649" r:id="R6358eb4dcda34569"/>
   </p:sldLayoutIdLst>
   <p:txStyles>
     <p:titleStyle>
@@ -5200,7 +5381,29 @@
                 <a:ea typeface="Helvetica Neue"/>
                 <a:cs typeface="Helvetica Neue"/>
               </a:rPr>
-              <a:t>Deterministic failure simulator; no LLM agents. Registered cells, stacks, and known fixtures.</a:t>
+              <a:t>Deterministic failure simulator; no LLM agents. </a:t>
+            </a:r>
+            <a:r>
+              <a:rPr sz="1350" b="0">
+                <a:solidFill>
+                  <a:srgbClr val="5D636D"/>
+                </a:solidFill>
+                <a:latin typeface="Helvetica Neue"/>
+                <a:ea typeface="Helvetica Neue"/>
+                <a:cs typeface="Helvetica Neue"/>
+              </a:rPr>
+              <a:t>Registered scenarios</a:t>
+            </a:r>
+            <a:r>
+              <a:rPr sz="1350" b="0">
+                <a:solidFill>
+                  <a:srgbClr val="5D636D"/>
+                </a:solidFill>
+                <a:latin typeface="Helvetica Neue"/>
+                <a:ea typeface="Helvetica Neue"/>
+                <a:cs typeface="Helvetica Neue"/>
+              </a:rPr>
+              <a:t>, stacks, and known fixtures.</a:t>
             </a:r>
           </a:p>
         </p:txBody>
@@ -7332,7 +7535,7 @@
         </p:xfrm>
         <a:graphic xmlns:a="http://schemas.openxmlformats.org/drawingml/2006/main">
           <a:graphicData uri="http://schemas.openxmlformats.org/drawingml/2006/chart">
-            <c:chart xmlns:r="http://schemas.openxmlformats.org/officeDocument/2006/relationships" xmlns:c="http://schemas.openxmlformats.org/drawingml/2006/chart" r:id="Rb68591f74d664dd3"/>
+            <c:chart xmlns:r="http://schemas.openxmlformats.org/officeDocument/2006/relationships" xmlns:c="http://schemas.openxmlformats.org/drawingml/2006/chart" r:id="Re2d3e03dc5bd4125"/>
           </a:graphicData>
         </a:graphic>
       </p:graphicFrame>
@@ -7857,7 +8060,7 @@
         </p:xfrm>
         <a:graphic xmlns:a="http://schemas.openxmlformats.org/drawingml/2006/main">
           <a:graphicData uri="http://schemas.openxmlformats.org/drawingml/2006/chart">
-            <c:chart xmlns:r="http://schemas.openxmlformats.org/officeDocument/2006/relationships" xmlns:c="http://schemas.openxmlformats.org/drawingml/2006/chart" r:id="R8319cc8d30b74531"/>
+            <c:chart xmlns:r="http://schemas.openxmlformats.org/officeDocument/2006/relationships" xmlns:c="http://schemas.openxmlformats.org/drawingml/2006/chart" r:id="Rfbe77fbf46a446ae"/>
           </a:graphicData>
         </a:graphic>
       </p:graphicFrame>
@@ -8325,7 +8528,7 @@
         </p:xfrm>
         <a:graphic xmlns:a="http://schemas.openxmlformats.org/drawingml/2006/main">
           <a:graphicData uri="http://schemas.openxmlformats.org/drawingml/2006/chart">
-            <c:chart xmlns:r="http://schemas.openxmlformats.org/officeDocument/2006/relationships" xmlns:c="http://schemas.openxmlformats.org/drawingml/2006/chart" r:id="R434525ad53d547d8"/>
+            <c:chart xmlns:r="http://schemas.openxmlformats.org/officeDocument/2006/relationships" xmlns:c="http://schemas.openxmlformats.org/drawingml/2006/chart" r:id="Rf1582404f7984cc1"/>
           </a:graphicData>
         </a:graphic>
       </p:graphicFrame>
@@ -9185,7 +9388,7 @@
       </p:sp>
       <p:cxnSp>
         <p:nvCxnSpPr>
-          <p:cNvPr id="168" name=""/>
+          <p:cNvPr id="216" name=""/>
           <p:cNvCxnSpPr/>
           <p:nvPr/>
         </p:nvCxnSpPr>
@@ -9889,7 +10092,29 @@
                 <a:ea typeface="Helvetica Neue"/>
                 <a:cs typeface="Helvetica Neue"/>
               </a:rPr>
-              <a:t>0.93 vs 1.00 worst-cell CVaR</a:t>
+              <a:t>0.93 vs 1.00 </a:t>
+            </a:r>
+            <a:r>
+              <a:rPr sz="1350" b="0">
+                <a:solidFill>
+                  <a:srgbClr val="5D636D"/>
+                </a:solidFill>
+                <a:latin typeface="Helvetica Neue"/>
+                <a:ea typeface="Helvetica Neue"/>
+                <a:cs typeface="Helvetica Neue"/>
+              </a:rPr>
+              <a:t>worst-scenario</a:t>
+            </a:r>
+            <a:r>
+              <a:rPr sz="1350" b="0">
+                <a:solidFill>
+                  <a:srgbClr val="5D636D"/>
+                </a:solidFill>
+                <a:latin typeface="Helvetica Neue"/>
+                <a:ea typeface="Helvetica Neue"/>
+                <a:cs typeface="Helvetica Neue"/>
+              </a:rPr>
+              <a:t> CVaR</a:t>
             </a:r>
           </a:p>
         </p:txBody>
@@ -10700,7 +10925,7 @@
         </p:xfrm>
         <a:graphic xmlns:a="http://schemas.openxmlformats.org/drawingml/2006/main">
           <a:graphicData uri="http://schemas.openxmlformats.org/drawingml/2006/chart">
-            <c:chart xmlns:r="http://schemas.openxmlformats.org/officeDocument/2006/relationships" xmlns:c="http://schemas.openxmlformats.org/drawingml/2006/chart" r:id="R0f4f2e4dd2244146"/>
+            <c:chart xmlns:r="http://schemas.openxmlformats.org/officeDocument/2006/relationships" xmlns:c="http://schemas.openxmlformats.org/drawingml/2006/chart" r:id="Rdfa6ebc4f9984a89"/>
           </a:graphicData>
         </a:graphic>
       </p:graphicFrame>
@@ -14088,7 +14313,29 @@
                 <a:ea typeface="Helvetica Neue"/>
                 <a:cs typeface="Helvetica Neue"/>
               </a:rPr>
-              <a:t>Qualify a distinct 7–9B model, then open single-axis and compound cells once.</a:t>
+              <a:t>Qualify a distinct 7–9B model, then open single-axis and </a:t>
+            </a:r>
+            <a:r>
+              <a:rPr sz="1425" b="0">
+                <a:solidFill>
+                  <a:srgbClr val="5D636D"/>
+                </a:solidFill>
+                <a:latin typeface="Helvetica Neue"/>
+                <a:ea typeface="Helvetica Neue"/>
+                <a:cs typeface="Helvetica Neue"/>
+              </a:rPr>
+              <a:t>compound attack scenarios</a:t>
+            </a:r>
+            <a:r>
+              <a:rPr sz="1425" b="0">
+                <a:solidFill>
+                  <a:srgbClr val="5D636D"/>
+                </a:solidFill>
+                <a:latin typeface="Helvetica Neue"/>
+                <a:ea typeface="Helvetica Neue"/>
+                <a:cs typeface="Helvetica Neue"/>
+              </a:rPr>
+              <a:t> once.</a:t>
             </a:r>
           </a:p>
         </p:txBody>
@@ -14630,7 +14877,7 @@
       </p:sp>
       <p:cxnSp>
         <p:nvCxnSpPr>
-          <p:cNvPr id="168" name=""/>
+          <p:cNvPr id="216" name=""/>
           <p:cNvCxnSpPr/>
           <p:nvPr/>
         </p:nvCxnSpPr>
@@ -15964,10 +16211,10 @@
       </p:grpSpPr>
       <p:sp>
         <p:nvSpPr>
-          <p:cNvPr id="17" name="">
-            <a:extLst xmlns:a="http://schemas.openxmlformats.org/drawingml/2006/main">
-              <a:ext uri="{FF2B5EF4-FFF2-40B4-BE49-F238E27FC236}">
-                <a16:creationId xmlns:a16="http://schemas.microsoft.com/office/drawing/2014/main" id="{51131C71-3FBE-45E9-B711-EDD3B75D35EC}"/>
+          <p:cNvPr id="11" name="">
+            <a:extLst xmlns:a="http://schemas.openxmlformats.org/drawingml/2006/main">
+              <a:ext uri="{FF2B5EF4-FFF2-40B4-BE49-F238E27FC236}">
+                <a16:creationId xmlns:a16="http://schemas.microsoft.com/office/drawing/2014/main" id="{54F5E479-F304-43E0-9DD7-6ECE0BB1B711}"/>
               </a:ext>
             </a:extLst>
           </p:cNvPr>
@@ -16021,10 +16268,10 @@
       </p:sp>
       <p:sp>
         <p:nvSpPr>
-          <p:cNvPr id="2" name="slide-6-title">
-            <a:extLst xmlns:a="http://schemas.openxmlformats.org/drawingml/2006/main">
-              <a:ext uri="{FF2B5EF4-FFF2-40B4-BE49-F238E27FC236}">
-                <a16:creationId xmlns:a16="http://schemas.microsoft.com/office/drawing/2014/main" id="{CA9E1DB2-44DE-4718-AAFD-A4928026059A}"/>
+          <p:cNvPr id="2" name="slide-4-title">
+            <a:extLst xmlns:a="http://schemas.openxmlformats.org/drawingml/2006/main">
+              <a:ext uri="{FF2B5EF4-FFF2-40B4-BE49-F238E27FC236}">
+                <a16:creationId xmlns:a16="http://schemas.microsoft.com/office/drawing/2014/main" id="{75D1F63C-9327-4B72-9129-8688169032A5}"/>
               </a:ext>
             </a:extLst>
           </p:cNvPr>
@@ -16071,7 +16318,7 @@
                 <a:ea typeface="Helvetica Neue"/>
                 <a:cs typeface="Helvetica Neue"/>
               </a:rPr>
-              <a:t>Fairlead operationalizes future multi-agent evaluations</a:t>
+              <a:t>Tail concentration and layer gains must be tested</a:t>
             </a:r>
           </a:p>
         </p:txBody>
@@ -16081,7 +16328,7 @@
           <p:cNvPr id="3" name="">
             <a:extLst xmlns:a="http://schemas.openxmlformats.org/drawingml/2006/main">
               <a:ext uri="{FF2B5EF4-FFF2-40B4-BE49-F238E27FC236}">
-                <a16:creationId xmlns:a16="http://schemas.microsoft.com/office/drawing/2014/main" id="{C0F74CF4-81B3-48FE-9AEA-F5440C2341C6}"/>
+                <a16:creationId xmlns:a16="http://schemas.microsoft.com/office/drawing/2014/main" id="{C457683D-8C23-4AC2-AA5B-ED38921DB861}"/>
               </a:ext>
             </a:extLst>
           </p:cNvPr>
@@ -16138,19 +16385,19 @@
           <p:cNvPr id="4" name="">
             <a:extLst xmlns:a="http://schemas.openxmlformats.org/drawingml/2006/main">
               <a:ext uri="{FF2B5EF4-FFF2-40B4-BE49-F238E27FC236}">
-                <a16:creationId xmlns:a16="http://schemas.microsoft.com/office/drawing/2014/main" id="{C317BDED-2BE1-4928-97F6-FC2F2BA93993}"/>
-              </a:ext>
-            </a:extLst>
-          </p:cNvPr>
-          <p:cNvSpPr>
-            <a:spLocks xmlns:a="http://schemas.openxmlformats.org/drawingml/2006/main" noGrp="1"/>
-          </p:cNvSpPr>
-          <p:nvPr/>
-        </p:nvSpPr>
-        <p:spPr>
-          <a:xfrm xmlns:a="http://schemas.openxmlformats.org/drawingml/2006/main">
-            <a:off x="400050" y="1809750"/>
-            <a:ext cx="3476625" cy="3333750"/>
+                <a16:creationId xmlns:a16="http://schemas.microsoft.com/office/drawing/2014/main" id="{A5BDC0CE-0622-4406-9B4F-98CF1B3429E7}"/>
+              </a:ext>
+            </a:extLst>
+          </p:cNvPr>
+          <p:cNvSpPr>
+            <a:spLocks xmlns:a="http://schemas.openxmlformats.org/drawingml/2006/main" noGrp="1"/>
+          </p:cNvSpPr>
+          <p:nvPr/>
+        </p:nvSpPr>
+        <p:spPr>
+          <a:xfrm xmlns:a="http://schemas.openxmlformats.org/drawingml/2006/main">
+            <a:off x="400050" y="1543050"/>
+            <a:ext cx="5429250" cy="4286250"/>
           </a:xfrm>
           <a:prstGeom xmlns:a="http://schemas.openxmlformats.org/drawingml/2006/main" prst="rect">
             <a:avLst/>
@@ -16169,6 +16416,700 @@
           <p:cNvPr id="5" name="">
             <a:extLst xmlns:a="http://schemas.openxmlformats.org/drawingml/2006/main">
               <a:ext uri="{FF2B5EF4-FFF2-40B4-BE49-F238E27FC236}">
+                <a16:creationId xmlns:a16="http://schemas.microsoft.com/office/drawing/2014/main" id="{D06CD06E-8FC1-495C-9B93-0E6F7A30042C}"/>
+              </a:ext>
+            </a:extLst>
+          </p:cNvPr>
+          <p:cNvSpPr>
+            <a:spLocks xmlns:a="http://schemas.openxmlformats.org/drawingml/2006/main" noGrp="1"/>
+          </p:cNvSpPr>
+          <p:nvPr/>
+        </p:nvSpPr>
+        <p:spPr>
+          <a:xfrm xmlns:a="http://schemas.openxmlformats.org/drawingml/2006/main">
+            <a:off x="6191250" y="1543050"/>
+            <a:ext cx="5600700" cy="4286250"/>
+          </a:xfrm>
+          <a:prstGeom xmlns:a="http://schemas.openxmlformats.org/drawingml/2006/main" prst="rect">
+            <a:avLst/>
+          </a:prstGeom>
+          <a:solidFill xmlns:a="http://schemas.openxmlformats.org/drawingml/2006/main">
+            <a:srgbClr val="D0EDFA"/>
+          </a:solidFill>
+          <a:ln xmlns:a="http://schemas.openxmlformats.org/drawingml/2006/main" w="0">
+            <a:noFill/>
+            <a:prstDash val="solid"/>
+          </a:ln>
+        </p:spPr>
+      </p:sp>
+      <p:sp>
+        <p:nvSpPr>
+          <p:cNvPr id="6" name="">
+            <a:extLst xmlns:a="http://schemas.openxmlformats.org/drawingml/2006/main">
+              <a:ext uri="{FF2B5EF4-FFF2-40B4-BE49-F238E27FC236}">
+                <a16:creationId xmlns:a16="http://schemas.microsoft.com/office/drawing/2014/main" id="{04363782-92FE-4FEB-9BA8-546B59559F92}"/>
+              </a:ext>
+            </a:extLst>
+          </p:cNvPr>
+          <p:cNvSpPr>
+            <a:spLocks xmlns:a="http://schemas.openxmlformats.org/drawingml/2006/main" noGrp="1"/>
+          </p:cNvSpPr>
+          <p:nvPr/>
+        </p:nvSpPr>
+        <p:spPr>
+          <a:xfrm xmlns:a="http://schemas.openxmlformats.org/drawingml/2006/main">
+            <a:off x="685800" y="1857375"/>
+            <a:ext cx="4476750" cy="381000"/>
+          </a:xfrm>
+          <a:prstGeom xmlns:a="http://schemas.openxmlformats.org/drawingml/2006/main" prst="rect">
+            <a:avLst/>
+          </a:prstGeom>
+          <a:noFill xmlns:a="http://schemas.openxmlformats.org/drawingml/2006/main"/>
+          <a:ln xmlns:a="http://schemas.openxmlformats.org/drawingml/2006/main" w="0">
+            <a:noFill/>
+            <a:prstDash val="solid"/>
+          </a:ln>
+        </p:spPr>
+        <p:txBody>
+          <a:bodyPr xmlns:a="http://schemas.openxmlformats.org/drawingml/2006/main" anchor="t"/>
+          <a:lstStyle xmlns:a="http://schemas.openxmlformats.org/drawingml/2006/main"/>
+          <a:p xmlns:a="http://schemas.openxmlformats.org/drawingml/2006/main">
+            <a:pPr algn="l">
+              <a:buNone/>
+              <a:defRPr sz="2100" b="1">
+                <a:solidFill>
+                  <a:srgbClr val="000000"/>
+                </a:solidFill>
+                <a:latin typeface="Helvetica Neue"/>
+                <a:ea typeface="Helvetica Neue"/>
+                <a:cs typeface="Helvetica Neue"/>
+              </a:defRPr>
+            </a:pPr>
+            <a:r>
+              <a:rPr sz="2100" b="1">
+                <a:solidFill>
+                  <a:srgbClr val="000000"/>
+                </a:solidFill>
+                <a:latin typeface="Helvetica Neue"/>
+                <a:ea typeface="Helvetica Neue"/>
+                <a:cs typeface="Helvetica Neue"/>
+              </a:rPr>
+              <a:t>Tail concentration</a:t>
+            </a:r>
+          </a:p>
+        </p:txBody>
+      </p:sp>
+      <p:sp>
+        <p:nvSpPr>
+          <p:cNvPr id="7" name="">
+            <a:extLst xmlns:a="http://schemas.openxmlformats.org/drawingml/2006/main">
+              <a:ext uri="{FF2B5EF4-FFF2-40B4-BE49-F238E27FC236}">
+                <a16:creationId xmlns:a16="http://schemas.microsoft.com/office/drawing/2014/main" id="{57764050-A6DA-4B46-82A2-CAB2EC10E2FA}"/>
+              </a:ext>
+            </a:extLst>
+          </p:cNvPr>
+          <p:cNvSpPr>
+            <a:spLocks xmlns:a="http://schemas.openxmlformats.org/drawingml/2006/main" noGrp="1"/>
+          </p:cNvSpPr>
+          <p:nvPr/>
+        </p:nvSpPr>
+        <p:spPr>
+          <a:xfrm xmlns:a="http://schemas.openxmlformats.org/drawingml/2006/main">
+            <a:off x="685800" y="2476500"/>
+            <a:ext cx="4667250" cy="2476500"/>
+          </a:xfrm>
+          <a:prstGeom xmlns:a="http://schemas.openxmlformats.org/drawingml/2006/main" prst="rect">
+            <a:avLst/>
+          </a:prstGeom>
+          <a:noFill xmlns:a="http://schemas.openxmlformats.org/drawingml/2006/main"/>
+          <a:ln xmlns:a="http://schemas.openxmlformats.org/drawingml/2006/main" w="0">
+            <a:noFill/>
+            <a:prstDash val="solid"/>
+          </a:ln>
+        </p:spPr>
+        <p:txBody>
+          <a:bodyPr xmlns:a="http://schemas.openxmlformats.org/drawingml/2006/main" anchor="t"/>
+          <a:lstStyle xmlns:a="http://schemas.openxmlformats.org/drawingml/2006/main"/>
+          <a:p xmlns:a="http://schemas.openxmlformats.org/drawingml/2006/main">
+            <a:pPr algn="l">
+              <a:buNone/>
+              <a:defRPr sz="1650" b="0">
+                <a:solidFill>
+                  <a:srgbClr val="5D636D"/>
+                </a:solidFill>
+                <a:latin typeface="Helvetica Neue"/>
+                <a:ea typeface="Helvetica Neue"/>
+                <a:cs typeface="Helvetica Neue"/>
+              </a:defRPr>
+            </a:pPr>
+            <a:r>
+              <a:rPr sz="1650" b="0">
+                <a:solidFill>
+                  <a:srgbClr val="5D636D"/>
+                </a:solidFill>
+                <a:latin typeface="Helvetica Neue"/>
+                <a:ea typeface="Helvetica Neue"/>
+                <a:cs typeface="Helvetica Neue"/>
+              </a:rPr>
+              <a:t>• Top-q harm share:</a:t>
+            </a:r>
+          </a:p>
+          <a:p xmlns:a="http://schemas.openxmlformats.org/drawingml/2006/main">
+            <a:pPr algn="l">
+              <a:buNone/>
+              <a:defRPr sz="1650" b="0">
+                <a:solidFill>
+                  <a:srgbClr val="5D636D"/>
+                </a:solidFill>
+                <a:latin typeface="Helvetica Neue"/>
+                <a:ea typeface="Helvetica Neue"/>
+                <a:cs typeface="Helvetica Neue"/>
+              </a:defRPr>
+            </a:pPr>
+            <a:r>
+              <a:rPr sz="1650" b="0">
+                <a:solidFill>
+                  <a:srgbClr val="5D636D"/>
+                </a:solidFill>
+                <a:latin typeface="Helvetica Neue"/>
+                <a:ea typeface="Helvetica Neue"/>
+                <a:cs typeface="Helvetica Neue"/>
+              </a:rPr>
+              <a:t>  S(q) = E[L * 1{L &gt;= VaR_(1-q)}] / E[L]</a:t>
+            </a:r>
+          </a:p>
+          <a:p xmlns:a="http://schemas.openxmlformats.org/drawingml/2006/main">
+            <a:pPr algn="l">
+              <a:buNone/>
+              <a:defRPr sz="1650" b="0">
+                <a:solidFill>
+                  <a:srgbClr val="5D636D"/>
+                </a:solidFill>
+                <a:latin typeface="Helvetica Neue"/>
+                <a:ea typeface="Helvetica Neue"/>
+                <a:cs typeface="Helvetica Neue"/>
+              </a:defRPr>
+            </a:pPr>
+            <a:r>
+              <a:rPr sz="1650" b="0">
+                <a:solidFill>
+                  <a:srgbClr val="5D636D"/>
+                </a:solidFill>
+                <a:latin typeface="Helvetica Neue"/>
+                <a:ea typeface="Helvetica Neue"/>
+                <a:cs typeface="Helvetica Neue"/>
+              </a:rPr>
+              <a:t>• Measures the fraction of total harm in the worst q outcomes.</a:t>
+            </a:r>
+          </a:p>
+          <a:p xmlns:a="http://schemas.openxmlformats.org/drawingml/2006/main">
+            <a:pPr algn="l">
+              <a:buNone/>
+              <a:defRPr sz="1650" b="0">
+                <a:solidFill>
+                  <a:srgbClr val="5D636D"/>
+                </a:solidFill>
+                <a:latin typeface="Helvetica Neue"/>
+                <a:ea typeface="Helvetica Neue"/>
+                <a:cs typeface="Helvetica Neue"/>
+              </a:defRPr>
+            </a:pPr>
+            <a:r>
+              <a:rPr sz="1650" b="0">
+                <a:solidFill>
+                  <a:srgbClr val="5D636D"/>
+                </a:solidFill>
+                <a:latin typeface="Helvetica Neue"/>
+                <a:ea typeface="Helvetica Neue"/>
+                <a:cs typeface="Helvetica Neue"/>
+              </a:rPr>
+              <a:t>• CVaR measures tail severity; it does not prove that the tail dominates.</a:t>
+            </a:r>
+          </a:p>
+        </p:txBody>
+      </p:sp>
+      <p:sp>
+        <p:nvSpPr>
+          <p:cNvPr id="8" name="">
+            <a:extLst xmlns:a="http://schemas.openxmlformats.org/drawingml/2006/main">
+              <a:ext uri="{FF2B5EF4-FFF2-40B4-BE49-F238E27FC236}">
+                <a16:creationId xmlns:a16="http://schemas.microsoft.com/office/drawing/2014/main" id="{B775A0DB-A5FB-4312-BFF3-AD6BAB917018}"/>
+              </a:ext>
+            </a:extLst>
+          </p:cNvPr>
+          <p:cNvSpPr>
+            <a:spLocks xmlns:a="http://schemas.openxmlformats.org/drawingml/2006/main" noGrp="1"/>
+          </p:cNvSpPr>
+          <p:nvPr/>
+        </p:nvSpPr>
+        <p:spPr>
+          <a:xfrm xmlns:a="http://schemas.openxmlformats.org/drawingml/2006/main">
+            <a:off x="6496050" y="1857375"/>
+            <a:ext cx="4762500" cy="381000"/>
+          </a:xfrm>
+          <a:prstGeom xmlns:a="http://schemas.openxmlformats.org/drawingml/2006/main" prst="rect">
+            <a:avLst/>
+          </a:prstGeom>
+          <a:noFill xmlns:a="http://schemas.openxmlformats.org/drawingml/2006/main"/>
+          <a:ln xmlns:a="http://schemas.openxmlformats.org/drawingml/2006/main" w="0">
+            <a:noFill/>
+            <a:prstDash val="solid"/>
+          </a:ln>
+        </p:spPr>
+        <p:txBody>
+          <a:bodyPr xmlns:a="http://schemas.openxmlformats.org/drawingml/2006/main" anchor="t"/>
+          <a:lstStyle xmlns:a="http://schemas.openxmlformats.org/drawingml/2006/main"/>
+          <a:p xmlns:a="http://schemas.openxmlformats.org/drawingml/2006/main">
+            <a:pPr algn="l">
+              <a:buNone/>
+              <a:defRPr sz="2100" b="1">
+                <a:solidFill>
+                  <a:srgbClr val="3D8DFF"/>
+                </a:solidFill>
+                <a:latin typeface="Helvetica Neue"/>
+                <a:ea typeface="Helvetica Neue"/>
+                <a:cs typeface="Helvetica Neue"/>
+              </a:defRPr>
+            </a:pPr>
+            <a:r>
+              <a:rPr sz="2100" b="1">
+                <a:solidFill>
+                  <a:srgbClr val="3D8DFF"/>
+                </a:solidFill>
+                <a:latin typeface="Helvetica Neue"/>
+                <a:ea typeface="Helvetica Neue"/>
+                <a:cs typeface="Helvetica Neue"/>
+              </a:rPr>
+              <a:t>Layered harm reduction</a:t>
+            </a:r>
+          </a:p>
+        </p:txBody>
+      </p:sp>
+      <p:sp>
+        <p:nvSpPr>
+          <p:cNvPr id="9" name="">
+            <a:extLst xmlns:a="http://schemas.openxmlformats.org/drawingml/2006/main">
+              <a:ext uri="{FF2B5EF4-FFF2-40B4-BE49-F238E27FC236}">
+                <a16:creationId xmlns:a16="http://schemas.microsoft.com/office/drawing/2014/main" id="{E64D6E4E-7DEC-485C-B4D4-00B4FD5E6370}"/>
+              </a:ext>
+            </a:extLst>
+          </p:cNvPr>
+          <p:cNvSpPr>
+            <a:spLocks xmlns:a="http://schemas.openxmlformats.org/drawingml/2006/main" noGrp="1"/>
+          </p:cNvSpPr>
+          <p:nvPr/>
+        </p:nvSpPr>
+        <p:spPr>
+          <a:xfrm xmlns:a="http://schemas.openxmlformats.org/drawingml/2006/main">
+            <a:off x="6496050" y="2476500"/>
+            <a:ext cx="4762500" cy="2857500"/>
+          </a:xfrm>
+          <a:prstGeom xmlns:a="http://schemas.openxmlformats.org/drawingml/2006/main" prst="rect">
+            <a:avLst/>
+          </a:prstGeom>
+          <a:noFill xmlns:a="http://schemas.openxmlformats.org/drawingml/2006/main"/>
+          <a:ln xmlns:a="http://schemas.openxmlformats.org/drawingml/2006/main" w="0">
+            <a:noFill/>
+            <a:prstDash val="solid"/>
+          </a:ln>
+        </p:spPr>
+        <p:txBody>
+          <a:bodyPr xmlns:a="http://schemas.openxmlformats.org/drawingml/2006/main" anchor="t"/>
+          <a:lstStyle xmlns:a="http://schemas.openxmlformats.org/drawingml/2006/main"/>
+          <a:p xmlns:a="http://schemas.openxmlformats.org/drawingml/2006/main">
+            <a:pPr algn="l">
+              <a:buNone/>
+              <a:defRPr sz="1650" b="1">
+                <a:solidFill>
+                  <a:srgbClr val="000000"/>
+                </a:solidFill>
+                <a:latin typeface="Helvetica Neue"/>
+                <a:ea typeface="Helvetica Neue"/>
+                <a:cs typeface="Helvetica Neue"/>
+              </a:defRPr>
+            </a:pPr>
+            <a:r>
+              <a:rPr sz="1650" b="1">
+                <a:solidFill>
+                  <a:srgbClr val="000000"/>
+                </a:solidFill>
+                <a:latin typeface="Helvetica Neue"/>
+                <a:ea typeface="Helvetica Neue"/>
+                <a:cs typeface="Helvetica Neue"/>
+              </a:rPr>
+              <a:t>1. Residual harm:</a:t>
+            </a:r>
+          </a:p>
+          <a:p xmlns:a="http://schemas.openxmlformats.org/drawingml/2006/main">
+            <a:r>
+              <a:t>H_m = sum_g P(g) E[L|g] prod_i b_ig</a:t>
+            </a:r>
+          </a:p>
+          <a:p xmlns:a="http://schemas.openxmlformats.org/drawingml/2006/main">
+            <a:pPr algn="l">
+              <a:buNone/>
+              <a:defRPr sz="1650" b="1">
+                <a:solidFill>
+                  <a:srgbClr val="000000"/>
+                </a:solidFill>
+                <a:latin typeface="Helvetica Neue"/>
+                <a:ea typeface="Helvetica Neue"/>
+                <a:cs typeface="Helvetica Neue"/>
+              </a:defRPr>
+            </a:pPr>
+            <a:r>
+              <a:rPr sz="1650" b="1">
+                <a:solidFill>
+                  <a:srgbClr val="000000"/>
+                </a:solidFill>
+                <a:latin typeface="Helvetica Neue"/>
+                <a:ea typeface="Helvetica Neue"/>
+                <a:cs typeface="Helvetica Neue"/>
+              </a:rPr>
+              <a:t/>
+            </a:r>
+          </a:p>
+          <a:p xmlns:a="http://schemas.openxmlformats.org/drawingml/2006/main">
+            <a:r>
+              <a:t>2. Geometric decline requires independent failures and stable coverage.</a:t>
+            </a:r>
+          </a:p>
+          <a:p xmlns:a="http://schemas.openxmlformats.org/drawingml/2006/main">
+            <a:pPr algn="l">
+              <a:buNone/>
+              <a:defRPr sz="1650" b="1">
+                <a:solidFill>
+                  <a:srgbClr val="000000"/>
+                </a:solidFill>
+                <a:latin typeface="Helvetica Neue"/>
+                <a:ea typeface="Helvetica Neue"/>
+                <a:cs typeface="Helvetica Neue"/>
+              </a:defRPr>
+            </a:pPr>
+            <a:r>
+              <a:rPr sz="1650" b="1">
+                <a:solidFill>
+                  <a:srgbClr val="000000"/>
+                </a:solidFill>
+                <a:latin typeface="Helvetica Neue"/>
+                <a:ea typeface="Helvetica Neue"/>
+                <a:cs typeface="Helvetica Neue"/>
+              </a:rPr>
+              <a:t/>
+            </a:r>
+          </a:p>
+          <a:p xmlns:a="http://schemas.openxmlformats.org/drawingml/2006/main">
+            <a:pPr algn="l">
+              <a:buNone/>
+              <a:defRPr sz="1650" b="1">
+                <a:solidFill>
+                  <a:srgbClr val="000000"/>
+                </a:solidFill>
+                <a:latin typeface="Helvetica Neue"/>
+                <a:ea typeface="Helvetica Neue"/>
+                <a:cs typeface="Helvetica Neue"/>
+              </a:defRPr>
+            </a:pPr>
+            <a:r>
+              <a:rPr sz="1650" b="1">
+                <a:solidFill>
+                  <a:srgbClr val="000000"/>
+                </a:solidFill>
+                <a:latin typeface="Helvetica Neue"/>
+                <a:ea typeface="Helvetica Neue"/>
+                <a:cs typeface="Helvetica Neue"/>
+              </a:rPr>
+              <a:t>3. Overlapping bypasses yield diminishing—or no—additional gain.</a:t>
+            </a:r>
+          </a:p>
+        </p:txBody>
+      </p:sp>
+      <p:sp>
+        <p:nvSpPr>
+          <p:cNvPr id="10" name="">
+            <a:extLst xmlns:a="http://schemas.openxmlformats.org/drawingml/2006/main">
+              <a:ext uri="{FF2B5EF4-FFF2-40B4-BE49-F238E27FC236}">
+                <a16:creationId xmlns:a16="http://schemas.microsoft.com/office/drawing/2014/main" id="{8B5C5AC7-7E09-417E-8BE5-0A3A14555694}"/>
+              </a:ext>
+            </a:extLst>
+          </p:cNvPr>
+          <p:cNvSpPr>
+            <a:spLocks xmlns:a="http://schemas.openxmlformats.org/drawingml/2006/main" noGrp="1"/>
+          </p:cNvSpPr>
+          <p:nvPr/>
+        </p:nvSpPr>
+        <p:spPr>
+          <a:xfrm xmlns:a="http://schemas.openxmlformats.org/drawingml/2006/main">
+            <a:off x="400050" y="6019800"/>
+            <a:ext cx="11049000" cy="323850"/>
+          </a:xfrm>
+          <a:prstGeom xmlns:a="http://schemas.openxmlformats.org/drawingml/2006/main" prst="rect">
+            <a:avLst/>
+          </a:prstGeom>
+          <a:noFill xmlns:a="http://schemas.openxmlformats.org/drawingml/2006/main"/>
+          <a:ln xmlns:a="http://schemas.openxmlformats.org/drawingml/2006/main" w="0">
+            <a:noFill/>
+            <a:prstDash val="solid"/>
+          </a:ln>
+        </p:spPr>
+        <p:txBody>
+          <a:bodyPr xmlns:a="http://schemas.openxmlformats.org/drawingml/2006/main" anchor="t"/>
+          <a:lstStyle xmlns:a="http://schemas.openxmlformats.org/drawingml/2006/main"/>
+          <a:p xmlns:a="http://schemas.openxmlformats.org/drawingml/2006/main">
+            <a:pPr algn="l">
+              <a:buNone/>
+              <a:defRPr sz="1500" b="1">
+                <a:solidFill>
+                  <a:srgbClr val="A63434"/>
+                </a:solidFill>
+                <a:latin typeface="Helvetica Neue"/>
+                <a:ea typeface="Helvetica Neue"/>
+                <a:cs typeface="Helvetica Neue"/>
+              </a:defRPr>
+            </a:pPr>
+            <a:r>
+              <a:rPr sz="1500" b="1">
+                <a:solidFill>
+                  <a:srgbClr val="A63434"/>
+                </a:solidFill>
+                <a:latin typeface="Helvetica Neue"/>
+                <a:ea typeface="Helvetica Neue"/>
+                <a:cs typeface="Helvetica Neue"/>
+              </a:rPr>
+              <a:t>Test tail concentration and failure complementarity—assume neither.</a:t>
+            </a:r>
+          </a:p>
+        </p:txBody>
+      </p:sp>
+    </p:spTree>
+    <p:extLst>
+      <p:ext uri="{BB962C8B-B14F-4D97-AF65-F5344CB8AC3E}">
+        <p14:creationId xmlns:p14="http://schemas.microsoft.com/office/powerpoint/2010/main" val="181609110"/>
+      </p:ext>
+    </p:extLst>
+  </p:cSld>
+</p:sld>
+</file>
+
+<file path=ppt/slides/slide23.xml><?xml version="1.0" encoding="utf-8"?>
+<p:sld xmlns:p="http://schemas.openxmlformats.org/presentationml/2006/main">
+  <p:cSld>
+    <p:spTree>
+      <p:nvGrpSpPr>
+        <p:cNvPr id="1" name=""/>
+        <p:cNvGrpSpPr/>
+        <p:nvPr/>
+      </p:nvGrpSpPr>
+      <p:grpSpPr>
+        <a:xfrm xmlns:a="http://schemas.openxmlformats.org/drawingml/2006/main"/>
+      </p:grpSpPr>
+      <p:sp>
+        <p:nvSpPr>
+          <p:cNvPr id="17" name="">
+            <a:extLst xmlns:a="http://schemas.openxmlformats.org/drawingml/2006/main">
+              <a:ext uri="{FF2B5EF4-FFF2-40B4-BE49-F238E27FC236}">
+                <a16:creationId xmlns:a16="http://schemas.microsoft.com/office/drawing/2014/main" id="{51131C71-3FBE-45E9-B711-EDD3B75D35EC}"/>
+              </a:ext>
+            </a:extLst>
+          </p:cNvPr>
+          <p:cNvSpPr>
+            <a:spLocks xmlns:a="http://schemas.openxmlformats.org/drawingml/2006/main" noGrp="1"/>
+          </p:cNvSpPr>
+          <p:nvPr/>
+        </p:nvSpPr>
+        <p:spPr>
+          <a:xfrm xmlns:a="http://schemas.openxmlformats.org/drawingml/2006/main">
+            <a:off x="400050" y="266700"/>
+            <a:ext cx="6667500" cy="266700"/>
+          </a:xfrm>
+          <a:prstGeom xmlns:a="http://schemas.openxmlformats.org/drawingml/2006/main" prst="rect">
+            <a:avLst/>
+          </a:prstGeom>
+          <a:noFill xmlns:a="http://schemas.openxmlformats.org/drawingml/2006/main"/>
+          <a:ln xmlns:a="http://schemas.openxmlformats.org/drawingml/2006/main" w="0">
+            <a:noFill/>
+            <a:prstDash val="solid"/>
+          </a:ln>
+        </p:spPr>
+        <p:txBody>
+          <a:bodyPr xmlns:a="http://schemas.openxmlformats.org/drawingml/2006/main" anchor="t"/>
+          <a:lstStyle xmlns:a="http://schemas.openxmlformats.org/drawingml/2006/main"/>
+          <a:p xmlns:a="http://schemas.openxmlformats.org/drawingml/2006/main">
+            <a:pPr algn="l">
+              <a:buNone/>
+              <a:defRPr sz="1200" b="1">
+                <a:solidFill>
+                  <a:srgbClr val="5D636D"/>
+                </a:solidFill>
+                <a:latin typeface="Helvetica Neue"/>
+                <a:ea typeface="Helvetica Neue"/>
+                <a:cs typeface="Helvetica Neue"/>
+              </a:defRPr>
+            </a:pPr>
+            <a:r>
+              <a:rPr sz="1200" b="1">
+                <a:solidFill>
+                  <a:srgbClr val="5D636D"/>
+                </a:solidFill>
+                <a:latin typeface="Helvetica Neue"/>
+                <a:ea typeface="Helvetica Neue"/>
+                <a:cs typeface="Helvetica Neue"/>
+              </a:rPr>
+              <a:t>MULTI-AGENT DEFENSE EVALUATION</a:t>
+            </a:r>
+          </a:p>
+        </p:txBody>
+      </p:sp>
+      <p:sp>
+        <p:nvSpPr>
+          <p:cNvPr id="2" name="slide-6-title">
+            <a:extLst xmlns:a="http://schemas.openxmlformats.org/drawingml/2006/main">
+              <a:ext uri="{FF2B5EF4-FFF2-40B4-BE49-F238E27FC236}">
+                <a16:creationId xmlns:a16="http://schemas.microsoft.com/office/drawing/2014/main" id="{CA9E1DB2-44DE-4718-AAFD-A4928026059A}"/>
+              </a:ext>
+            </a:extLst>
+          </p:cNvPr>
+          <p:cNvSpPr>
+            <a:spLocks xmlns:a="http://schemas.openxmlformats.org/drawingml/2006/main" noGrp="1"/>
+          </p:cNvSpPr>
+          <p:nvPr/>
+        </p:nvSpPr>
+        <p:spPr>
+          <a:xfrm xmlns:a="http://schemas.openxmlformats.org/drawingml/2006/main">
+            <a:off x="400050" y="619125"/>
+            <a:ext cx="11049000" cy="742950"/>
+          </a:xfrm>
+          <a:prstGeom xmlns:a="http://schemas.openxmlformats.org/drawingml/2006/main" prst="rect">
+            <a:avLst/>
+          </a:prstGeom>
+          <a:noFill xmlns:a="http://schemas.openxmlformats.org/drawingml/2006/main"/>
+          <a:ln xmlns:a="http://schemas.openxmlformats.org/drawingml/2006/main" w="0">
+            <a:noFill/>
+            <a:prstDash val="solid"/>
+          </a:ln>
+        </p:spPr>
+        <p:txBody>
+          <a:bodyPr xmlns:a="http://schemas.openxmlformats.org/drawingml/2006/main" anchor="t"/>
+          <a:lstStyle xmlns:a="http://schemas.openxmlformats.org/drawingml/2006/main"/>
+          <a:p xmlns:a="http://schemas.openxmlformats.org/drawingml/2006/main">
+            <a:pPr algn="l">
+              <a:buNone/>
+              <a:defRPr sz="3000" b="1">
+                <a:solidFill>
+                  <a:srgbClr val="000000"/>
+                </a:solidFill>
+                <a:latin typeface="Helvetica Neue"/>
+                <a:ea typeface="Helvetica Neue"/>
+                <a:cs typeface="Helvetica Neue"/>
+              </a:defRPr>
+            </a:pPr>
+            <a:r>
+              <a:rPr sz="3000" b="1">
+                <a:solidFill>
+                  <a:srgbClr val="000000"/>
+                </a:solidFill>
+                <a:latin typeface="Helvetica Neue"/>
+                <a:ea typeface="Helvetica Neue"/>
+                <a:cs typeface="Helvetica Neue"/>
+              </a:rPr>
+              <a:t>Fairlead operationalizes future multi-agent evaluations</a:t>
+            </a:r>
+          </a:p>
+        </p:txBody>
+      </p:sp>
+      <p:sp>
+        <p:nvSpPr>
+          <p:cNvPr id="3" name="">
+            <a:extLst xmlns:a="http://schemas.openxmlformats.org/drawingml/2006/main">
+              <a:ext uri="{FF2B5EF4-FFF2-40B4-BE49-F238E27FC236}">
+                <a16:creationId xmlns:a16="http://schemas.microsoft.com/office/drawing/2014/main" id="{C0F74CF4-81B3-48FE-9AEA-F5440C2341C6}"/>
+              </a:ext>
+            </a:extLst>
+          </p:cNvPr>
+          <p:cNvSpPr>
+            <a:spLocks xmlns:a="http://schemas.openxmlformats.org/drawingml/2006/main" noGrp="1"/>
+          </p:cNvSpPr>
+          <p:nvPr/>
+        </p:nvSpPr>
+        <p:spPr>
+          <a:xfrm xmlns:a="http://schemas.openxmlformats.org/drawingml/2006/main">
+            <a:off x="11239500" y="6334125"/>
+            <a:ext cx="523875" cy="228600"/>
+          </a:xfrm>
+          <a:prstGeom xmlns:a="http://schemas.openxmlformats.org/drawingml/2006/main" prst="rect">
+            <a:avLst/>
+          </a:prstGeom>
+          <a:noFill xmlns:a="http://schemas.openxmlformats.org/drawingml/2006/main"/>
+          <a:ln xmlns:a="http://schemas.openxmlformats.org/drawingml/2006/main" w="0">
+            <a:noFill/>
+            <a:prstDash val="solid"/>
+          </a:ln>
+        </p:spPr>
+        <p:txBody>
+          <a:bodyPr xmlns:a="http://schemas.openxmlformats.org/drawingml/2006/main" anchor="t"/>
+          <a:lstStyle xmlns:a="http://schemas.openxmlformats.org/drawingml/2006/main"/>
+          <a:p xmlns:a="http://schemas.openxmlformats.org/drawingml/2006/main">
+            <a:pPr algn="r">
+              <a:buNone/>
+              <a:defRPr sz="1050" b="0">
+                <a:solidFill>
+                  <a:srgbClr val="5D636D"/>
+                </a:solidFill>
+                <a:latin typeface="Helvetica Neue"/>
+                <a:ea typeface="Helvetica Neue"/>
+                <a:cs typeface="Helvetica Neue"/>
+              </a:defRPr>
+            </a:pPr>
+            <a:r>
+              <a:rPr sz="1050" b="0">
+                <a:solidFill>
+                  <a:srgbClr val="5D636D"/>
+                </a:solidFill>
+                <a:latin typeface="Helvetica Neue"/>
+                <a:ea typeface="Helvetica Neue"/>
+                <a:cs typeface="Helvetica Neue"/>
+              </a:rPr>
+              <a:t>23</a:t>
+            </a:r>
+          </a:p>
+        </p:txBody>
+      </p:sp>
+      <p:sp>
+        <p:nvSpPr>
+          <p:cNvPr id="4" name="">
+            <a:extLst xmlns:a="http://schemas.openxmlformats.org/drawingml/2006/main">
+              <a:ext uri="{FF2B5EF4-FFF2-40B4-BE49-F238E27FC236}">
+                <a16:creationId xmlns:a16="http://schemas.microsoft.com/office/drawing/2014/main" id="{C317BDED-2BE1-4928-97F6-FC2F2BA93993}"/>
+              </a:ext>
+            </a:extLst>
+          </p:cNvPr>
+          <p:cNvSpPr>
+            <a:spLocks xmlns:a="http://schemas.openxmlformats.org/drawingml/2006/main" noGrp="1"/>
+          </p:cNvSpPr>
+          <p:nvPr/>
+        </p:nvSpPr>
+        <p:spPr>
+          <a:xfrm xmlns:a="http://schemas.openxmlformats.org/drawingml/2006/main">
+            <a:off x="400050" y="1809750"/>
+            <a:ext cx="3476625" cy="3333750"/>
+          </a:xfrm>
+          <a:prstGeom xmlns:a="http://schemas.openxmlformats.org/drawingml/2006/main" prst="rect">
+            <a:avLst/>
+          </a:prstGeom>
+          <a:solidFill xmlns:a="http://schemas.openxmlformats.org/drawingml/2006/main">
+            <a:srgbClr val="F6F7F8"/>
+          </a:solidFill>
+          <a:ln xmlns:a="http://schemas.openxmlformats.org/drawingml/2006/main" w="0">
+            <a:noFill/>
+            <a:prstDash val="solid"/>
+          </a:ln>
+        </p:spPr>
+      </p:sp>
+      <p:sp>
+        <p:nvSpPr>
+          <p:cNvPr id="5" name="">
+            <a:extLst xmlns:a="http://schemas.openxmlformats.org/drawingml/2006/main">
+              <a:ext uri="{FF2B5EF4-FFF2-40B4-BE49-F238E27FC236}">
                 <a16:creationId xmlns:a16="http://schemas.microsoft.com/office/drawing/2014/main" id="{FD2BDC0F-8382-4F57-96E5-060EA267342B}"/>
               </a:ext>
             </a:extLst>
@@ -16743,7 +17684,29 @@
                 <a:ea typeface="Helvetica Neue"/>
                 <a:cs typeface="Helvetica Neue"/>
               </a:rPr>
-              <a:t>Shard held-out models and attack cells, preserve routing provenance, verify artifacts, and resume overnight campaigns.</a:t>
+              <a:t>Shard held-out models and </a:t>
+            </a:r>
+            <a:r>
+              <a:rPr sz="1350" b="0">
+                <a:solidFill>
+                  <a:srgbClr val="5D636D"/>
+                </a:solidFill>
+                <a:latin typeface="Helvetica Neue"/>
+                <a:ea typeface="Helvetica Neue"/>
+                <a:cs typeface="Helvetica Neue"/>
+              </a:rPr>
+              <a:t>attack scenario</a:t>
+            </a:r>
+            <a:r>
+              <a:rPr sz="1350" b="0">
+                <a:solidFill>
+                  <a:srgbClr val="5D636D"/>
+                </a:solidFill>
+                <a:latin typeface="Helvetica Neue"/>
+                <a:ea typeface="Helvetica Neue"/>
+                <a:cs typeface="Helvetica Neue"/>
+              </a:rPr>
+              <a:t>s, preserve routing provenance, verify artifacts, and resume overnight campaigns.</a:t>
             </a:r>
           </a:p>
         </p:txBody>
@@ -16936,7 +17899,18 @@
                 <a:ea typeface="Helvetica Neue"/>
                 <a:cs typeface="Helvetica Neue"/>
               </a:rPr>
-              <a:t>Attack variation creates hard-to-see worst-case cells</a:t>
+              <a:t>Attack variation creates hard-to-see </a:t>
+            </a:r>
+            <a:r>
+              <a:rPr sz="3000" b="1">
+                <a:solidFill>
+                  <a:srgbClr val="000000"/>
+                </a:solidFill>
+                <a:latin typeface="Helvetica Neue"/>
+                <a:ea typeface="Helvetica Neue"/>
+                <a:cs typeface="Helvetica Neue"/>
+              </a:rPr>
+              <a:t>worst-case scenarios</a:t>
             </a:r>
           </a:p>
         </p:txBody>
@@ -17171,7 +18145,7 @@
       </p:sp>
       <p:cxnSp>
         <p:nvCxnSpPr>
-          <p:cNvPr id="485" name=""/>
+          <p:cNvPr id="653" name=""/>
           <p:cNvCxnSpPr/>
           <p:nvPr/>
         </p:nvCxnSpPr>
@@ -17307,7 +18281,7 @@
       </p:sp>
       <p:cxnSp>
         <p:nvCxnSpPr>
-          <p:cNvPr id="488" name=""/>
+          <p:cNvPr id="656" name=""/>
           <p:cNvCxnSpPr/>
           <p:nvPr/>
         </p:nvCxnSpPr>
@@ -17443,7 +18417,7 @@
       </p:sp>
       <p:cxnSp>
         <p:nvCxnSpPr>
-          <p:cNvPr id="491" name=""/>
+          <p:cNvPr id="659" name=""/>
           <p:cNvCxnSpPr/>
           <p:nvPr/>
         </p:nvCxnSpPr>
@@ -17579,7 +18553,7 @@
       </p:sp>
       <p:cxnSp>
         <p:nvCxnSpPr>
-          <p:cNvPr id="494" name=""/>
+          <p:cNvPr id="662" name=""/>
           <p:cNvCxnSpPr/>
           <p:nvPr/>
         </p:nvCxnSpPr>
@@ -17715,7 +18689,7 @@
       </p:sp>
       <p:cxnSp>
         <p:nvCxnSpPr>
-          <p:cNvPr id="497" name=""/>
+          <p:cNvPr id="665" name=""/>
           <p:cNvCxnSpPr/>
           <p:nvPr/>
         </p:nvCxnSpPr>
@@ -17851,7 +18825,7 @@
       </p:sp>
       <p:cxnSp>
         <p:nvCxnSpPr>
-          <p:cNvPr id="500" name=""/>
+          <p:cNvPr id="668" name=""/>
           <p:cNvCxnSpPr/>
           <p:nvPr/>
         </p:nvCxnSpPr>
@@ -17987,7 +18961,7 @@
       </p:sp>
       <p:cxnSp>
         <p:nvCxnSpPr>
-          <p:cNvPr id="503" name=""/>
+          <p:cNvPr id="671" name=""/>
           <p:cNvCxnSpPr/>
           <p:nvPr/>
         </p:nvCxnSpPr>
@@ -18123,7 +19097,7 @@
       </p:sp>
       <p:cxnSp>
         <p:nvCxnSpPr>
-          <p:cNvPr id="506" name=""/>
+          <p:cNvPr id="674" name=""/>
           <p:cNvCxnSpPr/>
           <p:nvPr/>
         </p:nvCxnSpPr>
@@ -18252,7 +19226,29 @@
                 <a:ea typeface="Helvetica Neue"/>
                 <a:cs typeface="Helvetica Neue"/>
               </a:rPr>
-              <a:t>Optimize the worst conditional cell—not the pooled average.</a:t>
+              <a:t>Optimize the </a:t>
+            </a:r>
+            <a:r>
+              <a:rPr sz="1500" b="1">
+                <a:solidFill>
+                  <a:srgbClr val="000000"/>
+                </a:solidFill>
+                <a:latin typeface="Helvetica Neue"/>
+                <a:ea typeface="Helvetica Neue"/>
+                <a:cs typeface="Helvetica Neue"/>
+              </a:rPr>
+              <a:t>worst conditional scenario</a:t>
+            </a:r>
+            <a:r>
+              <a:rPr sz="1500" b="1">
+                <a:solidFill>
+                  <a:srgbClr val="000000"/>
+                </a:solidFill>
+                <a:latin typeface="Helvetica Neue"/>
+                <a:ea typeface="Helvetica Neue"/>
+                <a:cs typeface="Helvetica Neue"/>
+              </a:rPr>
+              <a:t>—not the pooled average.</a:t>
             </a:r>
           </a:p>
         </p:txBody>
@@ -19350,7 +20346,7 @@
       </p:sp>
       <p:cxnSp>
         <p:nvCxnSpPr>
-          <p:cNvPr id="168" name=""/>
+          <p:cNvPr id="216" name=""/>
           <p:cNvCxnSpPr/>
           <p:nvPr/>
         </p:nvCxnSpPr>
@@ -19762,7 +20758,7 @@
                 <a:ea typeface="Helvetica Neue"/>
                 <a:cs typeface="Helvetica Neue"/>
               </a:rPr>
-              <a:t>Attack cell</a:t>
+              <a:t>Attack scenario</a:t>
             </a:r>
           </a:p>
         </p:txBody>
@@ -20297,7 +21293,7 @@
                 <a:ea typeface="Helvetica Neue"/>
                 <a:cs typeface="Helvetica Neue"/>
               </a:rPr>
-              <a:t>Tail risk / CVaR</a:t>
+              <a:t>Conditional Value at Risk (CVaR)</a:t>
             </a:r>
           </a:p>
         </p:txBody>
@@ -20354,7 +21350,7 @@
                 <a:ea typeface="Helvetica Neue"/>
                 <a:cs typeface="Helvetica Neue"/>
               </a:rPr>
-              <a:t>Mean loss among the worst 10% of outcomes within an attack cell.</a:t>
+              <a:t>Average loss within the registered worst 10% of outcomes.</a:t>
             </a:r>
           </a:p>
         </p:txBody>
@@ -21203,7 +22199,7 @@
       </p:sp>
       <p:cxnSp>
         <p:nvCxnSpPr>
-          <p:cNvPr id="168" name=""/>
+          <p:cNvPr id="216" name=""/>
           <p:cNvCxnSpPr/>
           <p:nvPr/>
         </p:nvCxnSpPr>
@@ -22836,7 +23832,29 @@
                 <a:ea typeface="Helvetica Neue"/>
                 <a:cs typeface="Helvetica Neue"/>
               </a:rPr>
-              <a:t>Minimize worst-cell tail loss without destroying utility</a:t>
+              <a:t>Minimize </a:t>
+            </a:r>
+            <a:r>
+              <a:rPr sz="3000" b="1">
+                <a:solidFill>
+                  <a:srgbClr val="000000"/>
+                </a:solidFill>
+                <a:latin typeface="Helvetica Neue"/>
+                <a:ea typeface="Helvetica Neue"/>
+                <a:cs typeface="Helvetica Neue"/>
+              </a:rPr>
+              <a:t>worst-scenario</a:t>
+            </a:r>
+            <a:r>
+              <a:rPr sz="3000" b="1">
+                <a:solidFill>
+                  <a:srgbClr val="000000"/>
+                </a:solidFill>
+                <a:latin typeface="Helvetica Neue"/>
+                <a:ea typeface="Helvetica Neue"/>
+                <a:cs typeface="Helvetica Neue"/>
+              </a:rPr>
+              <a:t> tail loss without destroying utility</a:t>
             </a:r>
           </a:p>
         </p:txBody>
@@ -22981,7 +23999,7 @@
                 <a:ea typeface="Helvetica Neue"/>
                 <a:cs typeface="Helvetica Neue"/>
               </a:rPr>
-              <a:t>π* = arg minπ  maxg UCB[CVaR10%(L | g, BR(π,g))]</a:t>
+              <a:t>Risk(D) = max_s Upper95%[TailMean10%(Loss(D,s))]</a:t>
             </a:r>
           </a:p>
         </p:txBody>
@@ -23038,7 +24056,7 @@
                 <a:ea typeface="Helvetica Neue"/>
                 <a:cs typeface="Helvetica Neue"/>
               </a:rPr>
-              <a:t>subject to U(π) ≥ u_min and operational constraints; select on validation data</a:t>
+              <a:t>D = defense stack • s = scenario • require Utility(D) &gt;= minimum • validation only</a:t>
             </a:r>
           </a:p>
         </p:txBody>
@@ -23157,7 +24175,7 @@
                 <a:ea typeface="Helvetica Neue"/>
                 <a:cs typeface="Helvetica Neue"/>
               </a:rPr>
-              <a:t>Tail risk</a:t>
+              <a:t>Tail mean</a:t>
             </a:r>
           </a:p>
         </p:txBody>
@@ -23214,7 +24232,7 @@
                 <a:ea typeface="Helvetica Neue"/>
                 <a:cs typeface="Helvetica Neue"/>
               </a:rPr>
-              <a:t>Protect the severe 10% within each registered attack cell.</a:t>
+              <a:t>TailMean10% = CVaR10%: average loss in the worst 10% of runs.</a:t>
             </a:r>
           </a:p>
         </p:txBody>
@@ -23333,7 +24351,7 @@
                 <a:ea typeface="Helvetica Neue"/>
                 <a:cs typeface="Helvetica Neue"/>
               </a:rPr>
-              <a:t>Diversity Γ</a:t>
+              <a:t>Cautious bound</a:t>
             </a:r>
           </a:p>
         </p:txBody>
@@ -23390,7 +24408,7 @@
                 <a:ea typeface="Helvetica Neue"/>
                 <a:cs typeface="Helvetica Neue"/>
               </a:rPr>
-              <a:t>Reward layers only when matched bypass sets do not overlap.</a:t>
+              <a:t>Upper95% = UCB95%: estimate plus an uncertainty margin.</a:t>
             </a:r>
           </a:p>
         </p:txBody>
@@ -23509,7 +24527,7 @@
                 <a:ea typeface="Helvetica Neue"/>
                 <a:cs typeface="Helvetica Neue"/>
               </a:rPr>
-              <a:t>Best response</a:t>
+              <a:t>Adaptive retest</a:t>
             </a:r>
           </a:p>
         </p:txBody>
@@ -23566,7 +24584,7 @@
                 <a:ea typeface="Helvetica Neue"/>
                 <a:cs typeface="Helvetica Neue"/>
               </a:rPr>
-              <a:t>Re-optimize against every stack under equal budgets.</a:t>
+              <a:t>Re-optimize one attacker per stack under equal budgets.</a:t>
             </a:r>
           </a:p>
         </p:txBody>
@@ -23623,7 +24641,7 @@
                 <a:ea typeface="Helvetica Neue"/>
                 <a:cs typeface="Helvetica Neue"/>
               </a:rPr>
-              <a:t>Prediction: validation failure geometry forecasts held-out realized gain.</a:t>
+              <a:t>After selection, test whether layers fail on different matched opportunities.</a:t>
             </a:r>
           </a:p>
         </p:txBody>
@@ -24517,7 +25535,7 @@
       </p:sp>
       <p:cxnSp>
         <p:nvCxnSpPr>
-          <p:cNvPr id="94" name=""/>
+          <p:cNvPr id="118" name=""/>
           <p:cNvCxnSpPr/>
           <p:nvPr/>
         </p:nvCxnSpPr>
@@ -25444,7 +26462,29 @@
                 <a:ea typeface="Helvetica Neue"/>
                 <a:cs typeface="Helvetica Neue"/>
               </a:rPr>
-              <a:t>Open single-axis and compound cells only after selection freezes.</a:t>
+              <a:t>Open single-axis and </a:t>
+            </a:r>
+            <a:r>
+              <a:rPr sz="1275" b="0">
+                <a:solidFill>
+                  <a:srgbClr val="5D636D"/>
+                </a:solidFill>
+                <a:latin typeface="Helvetica Neue"/>
+                <a:ea typeface="Helvetica Neue"/>
+                <a:cs typeface="Helvetica Neue"/>
+              </a:rPr>
+              <a:t>compound attack scenarios</a:t>
+            </a:r>
+            <a:r>
+              <a:rPr sz="1275" b="0">
+                <a:solidFill>
+                  <a:srgbClr val="5D636D"/>
+                </a:solidFill>
+                <a:latin typeface="Helvetica Neue"/>
+                <a:ea typeface="Helvetica Neue"/>
+                <a:cs typeface="Helvetica Neue"/>
+              </a:rPr>
+              <a:t> only after selection freezes.</a:t>
             </a:r>
           </a:p>
         </p:txBody>

</xml_diff>